<commit_message>
feat: enhance Week 4, Session 1 PowerPoint and scripts by adding new diagrams on masked self-attention in decoders and transformer block, improving visual content for better understanding of NLP architectures
</commit_message>
<xml_diff>
--- a/web-presentation/pdf-exports/Week4-Session1-GenAI.pptx
+++ b/web-presentation/pdf-exports/Week4-Session1-GenAI.pptx
@@ -34,6 +34,10 @@
     <p:sldId id="282" r:id="rId33"/>
     <p:sldId id="283" r:id="rId34"/>
     <p:sldId id="284" r:id="rId35"/>
+    <p:sldId id="285" r:id="rId36"/>
+    <p:sldId id="286" r:id="rId37"/>
+    <p:sldId id="287" r:id="rId38"/>
+    <p:sldId id="288" r:id="rId39"/>
   </p:sldIdLst>
   <p:sldSz cx="12191695" cy="6858000" type="screen4x3"/>
   <p:notesSz cx="6858000" cy="9144000"/>
@@ -4077,7 +4081,7 @@
                 <a:ea typeface="DIN Next LT W23"/>
                 <a:cs typeface="DIN Next LT W23"/>
               </a:rPr>
-              <a:t>10  /  29</a:t>
+              <a:t>10  /  33</a:t>
             </a:r>
           </a:p>
         </p:txBody>
@@ -4477,7 +4481,7 @@
                 <a:ea typeface="DIN Next LT W23"/>
                 <a:cs typeface="DIN Next LT W23"/>
               </a:rPr>
-              <a:t>11  /  29</a:t>
+              <a:t>11  /  33</a:t>
             </a:r>
           </a:p>
         </p:txBody>
@@ -5066,7 +5070,7 @@
                 <a:ea typeface="DIN Next LT W23"/>
                 <a:cs typeface="DIN Next LT W23"/>
               </a:rPr>
-              <a:t>12  /  29</a:t>
+              <a:t>12  /  33</a:t>
             </a:r>
           </a:p>
         </p:txBody>
@@ -5618,7 +5622,7 @@
                 <a:ea typeface="DIN Next LT W23"/>
                 <a:cs typeface="DIN Next LT W23"/>
               </a:rPr>
-              <a:t>13  /  29</a:t>
+              <a:t>13  /  33</a:t>
             </a:r>
           </a:p>
         </p:txBody>
@@ -6166,7 +6170,7 @@
                 <a:ea typeface="DIN Next LT W23"/>
                 <a:cs typeface="DIN Next LT W23"/>
               </a:rPr>
-              <a:t>14  /  29</a:t>
+              <a:t>14  /  33</a:t>
             </a:r>
           </a:p>
         </p:txBody>
@@ -6755,7 +6759,7 @@
                 <a:ea typeface="DIN Next LT W23"/>
                 <a:cs typeface="DIN Next LT W23"/>
               </a:rPr>
-              <a:t>15  /  29</a:t>
+              <a:t>15  /  33</a:t>
             </a:r>
           </a:p>
         </p:txBody>
@@ -7307,7 +7311,7 @@
                 <a:ea typeface="DIN Next LT W23"/>
                 <a:cs typeface="DIN Next LT W23"/>
               </a:rPr>
-              <a:t>16  /  29</a:t>
+              <a:t>16  /  33</a:t>
             </a:r>
           </a:p>
         </p:txBody>
@@ -7877,7 +7881,7 @@
                 <a:ea typeface="DIN Next LT W23"/>
                 <a:cs typeface="DIN Next LT W23"/>
               </a:rPr>
-              <a:t>17  /  29</a:t>
+              <a:t>17  /  33</a:t>
             </a:r>
           </a:p>
         </p:txBody>
@@ -8277,7 +8281,7 @@
                 <a:ea typeface="DIN Next LT W23"/>
                 <a:cs typeface="DIN Next LT W23"/>
               </a:rPr>
-              <a:t>18  /  29</a:t>
+              <a:t>18  /  33</a:t>
             </a:r>
           </a:p>
         </p:txBody>
@@ -8918,7 +8922,7 @@
                 <a:ea typeface="DIN Next LT W23"/>
                 <a:cs typeface="DIN Next LT W23"/>
               </a:rPr>
-              <a:t>19  /  29</a:t>
+              <a:t>19  /  33</a:t>
             </a:r>
           </a:p>
         </p:txBody>
@@ -10837,7 +10841,7 @@
                 <a:ea typeface="DIN Next LT W23"/>
                 <a:cs typeface="DIN Next LT W23"/>
               </a:rPr>
-              <a:t>02  /  29</a:t>
+              <a:t>02  /  33</a:t>
             </a:r>
           </a:p>
         </p:txBody>
@@ -11237,7 +11241,7 @@
                 <a:ea typeface="DIN Next LT W23"/>
                 <a:cs typeface="DIN Next LT W23"/>
               </a:rPr>
-              <a:t>20  /  29</a:t>
+              <a:t>20  /  33</a:t>
             </a:r>
           </a:p>
         </p:txBody>
@@ -11789,7 +11793,7 @@
                 <a:ea typeface="DIN Next LT W23"/>
                 <a:cs typeface="DIN Next LT W23"/>
               </a:rPr>
-              <a:t>21  /  29</a:t>
+              <a:t>21  /  33</a:t>
             </a:r>
           </a:p>
         </p:txBody>
@@ -12513,7 +12517,7 @@
                 <a:ea typeface="DIN Next LT W23"/>
                 <a:cs typeface="DIN Next LT W23"/>
               </a:rPr>
-              <a:t>22  /  29</a:t>
+              <a:t>22  /  33</a:t>
             </a:r>
           </a:p>
         </p:txBody>
@@ -12913,7 +12917,7 @@
                 <a:ea typeface="DIN Next LT W23"/>
                 <a:cs typeface="DIN Next LT W23"/>
               </a:rPr>
-              <a:t>23  /  29</a:t>
+              <a:t>23  /  33</a:t>
             </a:r>
           </a:p>
         </p:txBody>
@@ -13465,7 +13469,7 @@
                 <a:ea typeface="DIN Next LT W23"/>
                 <a:cs typeface="DIN Next LT W23"/>
               </a:rPr>
-              <a:t>24  /  29</a:t>
+              <a:t>24  /  33</a:t>
             </a:r>
           </a:p>
         </p:txBody>
@@ -14087,7 +14091,7 @@
                 <a:ea typeface="DIN Next LT W23"/>
                 <a:cs typeface="DIN Next LT W23"/>
               </a:rPr>
-              <a:t>25  /  29</a:t>
+              <a:t>25  /  33</a:t>
             </a:r>
           </a:p>
         </p:txBody>
@@ -14740,7 +14744,7 @@
                 <a:ea typeface="DIN Next LT W23"/>
                 <a:cs typeface="DIN Next LT W23"/>
               </a:rPr>
-              <a:t>26  /  29</a:t>
+              <a:t>26  /  33</a:t>
             </a:r>
           </a:p>
         </p:txBody>
@@ -14928,8 +14932,8 @@
         </p:nvSpPr>
         <p:spPr>
           <a:xfrm>
-            <a:off x="548640" y="1051560"/>
-            <a:ext cx="10241280" cy="594360"/>
+            <a:off x="548640" y="1024128"/>
+            <a:ext cx="10241280" cy="566928"/>
           </a:xfrm>
           <a:prstGeom prst="rect">
             <a:avLst/>
@@ -14952,58 +14956,21 @@
                 <a:ea typeface="DIN Next LT W23"/>
                 <a:cs typeface="DIN Next LT W23"/>
               </a:rPr>
-              <a:t>Scaling &amp; Practice</a:t>
-            </a:r>
-          </a:p>
-        </p:txBody>
-      </p:sp>
-      <p:sp>
-        <p:nvSpPr>
-          <p:cNvPr id="7" name="TextBox 6"/>
-          <p:cNvSpPr txBox="1"/>
-          <p:nvPr/>
-        </p:nvSpPr>
-        <p:spPr>
-          <a:xfrm>
-            <a:off x="548640" y="1600200"/>
-            <a:ext cx="10241280" cy="365760"/>
-          </a:xfrm>
-          <a:prstGeom prst="rect">
-            <a:avLst/>
-          </a:prstGeom>
-          <a:noFill/>
-        </p:spPr>
-        <p:txBody>
-          <a:bodyPr wrap="square" anchor="t">
-            <a:spAutoFit/>
-          </a:bodyPr>
-          <a:lstStyle/>
-          <a:p>
-            <a:pPr algn="l"/>
-            <a:r>
-              <a:rPr sz="1500" b="0">
-                <a:solidFill>
-                  <a:srgbClr val="5A5470"/>
-                </a:solidFill>
-                <a:latin typeface="DIN Next LT W23"/>
-                <a:ea typeface="DIN Next LT W23"/>
-                <a:cs typeface="DIN Next LT W23"/>
-              </a:rPr>
-              <a:t>Topic 7 of 7</a:t>
-            </a:r>
-          </a:p>
-        </p:txBody>
-      </p:sp>
-      <p:sp>
-        <p:nvSpPr>
-          <p:cNvPr id="8" name="Rounded Rectangle 7"/>
+              <a:t>Self-Attention, Q/K/V, and Multi-Head</a:t>
+            </a:r>
+          </a:p>
+        </p:txBody>
+      </p:sp>
+      <p:sp>
+        <p:nvSpPr>
+          <p:cNvPr id="7" name="Rounded Rectangle 6"/>
           <p:cNvSpPr/>
           <p:nvPr/>
         </p:nvSpPr>
         <p:spPr>
           <a:xfrm>
-            <a:off x="548640" y="2240280"/>
-            <a:ext cx="10972800" cy="3383280"/>
+            <a:off x="548640" y="1737360"/>
+            <a:ext cx="10972800" cy="4617720"/>
           </a:xfrm>
           <a:prstGeom prst="roundRect">
             <a:avLst>
@@ -15040,46 +15007,33 @@
           </a:p>
         </p:txBody>
       </p:sp>
-      <p:sp>
-        <p:nvSpPr>
-          <p:cNvPr id="9" name="TextBox 8"/>
-          <p:cNvSpPr txBox="1"/>
-          <p:nvPr/>
-        </p:nvSpPr>
-        <p:spPr>
-          <a:xfrm>
-            <a:off x="914400" y="3246120"/>
-            <a:ext cx="10241280" cy="502920"/>
-          </a:xfrm>
-          <a:prstGeom prst="rect">
-            <a:avLst/>
-          </a:prstGeom>
-          <a:noFill/>
-        </p:spPr>
-        <p:txBody>
-          <a:bodyPr wrap="square" anchor="t">
-            <a:spAutoFit/>
-          </a:bodyPr>
-          <a:lstStyle/>
-          <a:p>
-            <a:pPr algn="ctr"/>
-            <a:r>
-              <a:rPr sz="2600" b="1">
-                <a:solidFill>
-                  <a:srgbClr val="5234B7"/>
-                </a:solidFill>
-                <a:latin typeface="DIN Next LT W23"/>
-                <a:ea typeface="DIN Next LT W23"/>
-                <a:cs typeface="DIN Next LT W23"/>
-              </a:rPr>
-              <a:t>Scaling &amp; Practice</a:t>
-            </a:r>
-          </a:p>
-        </p:txBody>
-      </p:sp>
-      <p:sp>
-        <p:nvSpPr>
-          <p:cNvPr id="10" name="Rectangle 9"/>
+      <p:pic>
+        <p:nvPicPr>
+          <p:cNvPr id="8" name="Picture 7" descr="attention-heatmap.png"/>
+          <p:cNvPicPr>
+            <a:picLocks noChangeAspect="1"/>
+          </p:cNvPicPr>
+          <p:nvPr/>
+        </p:nvPicPr>
+        <p:blipFill>
+          <a:blip r:embed="rId3"/>
+          <a:stretch>
+            <a:fillRect/>
+          </a:stretch>
+        </p:blipFill>
+        <p:spPr>
+          <a:xfrm>
+            <a:off x="2710978" y="1847088"/>
+            <a:ext cx="6648122" cy="4398264"/>
+          </a:xfrm>
+          <a:prstGeom prst="rect">
+            <a:avLst/>
+          </a:prstGeom>
+        </p:spPr>
+      </p:pic>
+      <p:sp>
+        <p:nvSpPr>
+          <p:cNvPr id="9" name="Rectangle 8"/>
           <p:cNvSpPr/>
           <p:nvPr/>
         </p:nvSpPr>
@@ -15123,7 +15077,7 @@
       </p:sp>
       <p:sp>
         <p:nvSpPr>
-          <p:cNvPr id="11" name="TextBox 10"/>
+          <p:cNvPr id="10" name="TextBox 9"/>
           <p:cNvSpPr txBox="1"/>
           <p:nvPr/>
         </p:nvSpPr>
@@ -15160,7 +15114,7 @@
       </p:sp>
       <p:sp>
         <p:nvSpPr>
-          <p:cNvPr id="12" name="TextBox 11"/>
+          <p:cNvPr id="11" name="TextBox 10"/>
           <p:cNvSpPr txBox="1"/>
           <p:nvPr/>
         </p:nvSpPr>
@@ -15190,7 +15144,7 @@
                 <a:ea typeface="DIN Next LT W23"/>
                 <a:cs typeface="DIN Next LT W23"/>
               </a:rPr>
-              <a:t>27  /  29</a:t>
+              <a:t>27  /  33</a:t>
             </a:r>
           </a:p>
         </p:txBody>
@@ -15321,7 +15275,7 @@
                 <a:ea typeface="DIN Next LT W23"/>
                 <a:cs typeface="DIN Next LT W23"/>
               </a:rPr>
-              <a:t>S14  ·  Takeaways</a:t>
+              <a:t>S14  ·  GenAI</a:t>
             </a:r>
           </a:p>
         </p:txBody>
@@ -15378,8 +15332,8 @@
         </p:nvSpPr>
         <p:spPr>
           <a:xfrm>
-            <a:off x="548640" y="1051560"/>
-            <a:ext cx="10241280" cy="594360"/>
+            <a:off x="548640" y="1024128"/>
+            <a:ext cx="10241280" cy="566928"/>
           </a:xfrm>
           <a:prstGeom prst="rect">
             <a:avLst/>
@@ -15402,7 +15356,7 @@
                 <a:ea typeface="DIN Next LT W23"/>
                 <a:cs typeface="DIN Next LT W23"/>
               </a:rPr>
-              <a:t>3 Ideas to Keep</a:t>
+              <a:t>Self-Attention, Q/K/V, and Multi-Head</a:t>
             </a:r>
           </a:p>
         </p:txBody>
@@ -15415,23 +15369,245 @@
         </p:nvSpPr>
         <p:spPr>
           <a:xfrm>
-            <a:off x="548640" y="1600200"/>
-            <a:ext cx="10241280" cy="365760"/>
-          </a:xfrm>
-          <a:prstGeom prst="rect">
-            <a:avLst/>
-          </a:prstGeom>
-          <a:noFill/>
-        </p:spPr>
-        <p:txBody>
-          <a:bodyPr wrap="square" anchor="t">
-            <a:spAutoFit/>
-          </a:bodyPr>
-          <a:lstStyle/>
-          <a:p>
-            <a:pPr algn="l"/>
-            <a:r>
-              <a:rPr sz="1500" b="0">
+            <a:off x="548640" y="1737360"/>
+            <a:ext cx="320040" cy="384048"/>
+          </a:xfrm>
+          <a:prstGeom prst="rect">
+            <a:avLst/>
+          </a:prstGeom>
+          <a:noFill/>
+        </p:spPr>
+        <p:txBody>
+          <a:bodyPr wrap="square" anchor="t">
+            <a:spAutoFit/>
+          </a:bodyPr>
+          <a:lstStyle/>
+          <a:p>
+            <a:pPr algn="l"/>
+            <a:r>
+              <a:rPr sz="1400" b="0">
+                <a:solidFill>
+                  <a:srgbClr val="9E59CD"/>
+                </a:solidFill>
+                <a:latin typeface="DIN Next LT W23"/>
+                <a:ea typeface="DIN Next LT W23"/>
+                <a:cs typeface="DIN Next LT W23"/>
+              </a:rPr>
+              <a:t>–</a:t>
+            </a:r>
+          </a:p>
+        </p:txBody>
+      </p:sp>
+      <p:sp>
+        <p:nvSpPr>
+          <p:cNvPr id="8" name="TextBox 7"/>
+          <p:cNvSpPr txBox="1"/>
+          <p:nvPr/>
+        </p:nvSpPr>
+        <p:spPr>
+          <a:xfrm>
+            <a:off x="914400" y="1737360"/>
+            <a:ext cx="9875519" cy="384048"/>
+          </a:xfrm>
+          <a:prstGeom prst="rect">
+            <a:avLst/>
+          </a:prstGeom>
+          <a:noFill/>
+        </p:spPr>
+        <p:txBody>
+          <a:bodyPr wrap="square" anchor="t">
+            <a:spAutoFit/>
+          </a:bodyPr>
+          <a:lstStyle/>
+          <a:p>
+            <a:pPr algn="l"/>
+            <a:r>
+              <a:rPr sz="1400" b="0">
+                <a:solidFill>
+                  <a:srgbClr val="121018"/>
+                </a:solidFill>
+                <a:latin typeface="DIN Next LT W23"/>
+                <a:ea typeface="DIN Next LT W23"/>
+                <a:cs typeface="DIN Next LT W23"/>
+              </a:rPr>
+              <a:t>Query asks for relevant context; Key indexes available context; Value carries content.</a:t>
+            </a:r>
+          </a:p>
+        </p:txBody>
+      </p:sp>
+      <p:sp>
+        <p:nvSpPr>
+          <p:cNvPr id="9" name="TextBox 8"/>
+          <p:cNvSpPr txBox="1"/>
+          <p:nvPr/>
+        </p:nvSpPr>
+        <p:spPr>
+          <a:xfrm>
+            <a:off x="548640" y="2212848"/>
+            <a:ext cx="320040" cy="384048"/>
+          </a:xfrm>
+          <a:prstGeom prst="rect">
+            <a:avLst/>
+          </a:prstGeom>
+          <a:noFill/>
+        </p:spPr>
+        <p:txBody>
+          <a:bodyPr wrap="square" anchor="t">
+            <a:spAutoFit/>
+          </a:bodyPr>
+          <a:lstStyle/>
+          <a:p>
+            <a:pPr algn="l"/>
+            <a:r>
+              <a:rPr sz="1400" b="0">
+                <a:solidFill>
+                  <a:srgbClr val="9E59CD"/>
+                </a:solidFill>
+                <a:latin typeface="DIN Next LT W23"/>
+                <a:ea typeface="DIN Next LT W23"/>
+                <a:cs typeface="DIN Next LT W23"/>
+              </a:rPr>
+              <a:t>–</a:t>
+            </a:r>
+          </a:p>
+        </p:txBody>
+      </p:sp>
+      <p:sp>
+        <p:nvSpPr>
+          <p:cNvPr id="10" name="TextBox 9"/>
+          <p:cNvSpPr txBox="1"/>
+          <p:nvPr/>
+        </p:nvSpPr>
+        <p:spPr>
+          <a:xfrm>
+            <a:off x="914400" y="2212848"/>
+            <a:ext cx="9875519" cy="384048"/>
+          </a:xfrm>
+          <a:prstGeom prst="rect">
+            <a:avLst/>
+          </a:prstGeom>
+          <a:noFill/>
+        </p:spPr>
+        <p:txBody>
+          <a:bodyPr wrap="square" anchor="t">
+            <a:spAutoFit/>
+          </a:bodyPr>
+          <a:lstStyle/>
+          <a:p>
+            <a:pPr algn="l"/>
+            <a:r>
+              <a:rPr sz="1400" b="0">
+                <a:solidFill>
+                  <a:srgbClr val="121018"/>
+                </a:solidFill>
+                <a:latin typeface="DIN Next LT W23"/>
+                <a:ea typeface="DIN Next LT W23"/>
+                <a:cs typeface="DIN Next LT W23"/>
+              </a:rPr>
+              <a:t>Self-attention lets each token aggregate information from other tokens in sequence.</a:t>
+            </a:r>
+          </a:p>
+        </p:txBody>
+      </p:sp>
+      <p:sp>
+        <p:nvSpPr>
+          <p:cNvPr id="11" name="TextBox 10"/>
+          <p:cNvSpPr txBox="1"/>
+          <p:nvPr/>
+        </p:nvSpPr>
+        <p:spPr>
+          <a:xfrm>
+            <a:off x="548640" y="2688336"/>
+            <a:ext cx="320040" cy="384048"/>
+          </a:xfrm>
+          <a:prstGeom prst="rect">
+            <a:avLst/>
+          </a:prstGeom>
+          <a:noFill/>
+        </p:spPr>
+        <p:txBody>
+          <a:bodyPr wrap="square" anchor="t">
+            <a:spAutoFit/>
+          </a:bodyPr>
+          <a:lstStyle/>
+          <a:p>
+            <a:pPr algn="l"/>
+            <a:r>
+              <a:rPr sz="1400" b="0">
+                <a:solidFill>
+                  <a:srgbClr val="9E59CD"/>
+                </a:solidFill>
+                <a:latin typeface="DIN Next LT W23"/>
+                <a:ea typeface="DIN Next LT W23"/>
+                <a:cs typeface="DIN Next LT W23"/>
+              </a:rPr>
+              <a:t>–</a:t>
+            </a:r>
+          </a:p>
+        </p:txBody>
+      </p:sp>
+      <p:sp>
+        <p:nvSpPr>
+          <p:cNvPr id="12" name="TextBox 11"/>
+          <p:cNvSpPr txBox="1"/>
+          <p:nvPr/>
+        </p:nvSpPr>
+        <p:spPr>
+          <a:xfrm>
+            <a:off x="914400" y="2688336"/>
+            <a:ext cx="9875519" cy="384048"/>
+          </a:xfrm>
+          <a:prstGeom prst="rect">
+            <a:avLst/>
+          </a:prstGeom>
+          <a:noFill/>
+        </p:spPr>
+        <p:txBody>
+          <a:bodyPr wrap="square" anchor="t">
+            <a:spAutoFit/>
+          </a:bodyPr>
+          <a:lstStyle/>
+          <a:p>
+            <a:pPr algn="l"/>
+            <a:r>
+              <a:rPr sz="1400" b="0">
+                <a:solidFill>
+                  <a:srgbClr val="121018"/>
+                </a:solidFill>
+                <a:latin typeface="DIN Next LT W23"/>
+                <a:ea typeface="DIN Next LT W23"/>
+                <a:cs typeface="DIN Next LT W23"/>
+              </a:rPr>
+              <a:t>Multi-head attention captures different linguistic relations in parallel.</a:t>
+            </a:r>
+          </a:p>
+        </p:txBody>
+      </p:sp>
+      <p:sp>
+        <p:nvSpPr>
+          <p:cNvPr id="13" name="TextBox 12"/>
+          <p:cNvSpPr txBox="1"/>
+          <p:nvPr/>
+        </p:nvSpPr>
+        <p:spPr>
+          <a:xfrm>
+            <a:off x="548640" y="5897880"/>
+            <a:ext cx="10972800" cy="274320"/>
+          </a:xfrm>
+          <a:prstGeom prst="rect">
+            <a:avLst/>
+          </a:prstGeom>
+          <a:noFill/>
+        </p:spPr>
+        <p:txBody>
+          <a:bodyPr wrap="square" anchor="t">
+            <a:spAutoFit/>
+          </a:bodyPr>
+          <a:lstStyle/>
+          <a:p>
+            <a:pPr algn="l"/>
+            <a:r>
+              <a:rPr sz="1200" b="0">
                 <a:solidFill>
                   <a:srgbClr val="5A5470"/>
                 </a:solidFill>
@@ -15439,374 +15615,14 @@
                 <a:ea typeface="DIN Next LT W23"/>
                 <a:cs typeface="DIN Next LT W23"/>
               </a:rPr>
-              <a:t>Leave with these</a:t>
-            </a:r>
-          </a:p>
-        </p:txBody>
-      </p:sp>
-      <p:sp>
-        <p:nvSpPr>
-          <p:cNvPr id="8" name="Rounded Rectangle 7"/>
-          <p:cNvSpPr/>
-          <p:nvPr/>
-        </p:nvSpPr>
-        <p:spPr>
-          <a:xfrm>
-            <a:off x="548640" y="2148840"/>
-            <a:ext cx="10972800" cy="987552"/>
-          </a:xfrm>
-          <a:prstGeom prst="roundRect">
-            <a:avLst>
-              <a:gd name="adj" fmla="val 10000"/>
-            </a:avLst>
-          </a:prstGeom>
-          <a:solidFill>
-            <a:srgbClr val="EEE8FA"/>
-          </a:solidFill>
-          <a:ln>
-            <a:noFill/>
-          </a:ln>
-          <a:effectLst/>
-        </p:spPr>
-        <p:style>
-          <a:lnRef idx="1">
-            <a:schemeClr val="accent1"/>
-          </a:lnRef>
-          <a:fillRef idx="3">
-            <a:schemeClr val="accent1"/>
-          </a:fillRef>
-          <a:effectRef idx="2">
-            <a:schemeClr val="accent1"/>
-          </a:effectRef>
-          <a:fontRef idx="minor">
-            <a:schemeClr val="lt1"/>
-          </a:fontRef>
-        </p:style>
-        <p:txBody>
-          <a:bodyPr rtlCol="0" anchor="ctr"/>
-          <a:lstStyle/>
-          <a:p>
-            <a:pPr algn="ctr"/>
-          </a:p>
-        </p:txBody>
-      </p:sp>
-      <p:sp>
-        <p:nvSpPr>
-          <p:cNvPr id="9" name="TextBox 8"/>
-          <p:cNvSpPr txBox="1"/>
-          <p:nvPr/>
-        </p:nvSpPr>
-        <p:spPr>
-          <a:xfrm>
-            <a:off x="822960" y="2404872"/>
-            <a:ext cx="457200" cy="457200"/>
-          </a:xfrm>
-          <a:prstGeom prst="rect">
-            <a:avLst/>
-          </a:prstGeom>
-          <a:noFill/>
-        </p:spPr>
-        <p:txBody>
-          <a:bodyPr wrap="square" anchor="t">
-            <a:spAutoFit/>
-          </a:bodyPr>
-          <a:lstStyle/>
-          <a:p>
-            <a:pPr algn="l"/>
-            <a:r>
-              <a:rPr sz="2200" b="1">
-                <a:solidFill>
-                  <a:srgbClr val="5234B7"/>
-                </a:solidFill>
-                <a:latin typeface="DIN Next LT W23"/>
-                <a:ea typeface="DIN Next LT W23"/>
-                <a:cs typeface="DIN Next LT W23"/>
-              </a:rPr>
-              <a:t>1</a:t>
-            </a:r>
-          </a:p>
-        </p:txBody>
-      </p:sp>
-      <p:sp>
-        <p:nvSpPr>
-          <p:cNvPr id="10" name="TextBox 9"/>
-          <p:cNvSpPr txBox="1"/>
-          <p:nvPr/>
-        </p:nvSpPr>
-        <p:spPr>
-          <a:xfrm>
-            <a:off x="1417320" y="2404872"/>
-            <a:ext cx="9692640" cy="548640"/>
-          </a:xfrm>
-          <a:prstGeom prst="rect">
-            <a:avLst/>
-          </a:prstGeom>
-          <a:noFill/>
-        </p:spPr>
-        <p:txBody>
-          <a:bodyPr wrap="square" anchor="t">
-            <a:spAutoFit/>
-          </a:bodyPr>
-          <a:lstStyle/>
-          <a:p>
-            <a:pPr algn="l"/>
-            <a:r>
-              <a:rPr sz="1600" b="0">
-                <a:solidFill>
-                  <a:srgbClr val="121018"/>
-                </a:solidFill>
-                <a:latin typeface="DIN Next LT W23"/>
-                <a:ea typeface="DIN Next LT W23"/>
-                <a:cs typeface="DIN Next LT W23"/>
-              </a:rPr>
-              <a:t>Choose architecture by task: encoder-only (BERT), encoder-decoder (T5), or decoder-only (GPT).</a:t>
-            </a:r>
-          </a:p>
-        </p:txBody>
-      </p:sp>
-      <p:sp>
-        <p:nvSpPr>
-          <p:cNvPr id="11" name="Rounded Rectangle 10"/>
-          <p:cNvSpPr/>
-          <p:nvPr/>
-        </p:nvSpPr>
-        <p:spPr>
-          <a:xfrm>
-            <a:off x="548640" y="3291840"/>
-            <a:ext cx="10972800" cy="987552"/>
-          </a:xfrm>
-          <a:prstGeom prst="roundRect">
-            <a:avLst>
-              <a:gd name="adj" fmla="val 10000"/>
-            </a:avLst>
-          </a:prstGeom>
-          <a:solidFill>
-            <a:srgbClr val="EEE8FA"/>
-          </a:solidFill>
-          <a:ln>
-            <a:noFill/>
-          </a:ln>
-          <a:effectLst/>
-        </p:spPr>
-        <p:style>
-          <a:lnRef idx="1">
-            <a:schemeClr val="accent1"/>
-          </a:lnRef>
-          <a:fillRef idx="3">
-            <a:schemeClr val="accent1"/>
-          </a:fillRef>
-          <a:effectRef idx="2">
-            <a:schemeClr val="accent1"/>
-          </a:effectRef>
-          <a:fontRef idx="minor">
-            <a:schemeClr val="lt1"/>
-          </a:fontRef>
-        </p:style>
-        <p:txBody>
-          <a:bodyPr rtlCol="0" anchor="ctr"/>
-          <a:lstStyle/>
-          <a:p>
-            <a:pPr algn="ctr"/>
-          </a:p>
-        </p:txBody>
-      </p:sp>
-      <p:sp>
-        <p:nvSpPr>
-          <p:cNvPr id="12" name="TextBox 11"/>
-          <p:cNvSpPr txBox="1"/>
-          <p:nvPr/>
-        </p:nvSpPr>
-        <p:spPr>
-          <a:xfrm>
-            <a:off x="822960" y="3547872"/>
-            <a:ext cx="457200" cy="457200"/>
-          </a:xfrm>
-          <a:prstGeom prst="rect">
-            <a:avLst/>
-          </a:prstGeom>
-          <a:noFill/>
-        </p:spPr>
-        <p:txBody>
-          <a:bodyPr wrap="square" anchor="t">
-            <a:spAutoFit/>
-          </a:bodyPr>
-          <a:lstStyle/>
-          <a:p>
-            <a:pPr algn="l"/>
-            <a:r>
-              <a:rPr sz="2200" b="1">
-                <a:solidFill>
-                  <a:srgbClr val="5234B7"/>
-                </a:solidFill>
-                <a:latin typeface="DIN Next LT W23"/>
-                <a:ea typeface="DIN Next LT W23"/>
-                <a:cs typeface="DIN Next LT W23"/>
-              </a:rPr>
-              <a:t>2</a:t>
-            </a:r>
-          </a:p>
-        </p:txBody>
-      </p:sp>
-      <p:sp>
-        <p:nvSpPr>
-          <p:cNvPr id="13" name="TextBox 12"/>
-          <p:cNvSpPr txBox="1"/>
-          <p:nvPr/>
-        </p:nvSpPr>
-        <p:spPr>
-          <a:xfrm>
-            <a:off x="1417320" y="3547872"/>
-            <a:ext cx="9692640" cy="548640"/>
-          </a:xfrm>
-          <a:prstGeom prst="rect">
-            <a:avLst/>
-          </a:prstGeom>
-          <a:noFill/>
-        </p:spPr>
-        <p:txBody>
-          <a:bodyPr wrap="square" anchor="t">
-            <a:spAutoFit/>
-          </a:bodyPr>
-          <a:lstStyle/>
-          <a:p>
-            <a:pPr algn="l"/>
-            <a:r>
-              <a:rPr sz="1600" b="0">
-                <a:solidFill>
-                  <a:srgbClr val="121018"/>
-                </a:solidFill>
-                <a:latin typeface="DIN Next LT W23"/>
-                <a:ea typeface="DIN Next LT W23"/>
-                <a:cs typeface="DIN Next LT W23"/>
-              </a:rPr>
-              <a:t>Prefer transfer learning and fine-tuning over training from scratch.</a:t>
-            </a:r>
-          </a:p>
-        </p:txBody>
-      </p:sp>
-      <p:sp>
-        <p:nvSpPr>
-          <p:cNvPr id="14" name="Rounded Rectangle 13"/>
-          <p:cNvSpPr/>
-          <p:nvPr/>
-        </p:nvSpPr>
-        <p:spPr>
-          <a:xfrm>
-            <a:off x="548640" y="4434840"/>
-            <a:ext cx="10972800" cy="987552"/>
-          </a:xfrm>
-          <a:prstGeom prst="roundRect">
-            <a:avLst>
-              <a:gd name="adj" fmla="val 10000"/>
-            </a:avLst>
-          </a:prstGeom>
-          <a:solidFill>
-            <a:srgbClr val="EEE8FA"/>
-          </a:solidFill>
-          <a:ln>
-            <a:noFill/>
-          </a:ln>
-          <a:effectLst/>
-        </p:spPr>
-        <p:style>
-          <a:lnRef idx="1">
-            <a:schemeClr val="accent1"/>
-          </a:lnRef>
-          <a:fillRef idx="3">
-            <a:schemeClr val="accent1"/>
-          </a:fillRef>
-          <a:effectRef idx="2">
-            <a:schemeClr val="accent1"/>
-          </a:effectRef>
-          <a:fontRef idx="minor">
-            <a:schemeClr val="lt1"/>
-          </a:fontRef>
-        </p:style>
-        <p:txBody>
-          <a:bodyPr rtlCol="0" anchor="ctr"/>
-          <a:lstStyle/>
-          <a:p>
-            <a:pPr algn="ctr"/>
-          </a:p>
-        </p:txBody>
-      </p:sp>
-      <p:sp>
-        <p:nvSpPr>
-          <p:cNvPr id="15" name="TextBox 14"/>
-          <p:cNvSpPr txBox="1"/>
-          <p:nvPr/>
-        </p:nvSpPr>
-        <p:spPr>
-          <a:xfrm>
-            <a:off x="822960" y="4690872"/>
-            <a:ext cx="457200" cy="457200"/>
-          </a:xfrm>
-          <a:prstGeom prst="rect">
-            <a:avLst/>
-          </a:prstGeom>
-          <a:noFill/>
-        </p:spPr>
-        <p:txBody>
-          <a:bodyPr wrap="square" anchor="t">
-            <a:spAutoFit/>
-          </a:bodyPr>
-          <a:lstStyle/>
-          <a:p>
-            <a:pPr algn="l"/>
-            <a:r>
-              <a:rPr sz="2200" b="1">
-                <a:solidFill>
-                  <a:srgbClr val="5234B7"/>
-                </a:solidFill>
-                <a:latin typeface="DIN Next LT W23"/>
-                <a:ea typeface="DIN Next LT W23"/>
-                <a:cs typeface="DIN Next LT W23"/>
-              </a:rPr>
-              <a:t>3</a:t>
-            </a:r>
-          </a:p>
-        </p:txBody>
-      </p:sp>
-      <p:sp>
-        <p:nvSpPr>
-          <p:cNvPr id="16" name="TextBox 15"/>
-          <p:cNvSpPr txBox="1"/>
-          <p:nvPr/>
-        </p:nvSpPr>
-        <p:spPr>
-          <a:xfrm>
-            <a:off x="1417320" y="4690872"/>
-            <a:ext cx="9692640" cy="548640"/>
-          </a:xfrm>
-          <a:prstGeom prst="rect">
-            <a:avLst/>
-          </a:prstGeom>
-          <a:noFill/>
-        </p:spPr>
-        <p:txBody>
-          <a:bodyPr wrap="square" anchor="t">
-            <a:spAutoFit/>
-          </a:bodyPr>
-          <a:lstStyle/>
-          <a:p>
-            <a:pPr algn="l"/>
-            <a:r>
-              <a:rPr sz="1600" b="0">
-                <a:solidFill>
-                  <a:srgbClr val="121018"/>
-                </a:solidFill>
-                <a:latin typeface="DIN Next LT W23"/>
-                <a:ea typeface="DIN Next LT W23"/>
-                <a:cs typeface="DIN Next LT W23"/>
-              </a:rPr>
-              <a:t>Attention, decoding strategy, and compute limits shape what you can ship.</a:t>
-            </a:r>
-          </a:p>
-        </p:txBody>
-      </p:sp>
-      <p:sp>
-        <p:nvSpPr>
-          <p:cNvPr id="17" name="Rectangle 16"/>
+              <a:t>Different heads can specialize in syntax, agreement, locality, or semantics.</a:t>
+            </a:r>
+          </a:p>
+        </p:txBody>
+      </p:sp>
+      <p:sp>
+        <p:nvSpPr>
+          <p:cNvPr id="14" name="Rectangle 13"/>
           <p:cNvSpPr/>
           <p:nvPr/>
         </p:nvSpPr>
@@ -15850,7 +15666,7 @@
       </p:sp>
       <p:sp>
         <p:nvSpPr>
-          <p:cNvPr id="18" name="TextBox 17"/>
+          <p:cNvPr id="15" name="TextBox 14"/>
           <p:cNvSpPr txBox="1"/>
           <p:nvPr/>
         </p:nvSpPr>
@@ -15887,7 +15703,7 @@
       </p:sp>
       <p:sp>
         <p:nvSpPr>
-          <p:cNvPr id="19" name="TextBox 18"/>
+          <p:cNvPr id="16" name="TextBox 15"/>
           <p:cNvSpPr txBox="1"/>
           <p:nvPr/>
         </p:nvSpPr>
@@ -15917,7 +15733,7 @@
                 <a:ea typeface="DIN Next LT W23"/>
                 <a:cs typeface="DIN Next LT W23"/>
               </a:rPr>
-              <a:t>28  /  29</a:t>
+              <a:t>28  /  33</a:t>
             </a:r>
           </a:p>
         </p:txBody>
@@ -16009,7 +15825,7 @@
         <p:spPr>
           <a:xfrm>
             <a:off x="10561320" y="411480"/>
-            <a:ext cx="1378516" cy="365760"/>
+            <a:ext cx="1206201" cy="320040"/>
           </a:xfrm>
           <a:prstGeom prst="rect">
             <a:avLst/>
@@ -16024,23 +15840,104 @@
         </p:nvSpPr>
         <p:spPr>
           <a:xfrm>
-            <a:off x="548640" y="2651760"/>
-            <a:ext cx="10972800" cy="731520"/>
-          </a:xfrm>
-          <a:prstGeom prst="rect">
-            <a:avLst/>
-          </a:prstGeom>
-          <a:noFill/>
-        </p:spPr>
-        <p:txBody>
-          <a:bodyPr wrap="square" anchor="t">
-            <a:spAutoFit/>
-          </a:bodyPr>
+            <a:off x="548640" y="438912"/>
+            <a:ext cx="7772400" cy="274320"/>
+          </a:xfrm>
+          <a:prstGeom prst="rect">
+            <a:avLst/>
+          </a:prstGeom>
+          <a:noFill/>
+        </p:spPr>
+        <p:txBody>
+          <a:bodyPr wrap="square" anchor="t">
+            <a:spAutoFit/>
+          </a:bodyPr>
+          <a:lstStyle/>
+          <a:p>
+            <a:pPr algn="l"/>
+            <a:r>
+              <a:rPr sz="1200" b="0">
+                <a:solidFill>
+                  <a:srgbClr val="5A5470"/>
+                </a:solidFill>
+                <a:latin typeface="DIN Next LT W23"/>
+                <a:ea typeface="DIN Next LT W23"/>
+                <a:cs typeface="DIN Next LT W23"/>
+              </a:rPr>
+              <a:t>S14  ·  GenAI</a:t>
+            </a:r>
+          </a:p>
+        </p:txBody>
+      </p:sp>
+      <p:sp>
+        <p:nvSpPr>
+          <p:cNvPr id="5" name="Rectangle 4"/>
+          <p:cNvSpPr/>
+          <p:nvPr/>
+        </p:nvSpPr>
+        <p:spPr>
+          <a:xfrm>
+            <a:off x="548640" y="822960"/>
+            <a:ext cx="11064240" cy="10972"/>
+          </a:xfrm>
+          <a:prstGeom prst="rect">
+            <a:avLst/>
+          </a:prstGeom>
+          <a:solidFill>
+            <a:srgbClr val="E4DCF4"/>
+          </a:solidFill>
+          <a:ln>
+            <a:noFill/>
+          </a:ln>
+          <a:effectLst/>
+        </p:spPr>
+        <p:style>
+          <a:lnRef idx="1">
+            <a:schemeClr val="accent1"/>
+          </a:lnRef>
+          <a:fillRef idx="3">
+            <a:schemeClr val="accent1"/>
+          </a:fillRef>
+          <a:effectRef idx="2">
+            <a:schemeClr val="accent1"/>
+          </a:effectRef>
+          <a:fontRef idx="minor">
+            <a:schemeClr val="lt1"/>
+          </a:fontRef>
+        </p:style>
+        <p:txBody>
+          <a:bodyPr rtlCol="0" anchor="ctr"/>
           <a:lstStyle/>
           <a:p>
             <a:pPr algn="ctr"/>
-            <a:r>
-              <a:rPr sz="4000" b="1">
+          </a:p>
+        </p:txBody>
+      </p:sp>
+      <p:sp>
+        <p:nvSpPr>
+          <p:cNvPr id="6" name="TextBox 5"/>
+          <p:cNvSpPr txBox="1"/>
+          <p:nvPr/>
+        </p:nvSpPr>
+        <p:spPr>
+          <a:xfrm>
+            <a:off x="548640" y="1024128"/>
+            <a:ext cx="10241280" cy="566928"/>
+          </a:xfrm>
+          <a:prstGeom prst="rect">
+            <a:avLst/>
+          </a:prstGeom>
+          <a:noFill/>
+        </p:spPr>
+        <p:txBody>
+          <a:bodyPr wrap="square" anchor="t">
+            <a:spAutoFit/>
+          </a:bodyPr>
+          <a:lstStyle/>
+          <a:p>
+            <a:pPr algn="l"/>
+            <a:r>
+              <a:rPr sz="3200" b="1">
                 <a:solidFill>
                   <a:srgbClr val="5234B7"/>
                 </a:solidFill>
@@ -16048,88 +15945,84 @@
                 <a:ea typeface="DIN Next LT W23"/>
                 <a:cs typeface="DIN Next LT W23"/>
               </a:rPr>
-              <a:t>Thank you</a:t>
-            </a:r>
-          </a:p>
-        </p:txBody>
-      </p:sp>
-      <p:sp>
-        <p:nvSpPr>
-          <p:cNvPr id="5" name="TextBox 4"/>
-          <p:cNvSpPr txBox="1"/>
-          <p:nvPr/>
-        </p:nvSpPr>
-        <p:spPr>
-          <a:xfrm>
-            <a:off x="548640" y="3474720"/>
-            <a:ext cx="10972800" cy="365760"/>
-          </a:xfrm>
-          <a:prstGeom prst="rect">
-            <a:avLst/>
-          </a:prstGeom>
-          <a:noFill/>
-        </p:spPr>
-        <p:txBody>
-          <a:bodyPr wrap="square" anchor="t">
-            <a:spAutoFit/>
-          </a:bodyPr>
+              <a:t>Masked Self-Attention in Decoders</a:t>
+            </a:r>
+          </a:p>
+        </p:txBody>
+      </p:sp>
+      <p:sp>
+        <p:nvSpPr>
+          <p:cNvPr id="7" name="Rounded Rectangle 6"/>
+          <p:cNvSpPr/>
+          <p:nvPr/>
+        </p:nvSpPr>
+        <p:spPr>
+          <a:xfrm>
+            <a:off x="548640" y="1737360"/>
+            <a:ext cx="10972800" cy="4617720"/>
+          </a:xfrm>
+          <a:prstGeom prst="roundRect">
+            <a:avLst>
+              <a:gd name="adj" fmla="val 10000"/>
+            </a:avLst>
+          </a:prstGeom>
+          <a:solidFill>
+            <a:srgbClr val="EEE8FA"/>
+          </a:solidFill>
+          <a:ln>
+            <a:noFill/>
+          </a:ln>
+          <a:effectLst/>
+        </p:spPr>
+        <p:style>
+          <a:lnRef idx="1">
+            <a:schemeClr val="accent1"/>
+          </a:lnRef>
+          <a:fillRef idx="3">
+            <a:schemeClr val="accent1"/>
+          </a:fillRef>
+          <a:effectRef idx="2">
+            <a:schemeClr val="accent1"/>
+          </a:effectRef>
+          <a:fontRef idx="minor">
+            <a:schemeClr val="lt1"/>
+          </a:fontRef>
+        </p:style>
+        <p:txBody>
+          <a:bodyPr rtlCol="0" anchor="ctr"/>
           <a:lstStyle/>
           <a:p>
             <a:pPr algn="ctr"/>
-            <a:r>
-              <a:rPr sz="1600" b="0">
-                <a:solidFill>
-                  <a:srgbClr val="5A5470"/>
-                </a:solidFill>
-                <a:latin typeface="DIN Next LT W23"/>
-                <a:ea typeface="DIN Next LT W23"/>
-                <a:cs typeface="DIN Next LT W23"/>
-              </a:rPr>
-              <a:t>Labs: code/17- GenAI</a:t>
-            </a:r>
-          </a:p>
-        </p:txBody>
-      </p:sp>
-      <p:sp>
-        <p:nvSpPr>
-          <p:cNvPr id="6" name="TextBox 5"/>
-          <p:cNvSpPr txBox="1"/>
-          <p:nvPr/>
-        </p:nvSpPr>
-        <p:spPr>
-          <a:xfrm>
-            <a:off x="548640" y="6126480"/>
-            <a:ext cx="5486400" cy="274320"/>
-          </a:xfrm>
-          <a:prstGeom prst="rect">
-            <a:avLst/>
-          </a:prstGeom>
-          <a:noFill/>
-        </p:spPr>
-        <p:txBody>
-          <a:bodyPr wrap="square" anchor="t">
-            <a:spAutoFit/>
-          </a:bodyPr>
-          <a:lstStyle/>
-          <a:p>
-            <a:pPr algn="l"/>
-            <a:r>
-              <a:rPr sz="1200" b="1">
-                <a:solidFill>
-                  <a:srgbClr val="5234B7"/>
-                </a:solidFill>
-                <a:latin typeface="DIN Next LT W23"/>
-                <a:ea typeface="DIN Next LT W23"/>
-                <a:cs typeface="DIN Next LT W23"/>
-              </a:rPr>
-              <a:t>ETRA</a:t>
-            </a:r>
-          </a:p>
-        </p:txBody>
-      </p:sp>
-      <p:sp>
-        <p:nvSpPr>
-          <p:cNvPr id="7" name="Rectangle 6"/>
+          </a:p>
+        </p:txBody>
+      </p:sp>
+      <p:pic>
+        <p:nvPicPr>
+          <p:cNvPr id="8" name="Picture 7" descr="transformer-block.png"/>
+          <p:cNvPicPr>
+            <a:picLocks noChangeAspect="1"/>
+          </p:cNvPicPr>
+          <p:nvPr/>
+        </p:nvPicPr>
+        <p:blipFill>
+          <a:blip r:embed="rId3"/>
+          <a:stretch>
+            <a:fillRect/>
+          </a:stretch>
+        </p:blipFill>
+        <p:spPr>
+          <a:xfrm>
+            <a:off x="2668290" y="1847088"/>
+            <a:ext cx="6733498" cy="4398264"/>
+          </a:xfrm>
+          <a:prstGeom prst="rect">
+            <a:avLst/>
+          </a:prstGeom>
+        </p:spPr>
+      </p:pic>
+      <p:sp>
+        <p:nvSpPr>
+          <p:cNvPr id="9" name="Rectangle 8"/>
           <p:cNvSpPr/>
           <p:nvPr/>
         </p:nvSpPr>
@@ -16173,7 +16066,7 @@
       </p:sp>
       <p:sp>
         <p:nvSpPr>
-          <p:cNvPr id="8" name="TextBox 7"/>
+          <p:cNvPr id="10" name="TextBox 9"/>
           <p:cNvSpPr txBox="1"/>
           <p:nvPr/>
         </p:nvSpPr>
@@ -16210,7 +16103,7 @@
       </p:sp>
       <p:sp>
         <p:nvSpPr>
-          <p:cNvPr id="9" name="TextBox 8"/>
+          <p:cNvPr id="11" name="TextBox 10"/>
           <p:cNvSpPr txBox="1"/>
           <p:nvPr/>
         </p:nvSpPr>
@@ -16240,7 +16133,7 @@
                 <a:ea typeface="DIN Next LT W23"/>
                 <a:cs typeface="DIN Next LT W23"/>
               </a:rPr>
-              <a:t>29  /  29</a:t>
+              <a:t>29  /  33</a:t>
             </a:r>
           </a:p>
         </p:txBody>
@@ -17196,7 +17089,2059 @@
                 <a:ea typeface="DIN Next LT W23"/>
                 <a:cs typeface="DIN Next LT W23"/>
               </a:rPr>
-              <a:t>03  /  29</a:t>
+              <a:t>03  /  33</a:t>
+            </a:r>
+          </a:p>
+        </p:txBody>
+      </p:sp>
+    </p:spTree>
+  </p:cSld>
+  <p:clrMapOvr>
+    <a:masterClrMapping/>
+  </p:clrMapOvr>
+</p:sld>
+</file>
+
+<file path=ppt/slides/slide30.xml><?xml version="1.0" encoding="utf-8"?>
+<p:sld xmlns:a="http://schemas.openxmlformats.org/drawingml/2006/main" xmlns:p="http://schemas.openxmlformats.org/presentationml/2006/main" xmlns:r="http://schemas.openxmlformats.org/officeDocument/2006/relationships">
+  <p:cSld>
+    <p:bg>
+      <p:bgPr>
+        <a:solidFill>
+          <a:srgbClr val="FAF8FF"/>
+        </a:solidFill>
+        <a:effectLst/>
+      </p:bgPr>
+    </p:bg>
+    <p:spTree>
+      <p:nvGrpSpPr>
+        <p:cNvPr id="1" name=""/>
+        <p:cNvGrpSpPr/>
+        <p:nvPr/>
+      </p:nvGrpSpPr>
+      <p:grpSpPr/>
+      <p:sp>
+        <p:nvSpPr>
+          <p:cNvPr id="2" name="Rectangle 1"/>
+          <p:cNvSpPr/>
+          <p:nvPr/>
+        </p:nvSpPr>
+        <p:spPr>
+          <a:xfrm>
+            <a:off x="12136831" y="0"/>
+            <a:ext cx="54864" cy="6858000"/>
+          </a:xfrm>
+          <a:prstGeom prst="rect">
+            <a:avLst/>
+          </a:prstGeom>
+          <a:solidFill>
+            <a:srgbClr val="5234B7"/>
+          </a:solidFill>
+          <a:ln>
+            <a:noFill/>
+          </a:ln>
+          <a:effectLst/>
+        </p:spPr>
+        <p:style>
+          <a:lnRef idx="1">
+            <a:schemeClr val="accent1"/>
+          </a:lnRef>
+          <a:fillRef idx="3">
+            <a:schemeClr val="accent1"/>
+          </a:fillRef>
+          <a:effectRef idx="2">
+            <a:schemeClr val="accent1"/>
+          </a:effectRef>
+          <a:fontRef idx="minor">
+            <a:schemeClr val="lt1"/>
+          </a:fontRef>
+        </p:style>
+        <p:txBody>
+          <a:bodyPr rtlCol="0" anchor="ctr"/>
+          <a:lstStyle/>
+          <a:p>
+            <a:pPr algn="ctr"/>
+          </a:p>
+        </p:txBody>
+      </p:sp>
+      <p:pic>
+        <p:nvPicPr>
+          <p:cNvPr id="3" name="Picture 2" descr="etra-wordmark.png"/>
+          <p:cNvPicPr>
+            <a:picLocks noChangeAspect="1"/>
+          </p:cNvPicPr>
+          <p:nvPr/>
+        </p:nvPicPr>
+        <p:blipFill>
+          <a:blip r:embed="rId2"/>
+          <a:stretch>
+            <a:fillRect/>
+          </a:stretch>
+        </p:blipFill>
+        <p:spPr>
+          <a:xfrm>
+            <a:off x="10561320" y="411480"/>
+            <a:ext cx="1206201" cy="320040"/>
+          </a:xfrm>
+          <a:prstGeom prst="rect">
+            <a:avLst/>
+          </a:prstGeom>
+        </p:spPr>
+      </p:pic>
+      <p:sp>
+        <p:nvSpPr>
+          <p:cNvPr id="4" name="TextBox 3"/>
+          <p:cNvSpPr txBox="1"/>
+          <p:nvPr/>
+        </p:nvSpPr>
+        <p:spPr>
+          <a:xfrm>
+            <a:off x="548640" y="438912"/>
+            <a:ext cx="7772400" cy="274320"/>
+          </a:xfrm>
+          <a:prstGeom prst="rect">
+            <a:avLst/>
+          </a:prstGeom>
+          <a:noFill/>
+        </p:spPr>
+        <p:txBody>
+          <a:bodyPr wrap="square" anchor="t">
+            <a:spAutoFit/>
+          </a:bodyPr>
+          <a:lstStyle/>
+          <a:p>
+            <a:pPr algn="l"/>
+            <a:r>
+              <a:rPr sz="1200" b="0">
+                <a:solidFill>
+                  <a:srgbClr val="5A5470"/>
+                </a:solidFill>
+                <a:latin typeface="DIN Next LT W23"/>
+                <a:ea typeface="DIN Next LT W23"/>
+                <a:cs typeface="DIN Next LT W23"/>
+              </a:rPr>
+              <a:t>S14  ·  GenAI</a:t>
+            </a:r>
+          </a:p>
+        </p:txBody>
+      </p:sp>
+      <p:sp>
+        <p:nvSpPr>
+          <p:cNvPr id="5" name="Rectangle 4"/>
+          <p:cNvSpPr/>
+          <p:nvPr/>
+        </p:nvSpPr>
+        <p:spPr>
+          <a:xfrm>
+            <a:off x="548640" y="822960"/>
+            <a:ext cx="11064240" cy="10972"/>
+          </a:xfrm>
+          <a:prstGeom prst="rect">
+            <a:avLst/>
+          </a:prstGeom>
+          <a:solidFill>
+            <a:srgbClr val="E4DCF4"/>
+          </a:solidFill>
+          <a:ln>
+            <a:noFill/>
+          </a:ln>
+          <a:effectLst/>
+        </p:spPr>
+        <p:style>
+          <a:lnRef idx="1">
+            <a:schemeClr val="accent1"/>
+          </a:lnRef>
+          <a:fillRef idx="3">
+            <a:schemeClr val="accent1"/>
+          </a:fillRef>
+          <a:effectRef idx="2">
+            <a:schemeClr val="accent1"/>
+          </a:effectRef>
+          <a:fontRef idx="minor">
+            <a:schemeClr val="lt1"/>
+          </a:fontRef>
+        </p:style>
+        <p:txBody>
+          <a:bodyPr rtlCol="0" anchor="ctr"/>
+          <a:lstStyle/>
+          <a:p>
+            <a:pPr algn="ctr"/>
+          </a:p>
+        </p:txBody>
+      </p:sp>
+      <p:sp>
+        <p:nvSpPr>
+          <p:cNvPr id="6" name="TextBox 5"/>
+          <p:cNvSpPr txBox="1"/>
+          <p:nvPr/>
+        </p:nvSpPr>
+        <p:spPr>
+          <a:xfrm>
+            <a:off x="548640" y="1024128"/>
+            <a:ext cx="10241280" cy="566928"/>
+          </a:xfrm>
+          <a:prstGeom prst="rect">
+            <a:avLst/>
+          </a:prstGeom>
+          <a:noFill/>
+        </p:spPr>
+        <p:txBody>
+          <a:bodyPr wrap="square" anchor="t">
+            <a:spAutoFit/>
+          </a:bodyPr>
+          <a:lstStyle/>
+          <a:p>
+            <a:pPr algn="l"/>
+            <a:r>
+              <a:rPr sz="3200" b="1">
+                <a:solidFill>
+                  <a:srgbClr val="5234B7"/>
+                </a:solidFill>
+                <a:latin typeface="DIN Next LT W23"/>
+                <a:ea typeface="DIN Next LT W23"/>
+                <a:cs typeface="DIN Next LT W23"/>
+              </a:rPr>
+              <a:t>Masked Self-Attention in Decoders</a:t>
+            </a:r>
+          </a:p>
+        </p:txBody>
+      </p:sp>
+      <p:sp>
+        <p:nvSpPr>
+          <p:cNvPr id="7" name="TextBox 6"/>
+          <p:cNvSpPr txBox="1"/>
+          <p:nvPr/>
+        </p:nvSpPr>
+        <p:spPr>
+          <a:xfrm>
+            <a:off x="548640" y="1737360"/>
+            <a:ext cx="320040" cy="605790"/>
+          </a:xfrm>
+          <a:prstGeom prst="rect">
+            <a:avLst/>
+          </a:prstGeom>
+          <a:noFill/>
+        </p:spPr>
+        <p:txBody>
+          <a:bodyPr wrap="square" anchor="t">
+            <a:spAutoFit/>
+          </a:bodyPr>
+          <a:lstStyle/>
+          <a:p>
+            <a:pPr algn="l"/>
+            <a:r>
+              <a:rPr sz="1500" b="0">
+                <a:solidFill>
+                  <a:srgbClr val="9E59CD"/>
+                </a:solidFill>
+                <a:latin typeface="DIN Next LT W23"/>
+                <a:ea typeface="DIN Next LT W23"/>
+                <a:cs typeface="DIN Next LT W23"/>
+              </a:rPr>
+              <a:t>–</a:t>
+            </a:r>
+          </a:p>
+        </p:txBody>
+      </p:sp>
+      <p:sp>
+        <p:nvSpPr>
+          <p:cNvPr id="8" name="TextBox 7"/>
+          <p:cNvSpPr txBox="1"/>
+          <p:nvPr/>
+        </p:nvSpPr>
+        <p:spPr>
+          <a:xfrm>
+            <a:off x="914400" y="1737360"/>
+            <a:ext cx="9875519" cy="605790"/>
+          </a:xfrm>
+          <a:prstGeom prst="rect">
+            <a:avLst/>
+          </a:prstGeom>
+          <a:noFill/>
+        </p:spPr>
+        <p:txBody>
+          <a:bodyPr wrap="square" anchor="t">
+            <a:spAutoFit/>
+          </a:bodyPr>
+          <a:lstStyle/>
+          <a:p>
+            <a:pPr algn="l"/>
+            <a:r>
+              <a:rPr sz="1500" b="0">
+                <a:solidFill>
+                  <a:srgbClr val="121018"/>
+                </a:solidFill>
+                <a:latin typeface="DIN Next LT W23"/>
+                <a:ea typeface="DIN Next LT W23"/>
+                <a:cs typeface="DIN Next LT W23"/>
+              </a:rPr>
+              <a:t>Decoder cannot access future tokens during generation.</a:t>
+            </a:r>
+          </a:p>
+        </p:txBody>
+      </p:sp>
+      <p:sp>
+        <p:nvSpPr>
+          <p:cNvPr id="9" name="TextBox 8"/>
+          <p:cNvSpPr txBox="1"/>
+          <p:nvPr/>
+        </p:nvSpPr>
+        <p:spPr>
+          <a:xfrm>
+            <a:off x="548640" y="2434590"/>
+            <a:ext cx="320040" cy="605790"/>
+          </a:xfrm>
+          <a:prstGeom prst="rect">
+            <a:avLst/>
+          </a:prstGeom>
+          <a:noFill/>
+        </p:spPr>
+        <p:txBody>
+          <a:bodyPr wrap="square" anchor="t">
+            <a:spAutoFit/>
+          </a:bodyPr>
+          <a:lstStyle/>
+          <a:p>
+            <a:pPr algn="l"/>
+            <a:r>
+              <a:rPr sz="1500" b="0">
+                <a:solidFill>
+                  <a:srgbClr val="9E59CD"/>
+                </a:solidFill>
+                <a:latin typeface="DIN Next LT W23"/>
+                <a:ea typeface="DIN Next LT W23"/>
+                <a:cs typeface="DIN Next LT W23"/>
+              </a:rPr>
+              <a:t>–</a:t>
+            </a:r>
+          </a:p>
+        </p:txBody>
+      </p:sp>
+      <p:sp>
+        <p:nvSpPr>
+          <p:cNvPr id="10" name="TextBox 9"/>
+          <p:cNvSpPr txBox="1"/>
+          <p:nvPr/>
+        </p:nvSpPr>
+        <p:spPr>
+          <a:xfrm>
+            <a:off x="914400" y="2434590"/>
+            <a:ext cx="9875519" cy="605790"/>
+          </a:xfrm>
+          <a:prstGeom prst="rect">
+            <a:avLst/>
+          </a:prstGeom>
+          <a:noFill/>
+        </p:spPr>
+        <p:txBody>
+          <a:bodyPr wrap="square" anchor="t">
+            <a:spAutoFit/>
+          </a:bodyPr>
+          <a:lstStyle/>
+          <a:p>
+            <a:pPr algn="l"/>
+            <a:r>
+              <a:rPr sz="1500" b="0">
+                <a:solidFill>
+                  <a:srgbClr val="121018"/>
+                </a:solidFill>
+                <a:latin typeface="DIN Next LT W23"/>
+                <a:ea typeface="DIN Next LT W23"/>
+                <a:cs typeface="DIN Next LT W23"/>
+              </a:rPr>
+              <a:t>Causal mask enforces left-to-right consistency and prevents information leakage.</a:t>
+            </a:r>
+          </a:p>
+        </p:txBody>
+      </p:sp>
+      <p:sp>
+        <p:nvSpPr>
+          <p:cNvPr id="11" name="TextBox 10"/>
+          <p:cNvSpPr txBox="1"/>
+          <p:nvPr/>
+        </p:nvSpPr>
+        <p:spPr>
+          <a:xfrm>
+            <a:off x="548640" y="3131820"/>
+            <a:ext cx="320040" cy="605790"/>
+          </a:xfrm>
+          <a:prstGeom prst="rect">
+            <a:avLst/>
+          </a:prstGeom>
+          <a:noFill/>
+        </p:spPr>
+        <p:txBody>
+          <a:bodyPr wrap="square" anchor="t">
+            <a:spAutoFit/>
+          </a:bodyPr>
+          <a:lstStyle/>
+          <a:p>
+            <a:pPr algn="l"/>
+            <a:r>
+              <a:rPr sz="1500" b="0">
+                <a:solidFill>
+                  <a:srgbClr val="9E59CD"/>
+                </a:solidFill>
+                <a:latin typeface="DIN Next LT W23"/>
+                <a:ea typeface="DIN Next LT W23"/>
+                <a:cs typeface="DIN Next LT W23"/>
+              </a:rPr>
+              <a:t>–</a:t>
+            </a:r>
+          </a:p>
+        </p:txBody>
+      </p:sp>
+      <p:sp>
+        <p:nvSpPr>
+          <p:cNvPr id="12" name="TextBox 11"/>
+          <p:cNvSpPr txBox="1"/>
+          <p:nvPr/>
+        </p:nvSpPr>
+        <p:spPr>
+          <a:xfrm>
+            <a:off x="914400" y="3131820"/>
+            <a:ext cx="9875519" cy="605790"/>
+          </a:xfrm>
+          <a:prstGeom prst="rect">
+            <a:avLst/>
+          </a:prstGeom>
+          <a:noFill/>
+        </p:spPr>
+        <p:txBody>
+          <a:bodyPr wrap="square" anchor="t">
+            <a:spAutoFit/>
+          </a:bodyPr>
+          <a:lstStyle/>
+          <a:p>
+            <a:pPr algn="l"/>
+            <a:r>
+              <a:rPr sz="1500" b="0">
+                <a:solidFill>
+                  <a:srgbClr val="121018"/>
+                </a:solidFill>
+                <a:latin typeface="DIN Next LT W23"/>
+                <a:ea typeface="DIN Next LT W23"/>
+                <a:cs typeface="DIN Next LT W23"/>
+              </a:rPr>
+              <a:t>Enables parallel training over full target sequence while preserving autoregressive objective.</a:t>
+            </a:r>
+          </a:p>
+        </p:txBody>
+      </p:sp>
+      <p:sp>
+        <p:nvSpPr>
+          <p:cNvPr id="13" name="Rectangle 12"/>
+          <p:cNvSpPr/>
+          <p:nvPr/>
+        </p:nvSpPr>
+        <p:spPr>
+          <a:xfrm>
+            <a:off x="548640" y="6446520"/>
+            <a:ext cx="11064240" cy="10972"/>
+          </a:xfrm>
+          <a:prstGeom prst="rect">
+            <a:avLst/>
+          </a:prstGeom>
+          <a:solidFill>
+            <a:srgbClr val="5234B7"/>
+          </a:solidFill>
+          <a:ln>
+            <a:noFill/>
+          </a:ln>
+          <a:effectLst/>
+        </p:spPr>
+        <p:style>
+          <a:lnRef idx="1">
+            <a:schemeClr val="accent1"/>
+          </a:lnRef>
+          <a:fillRef idx="3">
+            <a:schemeClr val="accent1"/>
+          </a:fillRef>
+          <a:effectRef idx="2">
+            <a:schemeClr val="accent1"/>
+          </a:effectRef>
+          <a:fontRef idx="minor">
+            <a:schemeClr val="lt1"/>
+          </a:fontRef>
+        </p:style>
+        <p:txBody>
+          <a:bodyPr rtlCol="0" anchor="ctr"/>
+          <a:lstStyle/>
+          <a:p>
+            <a:pPr algn="ctr"/>
+          </a:p>
+        </p:txBody>
+      </p:sp>
+      <p:sp>
+        <p:nvSpPr>
+          <p:cNvPr id="14" name="TextBox 13"/>
+          <p:cNvSpPr txBox="1"/>
+          <p:nvPr/>
+        </p:nvSpPr>
+        <p:spPr>
+          <a:xfrm>
+            <a:off x="548640" y="6510528"/>
+            <a:ext cx="2743200" cy="256032"/>
+          </a:xfrm>
+          <a:prstGeom prst="rect">
+            <a:avLst/>
+          </a:prstGeom>
+          <a:noFill/>
+        </p:spPr>
+        <p:txBody>
+          <a:bodyPr wrap="square" anchor="t">
+            <a:spAutoFit/>
+          </a:bodyPr>
+          <a:lstStyle/>
+          <a:p>
+            <a:pPr algn="l"/>
+            <a:r>
+              <a:rPr sz="1100" b="1">
+                <a:solidFill>
+                  <a:srgbClr val="5234B7"/>
+                </a:solidFill>
+                <a:latin typeface="DIN Next LT W23"/>
+                <a:ea typeface="DIN Next LT W23"/>
+                <a:cs typeface="DIN Next LT W23"/>
+              </a:rPr>
+              <a:t>ETRA</a:t>
+            </a:r>
+          </a:p>
+        </p:txBody>
+      </p:sp>
+      <p:sp>
+        <p:nvSpPr>
+          <p:cNvPr id="15" name="TextBox 14"/>
+          <p:cNvSpPr txBox="1"/>
+          <p:nvPr/>
+        </p:nvSpPr>
+        <p:spPr>
+          <a:xfrm>
+            <a:off x="9601200" y="6510528"/>
+            <a:ext cx="2011680" cy="256032"/>
+          </a:xfrm>
+          <a:prstGeom prst="rect">
+            <a:avLst/>
+          </a:prstGeom>
+          <a:noFill/>
+        </p:spPr>
+        <p:txBody>
+          <a:bodyPr wrap="square" anchor="t">
+            <a:spAutoFit/>
+          </a:bodyPr>
+          <a:lstStyle/>
+          <a:p>
+            <a:pPr algn="r"/>
+            <a:r>
+              <a:rPr sz="1100" b="0">
+                <a:solidFill>
+                  <a:srgbClr val="5A5470"/>
+                </a:solidFill>
+                <a:latin typeface="DIN Next LT W23"/>
+                <a:ea typeface="DIN Next LT W23"/>
+                <a:cs typeface="DIN Next LT W23"/>
+              </a:rPr>
+              <a:t>30  /  33</a:t>
+            </a:r>
+          </a:p>
+        </p:txBody>
+      </p:sp>
+    </p:spTree>
+  </p:cSld>
+  <p:clrMapOvr>
+    <a:masterClrMapping/>
+  </p:clrMapOvr>
+</p:sld>
+</file>
+
+<file path=ppt/slides/slide31.xml><?xml version="1.0" encoding="utf-8"?>
+<p:sld xmlns:a="http://schemas.openxmlformats.org/drawingml/2006/main" xmlns:p="http://schemas.openxmlformats.org/presentationml/2006/main" xmlns:r="http://schemas.openxmlformats.org/officeDocument/2006/relationships">
+  <p:cSld>
+    <p:bg>
+      <p:bgPr>
+        <a:solidFill>
+          <a:srgbClr val="FAF8FF"/>
+        </a:solidFill>
+        <a:effectLst/>
+      </p:bgPr>
+    </p:bg>
+    <p:spTree>
+      <p:nvGrpSpPr>
+        <p:cNvPr id="1" name=""/>
+        <p:cNvGrpSpPr/>
+        <p:nvPr/>
+      </p:nvGrpSpPr>
+      <p:grpSpPr/>
+      <p:sp>
+        <p:nvSpPr>
+          <p:cNvPr id="2" name="Rectangle 1"/>
+          <p:cNvSpPr/>
+          <p:nvPr/>
+        </p:nvSpPr>
+        <p:spPr>
+          <a:xfrm>
+            <a:off x="12136831" y="0"/>
+            <a:ext cx="54864" cy="6858000"/>
+          </a:xfrm>
+          <a:prstGeom prst="rect">
+            <a:avLst/>
+          </a:prstGeom>
+          <a:solidFill>
+            <a:srgbClr val="5234B7"/>
+          </a:solidFill>
+          <a:ln>
+            <a:noFill/>
+          </a:ln>
+          <a:effectLst/>
+        </p:spPr>
+        <p:style>
+          <a:lnRef idx="1">
+            <a:schemeClr val="accent1"/>
+          </a:lnRef>
+          <a:fillRef idx="3">
+            <a:schemeClr val="accent1"/>
+          </a:fillRef>
+          <a:effectRef idx="2">
+            <a:schemeClr val="accent1"/>
+          </a:effectRef>
+          <a:fontRef idx="minor">
+            <a:schemeClr val="lt1"/>
+          </a:fontRef>
+        </p:style>
+        <p:txBody>
+          <a:bodyPr rtlCol="0" anchor="ctr"/>
+          <a:lstStyle/>
+          <a:p>
+            <a:pPr algn="ctr"/>
+          </a:p>
+        </p:txBody>
+      </p:sp>
+      <p:pic>
+        <p:nvPicPr>
+          <p:cNvPr id="3" name="Picture 2" descr="etra-wordmark.png"/>
+          <p:cNvPicPr>
+            <a:picLocks noChangeAspect="1"/>
+          </p:cNvPicPr>
+          <p:nvPr/>
+        </p:nvPicPr>
+        <p:blipFill>
+          <a:blip r:embed="rId2"/>
+          <a:stretch>
+            <a:fillRect/>
+          </a:stretch>
+        </p:blipFill>
+        <p:spPr>
+          <a:xfrm>
+            <a:off x="10561320" y="411480"/>
+            <a:ext cx="1206201" cy="320040"/>
+          </a:xfrm>
+          <a:prstGeom prst="rect">
+            <a:avLst/>
+          </a:prstGeom>
+        </p:spPr>
+      </p:pic>
+      <p:sp>
+        <p:nvSpPr>
+          <p:cNvPr id="4" name="TextBox 3"/>
+          <p:cNvSpPr txBox="1"/>
+          <p:nvPr/>
+        </p:nvSpPr>
+        <p:spPr>
+          <a:xfrm>
+            <a:off x="548640" y="438912"/>
+            <a:ext cx="7772400" cy="274320"/>
+          </a:xfrm>
+          <a:prstGeom prst="rect">
+            <a:avLst/>
+          </a:prstGeom>
+          <a:noFill/>
+        </p:spPr>
+        <p:txBody>
+          <a:bodyPr wrap="square" anchor="t">
+            <a:spAutoFit/>
+          </a:bodyPr>
+          <a:lstStyle/>
+          <a:p>
+            <a:pPr algn="l"/>
+            <a:r>
+              <a:rPr sz="1200" b="0">
+                <a:solidFill>
+                  <a:srgbClr val="5A5470"/>
+                </a:solidFill>
+                <a:latin typeface="DIN Next LT W23"/>
+                <a:ea typeface="DIN Next LT W23"/>
+                <a:cs typeface="DIN Next LT W23"/>
+              </a:rPr>
+              <a:t>S14  ·  GenAI</a:t>
+            </a:r>
+          </a:p>
+        </p:txBody>
+      </p:sp>
+      <p:sp>
+        <p:nvSpPr>
+          <p:cNvPr id="5" name="Rectangle 4"/>
+          <p:cNvSpPr/>
+          <p:nvPr/>
+        </p:nvSpPr>
+        <p:spPr>
+          <a:xfrm>
+            <a:off x="548640" y="822960"/>
+            <a:ext cx="11064240" cy="10972"/>
+          </a:xfrm>
+          <a:prstGeom prst="rect">
+            <a:avLst/>
+          </a:prstGeom>
+          <a:solidFill>
+            <a:srgbClr val="E4DCF4"/>
+          </a:solidFill>
+          <a:ln>
+            <a:noFill/>
+          </a:ln>
+          <a:effectLst/>
+        </p:spPr>
+        <p:style>
+          <a:lnRef idx="1">
+            <a:schemeClr val="accent1"/>
+          </a:lnRef>
+          <a:fillRef idx="3">
+            <a:schemeClr val="accent1"/>
+          </a:fillRef>
+          <a:effectRef idx="2">
+            <a:schemeClr val="accent1"/>
+          </a:effectRef>
+          <a:fontRef idx="minor">
+            <a:schemeClr val="lt1"/>
+          </a:fontRef>
+        </p:style>
+        <p:txBody>
+          <a:bodyPr rtlCol="0" anchor="ctr"/>
+          <a:lstStyle/>
+          <a:p>
+            <a:pPr algn="ctr"/>
+          </a:p>
+        </p:txBody>
+      </p:sp>
+      <p:sp>
+        <p:nvSpPr>
+          <p:cNvPr id="6" name="TextBox 5"/>
+          <p:cNvSpPr txBox="1"/>
+          <p:nvPr/>
+        </p:nvSpPr>
+        <p:spPr>
+          <a:xfrm>
+            <a:off x="548640" y="1051560"/>
+            <a:ext cx="10241280" cy="594360"/>
+          </a:xfrm>
+          <a:prstGeom prst="rect">
+            <a:avLst/>
+          </a:prstGeom>
+          <a:noFill/>
+        </p:spPr>
+        <p:txBody>
+          <a:bodyPr wrap="square" anchor="t">
+            <a:spAutoFit/>
+          </a:bodyPr>
+          <a:lstStyle/>
+          <a:p>
+            <a:pPr algn="l"/>
+            <a:r>
+              <a:rPr sz="3200" b="1">
+                <a:solidFill>
+                  <a:srgbClr val="5234B7"/>
+                </a:solidFill>
+                <a:latin typeface="DIN Next LT W23"/>
+                <a:ea typeface="DIN Next LT W23"/>
+                <a:cs typeface="DIN Next LT W23"/>
+              </a:rPr>
+              <a:t>Scaling &amp; Practice</a:t>
+            </a:r>
+          </a:p>
+        </p:txBody>
+      </p:sp>
+      <p:sp>
+        <p:nvSpPr>
+          <p:cNvPr id="7" name="TextBox 6"/>
+          <p:cNvSpPr txBox="1"/>
+          <p:nvPr/>
+        </p:nvSpPr>
+        <p:spPr>
+          <a:xfrm>
+            <a:off x="548640" y="1600200"/>
+            <a:ext cx="10241280" cy="365760"/>
+          </a:xfrm>
+          <a:prstGeom prst="rect">
+            <a:avLst/>
+          </a:prstGeom>
+          <a:noFill/>
+        </p:spPr>
+        <p:txBody>
+          <a:bodyPr wrap="square" anchor="t">
+            <a:spAutoFit/>
+          </a:bodyPr>
+          <a:lstStyle/>
+          <a:p>
+            <a:pPr algn="l"/>
+            <a:r>
+              <a:rPr sz="1500" b="0">
+                <a:solidFill>
+                  <a:srgbClr val="5A5470"/>
+                </a:solidFill>
+                <a:latin typeface="DIN Next LT W23"/>
+                <a:ea typeface="DIN Next LT W23"/>
+                <a:cs typeface="DIN Next LT W23"/>
+              </a:rPr>
+              <a:t>Topic 7 of 7</a:t>
+            </a:r>
+          </a:p>
+        </p:txBody>
+      </p:sp>
+      <p:sp>
+        <p:nvSpPr>
+          <p:cNvPr id="8" name="Rounded Rectangle 7"/>
+          <p:cNvSpPr/>
+          <p:nvPr/>
+        </p:nvSpPr>
+        <p:spPr>
+          <a:xfrm>
+            <a:off x="548640" y="2240280"/>
+            <a:ext cx="10972800" cy="3383280"/>
+          </a:xfrm>
+          <a:prstGeom prst="roundRect">
+            <a:avLst>
+              <a:gd name="adj" fmla="val 10000"/>
+            </a:avLst>
+          </a:prstGeom>
+          <a:solidFill>
+            <a:srgbClr val="EEE8FA"/>
+          </a:solidFill>
+          <a:ln>
+            <a:noFill/>
+          </a:ln>
+          <a:effectLst/>
+        </p:spPr>
+        <p:style>
+          <a:lnRef idx="1">
+            <a:schemeClr val="accent1"/>
+          </a:lnRef>
+          <a:fillRef idx="3">
+            <a:schemeClr val="accent1"/>
+          </a:fillRef>
+          <a:effectRef idx="2">
+            <a:schemeClr val="accent1"/>
+          </a:effectRef>
+          <a:fontRef idx="minor">
+            <a:schemeClr val="lt1"/>
+          </a:fontRef>
+        </p:style>
+        <p:txBody>
+          <a:bodyPr rtlCol="0" anchor="ctr"/>
+          <a:lstStyle/>
+          <a:p>
+            <a:pPr algn="ctr"/>
+          </a:p>
+        </p:txBody>
+      </p:sp>
+      <p:sp>
+        <p:nvSpPr>
+          <p:cNvPr id="9" name="TextBox 8"/>
+          <p:cNvSpPr txBox="1"/>
+          <p:nvPr/>
+        </p:nvSpPr>
+        <p:spPr>
+          <a:xfrm>
+            <a:off x="914400" y="3246120"/>
+            <a:ext cx="10241280" cy="502920"/>
+          </a:xfrm>
+          <a:prstGeom prst="rect">
+            <a:avLst/>
+          </a:prstGeom>
+          <a:noFill/>
+        </p:spPr>
+        <p:txBody>
+          <a:bodyPr wrap="square" anchor="t">
+            <a:spAutoFit/>
+          </a:bodyPr>
+          <a:lstStyle/>
+          <a:p>
+            <a:pPr algn="ctr"/>
+            <a:r>
+              <a:rPr sz="2600" b="1">
+                <a:solidFill>
+                  <a:srgbClr val="5234B7"/>
+                </a:solidFill>
+                <a:latin typeface="DIN Next LT W23"/>
+                <a:ea typeface="DIN Next LT W23"/>
+                <a:cs typeface="DIN Next LT W23"/>
+              </a:rPr>
+              <a:t>Scaling &amp; Practice</a:t>
+            </a:r>
+          </a:p>
+        </p:txBody>
+      </p:sp>
+      <p:sp>
+        <p:nvSpPr>
+          <p:cNvPr id="10" name="Rectangle 9"/>
+          <p:cNvSpPr/>
+          <p:nvPr/>
+        </p:nvSpPr>
+        <p:spPr>
+          <a:xfrm>
+            <a:off x="548640" y="6446520"/>
+            <a:ext cx="11064240" cy="10972"/>
+          </a:xfrm>
+          <a:prstGeom prst="rect">
+            <a:avLst/>
+          </a:prstGeom>
+          <a:solidFill>
+            <a:srgbClr val="5234B7"/>
+          </a:solidFill>
+          <a:ln>
+            <a:noFill/>
+          </a:ln>
+          <a:effectLst/>
+        </p:spPr>
+        <p:style>
+          <a:lnRef idx="1">
+            <a:schemeClr val="accent1"/>
+          </a:lnRef>
+          <a:fillRef idx="3">
+            <a:schemeClr val="accent1"/>
+          </a:fillRef>
+          <a:effectRef idx="2">
+            <a:schemeClr val="accent1"/>
+          </a:effectRef>
+          <a:fontRef idx="minor">
+            <a:schemeClr val="lt1"/>
+          </a:fontRef>
+        </p:style>
+        <p:txBody>
+          <a:bodyPr rtlCol="0" anchor="ctr"/>
+          <a:lstStyle/>
+          <a:p>
+            <a:pPr algn="ctr"/>
+          </a:p>
+        </p:txBody>
+      </p:sp>
+      <p:sp>
+        <p:nvSpPr>
+          <p:cNvPr id="11" name="TextBox 10"/>
+          <p:cNvSpPr txBox="1"/>
+          <p:nvPr/>
+        </p:nvSpPr>
+        <p:spPr>
+          <a:xfrm>
+            <a:off x="548640" y="6510528"/>
+            <a:ext cx="2743200" cy="256032"/>
+          </a:xfrm>
+          <a:prstGeom prst="rect">
+            <a:avLst/>
+          </a:prstGeom>
+          <a:noFill/>
+        </p:spPr>
+        <p:txBody>
+          <a:bodyPr wrap="square" anchor="t">
+            <a:spAutoFit/>
+          </a:bodyPr>
+          <a:lstStyle/>
+          <a:p>
+            <a:pPr algn="l"/>
+            <a:r>
+              <a:rPr sz="1100" b="1">
+                <a:solidFill>
+                  <a:srgbClr val="5234B7"/>
+                </a:solidFill>
+                <a:latin typeface="DIN Next LT W23"/>
+                <a:ea typeface="DIN Next LT W23"/>
+                <a:cs typeface="DIN Next LT W23"/>
+              </a:rPr>
+              <a:t>ETRA</a:t>
+            </a:r>
+          </a:p>
+        </p:txBody>
+      </p:sp>
+      <p:sp>
+        <p:nvSpPr>
+          <p:cNvPr id="12" name="TextBox 11"/>
+          <p:cNvSpPr txBox="1"/>
+          <p:nvPr/>
+        </p:nvSpPr>
+        <p:spPr>
+          <a:xfrm>
+            <a:off x="9601200" y="6510528"/>
+            <a:ext cx="2011680" cy="256032"/>
+          </a:xfrm>
+          <a:prstGeom prst="rect">
+            <a:avLst/>
+          </a:prstGeom>
+          <a:noFill/>
+        </p:spPr>
+        <p:txBody>
+          <a:bodyPr wrap="square" anchor="t">
+            <a:spAutoFit/>
+          </a:bodyPr>
+          <a:lstStyle/>
+          <a:p>
+            <a:pPr algn="r"/>
+            <a:r>
+              <a:rPr sz="1100" b="0">
+                <a:solidFill>
+                  <a:srgbClr val="5A5470"/>
+                </a:solidFill>
+                <a:latin typeface="DIN Next LT W23"/>
+                <a:ea typeface="DIN Next LT W23"/>
+                <a:cs typeface="DIN Next LT W23"/>
+              </a:rPr>
+              <a:t>31  /  33</a:t>
+            </a:r>
+          </a:p>
+        </p:txBody>
+      </p:sp>
+    </p:spTree>
+  </p:cSld>
+  <p:clrMapOvr>
+    <a:masterClrMapping/>
+  </p:clrMapOvr>
+</p:sld>
+</file>
+
+<file path=ppt/slides/slide32.xml><?xml version="1.0" encoding="utf-8"?>
+<p:sld xmlns:a="http://schemas.openxmlformats.org/drawingml/2006/main" xmlns:p="http://schemas.openxmlformats.org/presentationml/2006/main" xmlns:r="http://schemas.openxmlformats.org/officeDocument/2006/relationships">
+  <p:cSld>
+    <p:bg>
+      <p:bgPr>
+        <a:solidFill>
+          <a:srgbClr val="FAF8FF"/>
+        </a:solidFill>
+        <a:effectLst/>
+      </p:bgPr>
+    </p:bg>
+    <p:spTree>
+      <p:nvGrpSpPr>
+        <p:cNvPr id="1" name=""/>
+        <p:cNvGrpSpPr/>
+        <p:nvPr/>
+      </p:nvGrpSpPr>
+      <p:grpSpPr/>
+      <p:sp>
+        <p:nvSpPr>
+          <p:cNvPr id="2" name="Rectangle 1"/>
+          <p:cNvSpPr/>
+          <p:nvPr/>
+        </p:nvSpPr>
+        <p:spPr>
+          <a:xfrm>
+            <a:off x="12136831" y="0"/>
+            <a:ext cx="54864" cy="6858000"/>
+          </a:xfrm>
+          <a:prstGeom prst="rect">
+            <a:avLst/>
+          </a:prstGeom>
+          <a:solidFill>
+            <a:srgbClr val="5234B7"/>
+          </a:solidFill>
+          <a:ln>
+            <a:noFill/>
+          </a:ln>
+          <a:effectLst/>
+        </p:spPr>
+        <p:style>
+          <a:lnRef idx="1">
+            <a:schemeClr val="accent1"/>
+          </a:lnRef>
+          <a:fillRef idx="3">
+            <a:schemeClr val="accent1"/>
+          </a:fillRef>
+          <a:effectRef idx="2">
+            <a:schemeClr val="accent1"/>
+          </a:effectRef>
+          <a:fontRef idx="minor">
+            <a:schemeClr val="lt1"/>
+          </a:fontRef>
+        </p:style>
+        <p:txBody>
+          <a:bodyPr rtlCol="0" anchor="ctr"/>
+          <a:lstStyle/>
+          <a:p>
+            <a:pPr algn="ctr"/>
+          </a:p>
+        </p:txBody>
+      </p:sp>
+      <p:pic>
+        <p:nvPicPr>
+          <p:cNvPr id="3" name="Picture 2" descr="etra-wordmark.png"/>
+          <p:cNvPicPr>
+            <a:picLocks noChangeAspect="1"/>
+          </p:cNvPicPr>
+          <p:nvPr/>
+        </p:nvPicPr>
+        <p:blipFill>
+          <a:blip r:embed="rId2"/>
+          <a:stretch>
+            <a:fillRect/>
+          </a:stretch>
+        </p:blipFill>
+        <p:spPr>
+          <a:xfrm>
+            <a:off x="10561320" y="411480"/>
+            <a:ext cx="1206201" cy="320040"/>
+          </a:xfrm>
+          <a:prstGeom prst="rect">
+            <a:avLst/>
+          </a:prstGeom>
+        </p:spPr>
+      </p:pic>
+      <p:sp>
+        <p:nvSpPr>
+          <p:cNvPr id="4" name="TextBox 3"/>
+          <p:cNvSpPr txBox="1"/>
+          <p:nvPr/>
+        </p:nvSpPr>
+        <p:spPr>
+          <a:xfrm>
+            <a:off x="548640" y="438912"/>
+            <a:ext cx="7772400" cy="274320"/>
+          </a:xfrm>
+          <a:prstGeom prst="rect">
+            <a:avLst/>
+          </a:prstGeom>
+          <a:noFill/>
+        </p:spPr>
+        <p:txBody>
+          <a:bodyPr wrap="square" anchor="t">
+            <a:spAutoFit/>
+          </a:bodyPr>
+          <a:lstStyle/>
+          <a:p>
+            <a:pPr algn="l"/>
+            <a:r>
+              <a:rPr sz="1200" b="0">
+                <a:solidFill>
+                  <a:srgbClr val="5A5470"/>
+                </a:solidFill>
+                <a:latin typeface="DIN Next LT W23"/>
+                <a:ea typeface="DIN Next LT W23"/>
+                <a:cs typeface="DIN Next LT W23"/>
+              </a:rPr>
+              <a:t>S14  ·  Takeaways</a:t>
+            </a:r>
+          </a:p>
+        </p:txBody>
+      </p:sp>
+      <p:sp>
+        <p:nvSpPr>
+          <p:cNvPr id="5" name="Rectangle 4"/>
+          <p:cNvSpPr/>
+          <p:nvPr/>
+        </p:nvSpPr>
+        <p:spPr>
+          <a:xfrm>
+            <a:off x="548640" y="822960"/>
+            <a:ext cx="11064240" cy="10972"/>
+          </a:xfrm>
+          <a:prstGeom prst="rect">
+            <a:avLst/>
+          </a:prstGeom>
+          <a:solidFill>
+            <a:srgbClr val="E4DCF4"/>
+          </a:solidFill>
+          <a:ln>
+            <a:noFill/>
+          </a:ln>
+          <a:effectLst/>
+        </p:spPr>
+        <p:style>
+          <a:lnRef idx="1">
+            <a:schemeClr val="accent1"/>
+          </a:lnRef>
+          <a:fillRef idx="3">
+            <a:schemeClr val="accent1"/>
+          </a:fillRef>
+          <a:effectRef idx="2">
+            <a:schemeClr val="accent1"/>
+          </a:effectRef>
+          <a:fontRef idx="minor">
+            <a:schemeClr val="lt1"/>
+          </a:fontRef>
+        </p:style>
+        <p:txBody>
+          <a:bodyPr rtlCol="0" anchor="ctr"/>
+          <a:lstStyle/>
+          <a:p>
+            <a:pPr algn="ctr"/>
+          </a:p>
+        </p:txBody>
+      </p:sp>
+      <p:sp>
+        <p:nvSpPr>
+          <p:cNvPr id="6" name="TextBox 5"/>
+          <p:cNvSpPr txBox="1"/>
+          <p:nvPr/>
+        </p:nvSpPr>
+        <p:spPr>
+          <a:xfrm>
+            <a:off x="548640" y="1051560"/>
+            <a:ext cx="10241280" cy="594360"/>
+          </a:xfrm>
+          <a:prstGeom prst="rect">
+            <a:avLst/>
+          </a:prstGeom>
+          <a:noFill/>
+        </p:spPr>
+        <p:txBody>
+          <a:bodyPr wrap="square" anchor="t">
+            <a:spAutoFit/>
+          </a:bodyPr>
+          <a:lstStyle/>
+          <a:p>
+            <a:pPr algn="l"/>
+            <a:r>
+              <a:rPr sz="3200" b="1">
+                <a:solidFill>
+                  <a:srgbClr val="5234B7"/>
+                </a:solidFill>
+                <a:latin typeface="DIN Next LT W23"/>
+                <a:ea typeface="DIN Next LT W23"/>
+                <a:cs typeface="DIN Next LT W23"/>
+              </a:rPr>
+              <a:t>3 Ideas to Keep</a:t>
+            </a:r>
+          </a:p>
+        </p:txBody>
+      </p:sp>
+      <p:sp>
+        <p:nvSpPr>
+          <p:cNvPr id="7" name="TextBox 6"/>
+          <p:cNvSpPr txBox="1"/>
+          <p:nvPr/>
+        </p:nvSpPr>
+        <p:spPr>
+          <a:xfrm>
+            <a:off x="548640" y="1600200"/>
+            <a:ext cx="10241280" cy="365760"/>
+          </a:xfrm>
+          <a:prstGeom prst="rect">
+            <a:avLst/>
+          </a:prstGeom>
+          <a:noFill/>
+        </p:spPr>
+        <p:txBody>
+          <a:bodyPr wrap="square" anchor="t">
+            <a:spAutoFit/>
+          </a:bodyPr>
+          <a:lstStyle/>
+          <a:p>
+            <a:pPr algn="l"/>
+            <a:r>
+              <a:rPr sz="1500" b="0">
+                <a:solidFill>
+                  <a:srgbClr val="5A5470"/>
+                </a:solidFill>
+                <a:latin typeface="DIN Next LT W23"/>
+                <a:ea typeface="DIN Next LT W23"/>
+                <a:cs typeface="DIN Next LT W23"/>
+              </a:rPr>
+              <a:t>Leave with these</a:t>
+            </a:r>
+          </a:p>
+        </p:txBody>
+      </p:sp>
+      <p:sp>
+        <p:nvSpPr>
+          <p:cNvPr id="8" name="Rounded Rectangle 7"/>
+          <p:cNvSpPr/>
+          <p:nvPr/>
+        </p:nvSpPr>
+        <p:spPr>
+          <a:xfrm>
+            <a:off x="548640" y="2148840"/>
+            <a:ext cx="10972800" cy="987552"/>
+          </a:xfrm>
+          <a:prstGeom prst="roundRect">
+            <a:avLst>
+              <a:gd name="adj" fmla="val 10000"/>
+            </a:avLst>
+          </a:prstGeom>
+          <a:solidFill>
+            <a:srgbClr val="EEE8FA"/>
+          </a:solidFill>
+          <a:ln>
+            <a:noFill/>
+          </a:ln>
+          <a:effectLst/>
+        </p:spPr>
+        <p:style>
+          <a:lnRef idx="1">
+            <a:schemeClr val="accent1"/>
+          </a:lnRef>
+          <a:fillRef idx="3">
+            <a:schemeClr val="accent1"/>
+          </a:fillRef>
+          <a:effectRef idx="2">
+            <a:schemeClr val="accent1"/>
+          </a:effectRef>
+          <a:fontRef idx="minor">
+            <a:schemeClr val="lt1"/>
+          </a:fontRef>
+        </p:style>
+        <p:txBody>
+          <a:bodyPr rtlCol="0" anchor="ctr"/>
+          <a:lstStyle/>
+          <a:p>
+            <a:pPr algn="ctr"/>
+          </a:p>
+        </p:txBody>
+      </p:sp>
+      <p:sp>
+        <p:nvSpPr>
+          <p:cNvPr id="9" name="TextBox 8"/>
+          <p:cNvSpPr txBox="1"/>
+          <p:nvPr/>
+        </p:nvSpPr>
+        <p:spPr>
+          <a:xfrm>
+            <a:off x="822960" y="2404872"/>
+            <a:ext cx="457200" cy="457200"/>
+          </a:xfrm>
+          <a:prstGeom prst="rect">
+            <a:avLst/>
+          </a:prstGeom>
+          <a:noFill/>
+        </p:spPr>
+        <p:txBody>
+          <a:bodyPr wrap="square" anchor="t">
+            <a:spAutoFit/>
+          </a:bodyPr>
+          <a:lstStyle/>
+          <a:p>
+            <a:pPr algn="l"/>
+            <a:r>
+              <a:rPr sz="2200" b="1">
+                <a:solidFill>
+                  <a:srgbClr val="5234B7"/>
+                </a:solidFill>
+                <a:latin typeface="DIN Next LT W23"/>
+                <a:ea typeface="DIN Next LT W23"/>
+                <a:cs typeface="DIN Next LT W23"/>
+              </a:rPr>
+              <a:t>1</a:t>
+            </a:r>
+          </a:p>
+        </p:txBody>
+      </p:sp>
+      <p:sp>
+        <p:nvSpPr>
+          <p:cNvPr id="10" name="TextBox 9"/>
+          <p:cNvSpPr txBox="1"/>
+          <p:nvPr/>
+        </p:nvSpPr>
+        <p:spPr>
+          <a:xfrm>
+            <a:off x="1417320" y="2404872"/>
+            <a:ext cx="9692640" cy="548640"/>
+          </a:xfrm>
+          <a:prstGeom prst="rect">
+            <a:avLst/>
+          </a:prstGeom>
+          <a:noFill/>
+        </p:spPr>
+        <p:txBody>
+          <a:bodyPr wrap="square" anchor="t">
+            <a:spAutoFit/>
+          </a:bodyPr>
+          <a:lstStyle/>
+          <a:p>
+            <a:pPr algn="l"/>
+            <a:r>
+              <a:rPr sz="1600" b="0">
+                <a:solidFill>
+                  <a:srgbClr val="121018"/>
+                </a:solidFill>
+                <a:latin typeface="DIN Next LT W23"/>
+                <a:ea typeface="DIN Next LT W23"/>
+                <a:cs typeface="DIN Next LT W23"/>
+              </a:rPr>
+              <a:t>Choose architecture by task: encoder-only (BERT), encoder-decoder (T5), or decoder-only (GPT).</a:t>
+            </a:r>
+          </a:p>
+        </p:txBody>
+      </p:sp>
+      <p:sp>
+        <p:nvSpPr>
+          <p:cNvPr id="11" name="Rounded Rectangle 10"/>
+          <p:cNvSpPr/>
+          <p:nvPr/>
+        </p:nvSpPr>
+        <p:spPr>
+          <a:xfrm>
+            <a:off x="548640" y="3291840"/>
+            <a:ext cx="10972800" cy="987552"/>
+          </a:xfrm>
+          <a:prstGeom prst="roundRect">
+            <a:avLst>
+              <a:gd name="adj" fmla="val 10000"/>
+            </a:avLst>
+          </a:prstGeom>
+          <a:solidFill>
+            <a:srgbClr val="EEE8FA"/>
+          </a:solidFill>
+          <a:ln>
+            <a:noFill/>
+          </a:ln>
+          <a:effectLst/>
+        </p:spPr>
+        <p:style>
+          <a:lnRef idx="1">
+            <a:schemeClr val="accent1"/>
+          </a:lnRef>
+          <a:fillRef idx="3">
+            <a:schemeClr val="accent1"/>
+          </a:fillRef>
+          <a:effectRef idx="2">
+            <a:schemeClr val="accent1"/>
+          </a:effectRef>
+          <a:fontRef idx="minor">
+            <a:schemeClr val="lt1"/>
+          </a:fontRef>
+        </p:style>
+        <p:txBody>
+          <a:bodyPr rtlCol="0" anchor="ctr"/>
+          <a:lstStyle/>
+          <a:p>
+            <a:pPr algn="ctr"/>
+          </a:p>
+        </p:txBody>
+      </p:sp>
+      <p:sp>
+        <p:nvSpPr>
+          <p:cNvPr id="12" name="TextBox 11"/>
+          <p:cNvSpPr txBox="1"/>
+          <p:nvPr/>
+        </p:nvSpPr>
+        <p:spPr>
+          <a:xfrm>
+            <a:off x="822960" y="3547872"/>
+            <a:ext cx="457200" cy="457200"/>
+          </a:xfrm>
+          <a:prstGeom prst="rect">
+            <a:avLst/>
+          </a:prstGeom>
+          <a:noFill/>
+        </p:spPr>
+        <p:txBody>
+          <a:bodyPr wrap="square" anchor="t">
+            <a:spAutoFit/>
+          </a:bodyPr>
+          <a:lstStyle/>
+          <a:p>
+            <a:pPr algn="l"/>
+            <a:r>
+              <a:rPr sz="2200" b="1">
+                <a:solidFill>
+                  <a:srgbClr val="5234B7"/>
+                </a:solidFill>
+                <a:latin typeface="DIN Next LT W23"/>
+                <a:ea typeface="DIN Next LT W23"/>
+                <a:cs typeface="DIN Next LT W23"/>
+              </a:rPr>
+              <a:t>2</a:t>
+            </a:r>
+          </a:p>
+        </p:txBody>
+      </p:sp>
+      <p:sp>
+        <p:nvSpPr>
+          <p:cNvPr id="13" name="TextBox 12"/>
+          <p:cNvSpPr txBox="1"/>
+          <p:nvPr/>
+        </p:nvSpPr>
+        <p:spPr>
+          <a:xfrm>
+            <a:off x="1417320" y="3547872"/>
+            <a:ext cx="9692640" cy="548640"/>
+          </a:xfrm>
+          <a:prstGeom prst="rect">
+            <a:avLst/>
+          </a:prstGeom>
+          <a:noFill/>
+        </p:spPr>
+        <p:txBody>
+          <a:bodyPr wrap="square" anchor="t">
+            <a:spAutoFit/>
+          </a:bodyPr>
+          <a:lstStyle/>
+          <a:p>
+            <a:pPr algn="l"/>
+            <a:r>
+              <a:rPr sz="1600" b="0">
+                <a:solidFill>
+                  <a:srgbClr val="121018"/>
+                </a:solidFill>
+                <a:latin typeface="DIN Next LT W23"/>
+                <a:ea typeface="DIN Next LT W23"/>
+                <a:cs typeface="DIN Next LT W23"/>
+              </a:rPr>
+              <a:t>Prefer transfer learning and fine-tuning over training from scratch.</a:t>
+            </a:r>
+          </a:p>
+        </p:txBody>
+      </p:sp>
+      <p:sp>
+        <p:nvSpPr>
+          <p:cNvPr id="14" name="Rounded Rectangle 13"/>
+          <p:cNvSpPr/>
+          <p:nvPr/>
+        </p:nvSpPr>
+        <p:spPr>
+          <a:xfrm>
+            <a:off x="548640" y="4434840"/>
+            <a:ext cx="10972800" cy="987552"/>
+          </a:xfrm>
+          <a:prstGeom prst="roundRect">
+            <a:avLst>
+              <a:gd name="adj" fmla="val 10000"/>
+            </a:avLst>
+          </a:prstGeom>
+          <a:solidFill>
+            <a:srgbClr val="EEE8FA"/>
+          </a:solidFill>
+          <a:ln>
+            <a:noFill/>
+          </a:ln>
+          <a:effectLst/>
+        </p:spPr>
+        <p:style>
+          <a:lnRef idx="1">
+            <a:schemeClr val="accent1"/>
+          </a:lnRef>
+          <a:fillRef idx="3">
+            <a:schemeClr val="accent1"/>
+          </a:fillRef>
+          <a:effectRef idx="2">
+            <a:schemeClr val="accent1"/>
+          </a:effectRef>
+          <a:fontRef idx="minor">
+            <a:schemeClr val="lt1"/>
+          </a:fontRef>
+        </p:style>
+        <p:txBody>
+          <a:bodyPr rtlCol="0" anchor="ctr"/>
+          <a:lstStyle/>
+          <a:p>
+            <a:pPr algn="ctr"/>
+          </a:p>
+        </p:txBody>
+      </p:sp>
+      <p:sp>
+        <p:nvSpPr>
+          <p:cNvPr id="15" name="TextBox 14"/>
+          <p:cNvSpPr txBox="1"/>
+          <p:nvPr/>
+        </p:nvSpPr>
+        <p:spPr>
+          <a:xfrm>
+            <a:off x="822960" y="4690872"/>
+            <a:ext cx="457200" cy="457200"/>
+          </a:xfrm>
+          <a:prstGeom prst="rect">
+            <a:avLst/>
+          </a:prstGeom>
+          <a:noFill/>
+        </p:spPr>
+        <p:txBody>
+          <a:bodyPr wrap="square" anchor="t">
+            <a:spAutoFit/>
+          </a:bodyPr>
+          <a:lstStyle/>
+          <a:p>
+            <a:pPr algn="l"/>
+            <a:r>
+              <a:rPr sz="2200" b="1">
+                <a:solidFill>
+                  <a:srgbClr val="5234B7"/>
+                </a:solidFill>
+                <a:latin typeface="DIN Next LT W23"/>
+                <a:ea typeface="DIN Next LT W23"/>
+                <a:cs typeface="DIN Next LT W23"/>
+              </a:rPr>
+              <a:t>3</a:t>
+            </a:r>
+          </a:p>
+        </p:txBody>
+      </p:sp>
+      <p:sp>
+        <p:nvSpPr>
+          <p:cNvPr id="16" name="TextBox 15"/>
+          <p:cNvSpPr txBox="1"/>
+          <p:nvPr/>
+        </p:nvSpPr>
+        <p:spPr>
+          <a:xfrm>
+            <a:off x="1417320" y="4690872"/>
+            <a:ext cx="9692640" cy="548640"/>
+          </a:xfrm>
+          <a:prstGeom prst="rect">
+            <a:avLst/>
+          </a:prstGeom>
+          <a:noFill/>
+        </p:spPr>
+        <p:txBody>
+          <a:bodyPr wrap="square" anchor="t">
+            <a:spAutoFit/>
+          </a:bodyPr>
+          <a:lstStyle/>
+          <a:p>
+            <a:pPr algn="l"/>
+            <a:r>
+              <a:rPr sz="1600" b="0">
+                <a:solidFill>
+                  <a:srgbClr val="121018"/>
+                </a:solidFill>
+                <a:latin typeface="DIN Next LT W23"/>
+                <a:ea typeface="DIN Next LT W23"/>
+                <a:cs typeface="DIN Next LT W23"/>
+              </a:rPr>
+              <a:t>Attention, decoding strategy, and compute limits shape what you can ship.</a:t>
+            </a:r>
+          </a:p>
+        </p:txBody>
+      </p:sp>
+      <p:sp>
+        <p:nvSpPr>
+          <p:cNvPr id="17" name="Rectangle 16"/>
+          <p:cNvSpPr/>
+          <p:nvPr/>
+        </p:nvSpPr>
+        <p:spPr>
+          <a:xfrm>
+            <a:off x="548640" y="6446520"/>
+            <a:ext cx="11064240" cy="10972"/>
+          </a:xfrm>
+          <a:prstGeom prst="rect">
+            <a:avLst/>
+          </a:prstGeom>
+          <a:solidFill>
+            <a:srgbClr val="5234B7"/>
+          </a:solidFill>
+          <a:ln>
+            <a:noFill/>
+          </a:ln>
+          <a:effectLst/>
+        </p:spPr>
+        <p:style>
+          <a:lnRef idx="1">
+            <a:schemeClr val="accent1"/>
+          </a:lnRef>
+          <a:fillRef idx="3">
+            <a:schemeClr val="accent1"/>
+          </a:fillRef>
+          <a:effectRef idx="2">
+            <a:schemeClr val="accent1"/>
+          </a:effectRef>
+          <a:fontRef idx="minor">
+            <a:schemeClr val="lt1"/>
+          </a:fontRef>
+        </p:style>
+        <p:txBody>
+          <a:bodyPr rtlCol="0" anchor="ctr"/>
+          <a:lstStyle/>
+          <a:p>
+            <a:pPr algn="ctr"/>
+          </a:p>
+        </p:txBody>
+      </p:sp>
+      <p:sp>
+        <p:nvSpPr>
+          <p:cNvPr id="18" name="TextBox 17"/>
+          <p:cNvSpPr txBox="1"/>
+          <p:nvPr/>
+        </p:nvSpPr>
+        <p:spPr>
+          <a:xfrm>
+            <a:off x="548640" y="6510528"/>
+            <a:ext cx="2743200" cy="256032"/>
+          </a:xfrm>
+          <a:prstGeom prst="rect">
+            <a:avLst/>
+          </a:prstGeom>
+          <a:noFill/>
+        </p:spPr>
+        <p:txBody>
+          <a:bodyPr wrap="square" anchor="t">
+            <a:spAutoFit/>
+          </a:bodyPr>
+          <a:lstStyle/>
+          <a:p>
+            <a:pPr algn="l"/>
+            <a:r>
+              <a:rPr sz="1100" b="1">
+                <a:solidFill>
+                  <a:srgbClr val="5234B7"/>
+                </a:solidFill>
+                <a:latin typeface="DIN Next LT W23"/>
+                <a:ea typeface="DIN Next LT W23"/>
+                <a:cs typeface="DIN Next LT W23"/>
+              </a:rPr>
+              <a:t>ETRA</a:t>
+            </a:r>
+          </a:p>
+        </p:txBody>
+      </p:sp>
+      <p:sp>
+        <p:nvSpPr>
+          <p:cNvPr id="19" name="TextBox 18"/>
+          <p:cNvSpPr txBox="1"/>
+          <p:nvPr/>
+        </p:nvSpPr>
+        <p:spPr>
+          <a:xfrm>
+            <a:off x="9601200" y="6510528"/>
+            <a:ext cx="2011680" cy="256032"/>
+          </a:xfrm>
+          <a:prstGeom prst="rect">
+            <a:avLst/>
+          </a:prstGeom>
+          <a:noFill/>
+        </p:spPr>
+        <p:txBody>
+          <a:bodyPr wrap="square" anchor="t">
+            <a:spAutoFit/>
+          </a:bodyPr>
+          <a:lstStyle/>
+          <a:p>
+            <a:pPr algn="r"/>
+            <a:r>
+              <a:rPr sz="1100" b="0">
+                <a:solidFill>
+                  <a:srgbClr val="5A5470"/>
+                </a:solidFill>
+                <a:latin typeface="DIN Next LT W23"/>
+                <a:ea typeface="DIN Next LT W23"/>
+                <a:cs typeface="DIN Next LT W23"/>
+              </a:rPr>
+              <a:t>32  /  33</a:t>
+            </a:r>
+          </a:p>
+        </p:txBody>
+      </p:sp>
+    </p:spTree>
+  </p:cSld>
+  <p:clrMapOvr>
+    <a:masterClrMapping/>
+  </p:clrMapOvr>
+</p:sld>
+</file>
+
+<file path=ppt/slides/slide33.xml><?xml version="1.0" encoding="utf-8"?>
+<p:sld xmlns:a="http://schemas.openxmlformats.org/drawingml/2006/main" xmlns:p="http://schemas.openxmlformats.org/presentationml/2006/main" xmlns:r="http://schemas.openxmlformats.org/officeDocument/2006/relationships">
+  <p:cSld>
+    <p:bg>
+      <p:bgPr>
+        <a:solidFill>
+          <a:srgbClr val="FAF8FF"/>
+        </a:solidFill>
+        <a:effectLst/>
+      </p:bgPr>
+    </p:bg>
+    <p:spTree>
+      <p:nvGrpSpPr>
+        <p:cNvPr id="1" name=""/>
+        <p:cNvGrpSpPr/>
+        <p:nvPr/>
+      </p:nvGrpSpPr>
+      <p:grpSpPr/>
+      <p:sp>
+        <p:nvSpPr>
+          <p:cNvPr id="2" name="Rectangle 1"/>
+          <p:cNvSpPr/>
+          <p:nvPr/>
+        </p:nvSpPr>
+        <p:spPr>
+          <a:xfrm>
+            <a:off x="12136831" y="0"/>
+            <a:ext cx="54864" cy="6858000"/>
+          </a:xfrm>
+          <a:prstGeom prst="rect">
+            <a:avLst/>
+          </a:prstGeom>
+          <a:solidFill>
+            <a:srgbClr val="5234B7"/>
+          </a:solidFill>
+          <a:ln>
+            <a:noFill/>
+          </a:ln>
+          <a:effectLst/>
+        </p:spPr>
+        <p:style>
+          <a:lnRef idx="1">
+            <a:schemeClr val="accent1"/>
+          </a:lnRef>
+          <a:fillRef idx="3">
+            <a:schemeClr val="accent1"/>
+          </a:fillRef>
+          <a:effectRef idx="2">
+            <a:schemeClr val="accent1"/>
+          </a:effectRef>
+          <a:fontRef idx="minor">
+            <a:schemeClr val="lt1"/>
+          </a:fontRef>
+        </p:style>
+        <p:txBody>
+          <a:bodyPr rtlCol="0" anchor="ctr"/>
+          <a:lstStyle/>
+          <a:p>
+            <a:pPr algn="ctr"/>
+          </a:p>
+        </p:txBody>
+      </p:sp>
+      <p:pic>
+        <p:nvPicPr>
+          <p:cNvPr id="3" name="Picture 2" descr="etra-wordmark.png"/>
+          <p:cNvPicPr>
+            <a:picLocks noChangeAspect="1"/>
+          </p:cNvPicPr>
+          <p:nvPr/>
+        </p:nvPicPr>
+        <p:blipFill>
+          <a:blip r:embed="rId2"/>
+          <a:stretch>
+            <a:fillRect/>
+          </a:stretch>
+        </p:blipFill>
+        <p:spPr>
+          <a:xfrm>
+            <a:off x="10561320" y="411480"/>
+            <a:ext cx="1378516" cy="365760"/>
+          </a:xfrm>
+          <a:prstGeom prst="rect">
+            <a:avLst/>
+          </a:prstGeom>
+        </p:spPr>
+      </p:pic>
+      <p:sp>
+        <p:nvSpPr>
+          <p:cNvPr id="4" name="TextBox 3"/>
+          <p:cNvSpPr txBox="1"/>
+          <p:nvPr/>
+        </p:nvSpPr>
+        <p:spPr>
+          <a:xfrm>
+            <a:off x="548640" y="2651760"/>
+            <a:ext cx="10972800" cy="731520"/>
+          </a:xfrm>
+          <a:prstGeom prst="rect">
+            <a:avLst/>
+          </a:prstGeom>
+          <a:noFill/>
+        </p:spPr>
+        <p:txBody>
+          <a:bodyPr wrap="square" anchor="t">
+            <a:spAutoFit/>
+          </a:bodyPr>
+          <a:lstStyle/>
+          <a:p>
+            <a:pPr algn="ctr"/>
+            <a:r>
+              <a:rPr sz="4000" b="1">
+                <a:solidFill>
+                  <a:srgbClr val="5234B7"/>
+                </a:solidFill>
+                <a:latin typeface="DIN Next LT W23"/>
+                <a:ea typeface="DIN Next LT W23"/>
+                <a:cs typeface="DIN Next LT W23"/>
+              </a:rPr>
+              <a:t>Thank you</a:t>
+            </a:r>
+          </a:p>
+        </p:txBody>
+      </p:sp>
+      <p:sp>
+        <p:nvSpPr>
+          <p:cNvPr id="5" name="TextBox 4"/>
+          <p:cNvSpPr txBox="1"/>
+          <p:nvPr/>
+        </p:nvSpPr>
+        <p:spPr>
+          <a:xfrm>
+            <a:off x="548640" y="3474720"/>
+            <a:ext cx="10972800" cy="365760"/>
+          </a:xfrm>
+          <a:prstGeom prst="rect">
+            <a:avLst/>
+          </a:prstGeom>
+          <a:noFill/>
+        </p:spPr>
+        <p:txBody>
+          <a:bodyPr wrap="square" anchor="t">
+            <a:spAutoFit/>
+          </a:bodyPr>
+          <a:lstStyle/>
+          <a:p>
+            <a:pPr algn="ctr"/>
+            <a:r>
+              <a:rPr sz="1600" b="0">
+                <a:solidFill>
+                  <a:srgbClr val="5A5470"/>
+                </a:solidFill>
+                <a:latin typeface="DIN Next LT W23"/>
+                <a:ea typeface="DIN Next LT W23"/>
+                <a:cs typeface="DIN Next LT W23"/>
+              </a:rPr>
+              <a:t>Labs: code/17- GenAI</a:t>
+            </a:r>
+          </a:p>
+        </p:txBody>
+      </p:sp>
+      <p:sp>
+        <p:nvSpPr>
+          <p:cNvPr id="6" name="TextBox 5"/>
+          <p:cNvSpPr txBox="1"/>
+          <p:nvPr/>
+        </p:nvSpPr>
+        <p:spPr>
+          <a:xfrm>
+            <a:off x="548640" y="6126480"/>
+            <a:ext cx="5486400" cy="274320"/>
+          </a:xfrm>
+          <a:prstGeom prst="rect">
+            <a:avLst/>
+          </a:prstGeom>
+          <a:noFill/>
+        </p:spPr>
+        <p:txBody>
+          <a:bodyPr wrap="square" anchor="t">
+            <a:spAutoFit/>
+          </a:bodyPr>
+          <a:lstStyle/>
+          <a:p>
+            <a:pPr algn="l"/>
+            <a:r>
+              <a:rPr sz="1200" b="1">
+                <a:solidFill>
+                  <a:srgbClr val="5234B7"/>
+                </a:solidFill>
+                <a:latin typeface="DIN Next LT W23"/>
+                <a:ea typeface="DIN Next LT W23"/>
+                <a:cs typeface="DIN Next LT W23"/>
+              </a:rPr>
+              <a:t>ETRA</a:t>
+            </a:r>
+          </a:p>
+        </p:txBody>
+      </p:sp>
+      <p:sp>
+        <p:nvSpPr>
+          <p:cNvPr id="7" name="Rectangle 6"/>
+          <p:cNvSpPr/>
+          <p:nvPr/>
+        </p:nvSpPr>
+        <p:spPr>
+          <a:xfrm>
+            <a:off x="548640" y="6446520"/>
+            <a:ext cx="11064240" cy="10972"/>
+          </a:xfrm>
+          <a:prstGeom prst="rect">
+            <a:avLst/>
+          </a:prstGeom>
+          <a:solidFill>
+            <a:srgbClr val="5234B7"/>
+          </a:solidFill>
+          <a:ln>
+            <a:noFill/>
+          </a:ln>
+          <a:effectLst/>
+        </p:spPr>
+        <p:style>
+          <a:lnRef idx="1">
+            <a:schemeClr val="accent1"/>
+          </a:lnRef>
+          <a:fillRef idx="3">
+            <a:schemeClr val="accent1"/>
+          </a:fillRef>
+          <a:effectRef idx="2">
+            <a:schemeClr val="accent1"/>
+          </a:effectRef>
+          <a:fontRef idx="minor">
+            <a:schemeClr val="lt1"/>
+          </a:fontRef>
+        </p:style>
+        <p:txBody>
+          <a:bodyPr rtlCol="0" anchor="ctr"/>
+          <a:lstStyle/>
+          <a:p>
+            <a:pPr algn="ctr"/>
+          </a:p>
+        </p:txBody>
+      </p:sp>
+      <p:sp>
+        <p:nvSpPr>
+          <p:cNvPr id="8" name="TextBox 7"/>
+          <p:cNvSpPr txBox="1"/>
+          <p:nvPr/>
+        </p:nvSpPr>
+        <p:spPr>
+          <a:xfrm>
+            <a:off x="548640" y="6510528"/>
+            <a:ext cx="2743200" cy="256032"/>
+          </a:xfrm>
+          <a:prstGeom prst="rect">
+            <a:avLst/>
+          </a:prstGeom>
+          <a:noFill/>
+        </p:spPr>
+        <p:txBody>
+          <a:bodyPr wrap="square" anchor="t">
+            <a:spAutoFit/>
+          </a:bodyPr>
+          <a:lstStyle/>
+          <a:p>
+            <a:pPr algn="l"/>
+            <a:r>
+              <a:rPr sz="1100" b="1">
+                <a:solidFill>
+                  <a:srgbClr val="5234B7"/>
+                </a:solidFill>
+                <a:latin typeface="DIN Next LT W23"/>
+                <a:ea typeface="DIN Next LT W23"/>
+                <a:cs typeface="DIN Next LT W23"/>
+              </a:rPr>
+              <a:t>ETRA</a:t>
+            </a:r>
+          </a:p>
+        </p:txBody>
+      </p:sp>
+      <p:sp>
+        <p:nvSpPr>
+          <p:cNvPr id="9" name="TextBox 8"/>
+          <p:cNvSpPr txBox="1"/>
+          <p:nvPr/>
+        </p:nvSpPr>
+        <p:spPr>
+          <a:xfrm>
+            <a:off x="9601200" y="6510528"/>
+            <a:ext cx="2011680" cy="256032"/>
+          </a:xfrm>
+          <a:prstGeom prst="rect">
+            <a:avLst/>
+          </a:prstGeom>
+          <a:noFill/>
+        </p:spPr>
+        <p:txBody>
+          <a:bodyPr wrap="square" anchor="t">
+            <a:spAutoFit/>
+          </a:bodyPr>
+          <a:lstStyle/>
+          <a:p>
+            <a:pPr algn="r"/>
+            <a:r>
+              <a:rPr sz="1100" b="0">
+                <a:solidFill>
+                  <a:srgbClr val="5A5470"/>
+                </a:solidFill>
+                <a:latin typeface="DIN Next LT W23"/>
+                <a:ea typeface="DIN Next LT W23"/>
+                <a:cs typeface="DIN Next LT W23"/>
+              </a:rPr>
+              <a:t>33  /  33</a:t>
             </a:r>
           </a:p>
         </p:txBody>
@@ -18081,7 +20026,7 @@
                 <a:ea typeface="DIN Next LT W23"/>
                 <a:cs typeface="DIN Next LT W23"/>
               </a:rPr>
-              <a:t>04  /  29</a:t>
+              <a:t>04  /  33</a:t>
             </a:r>
           </a:p>
         </p:txBody>
@@ -18670,7 +20615,7 @@
                 <a:ea typeface="DIN Next LT W23"/>
                 <a:cs typeface="DIN Next LT W23"/>
               </a:rPr>
-              <a:t>05  /  29</a:t>
+              <a:t>05  /  33</a:t>
             </a:r>
           </a:p>
         </p:txBody>
@@ -19394,7 +21339,7 @@
                 <a:ea typeface="DIN Next LT W23"/>
                 <a:cs typeface="DIN Next LT W23"/>
               </a:rPr>
-              <a:t>06  /  29</a:t>
+              <a:t>06  /  33</a:t>
             </a:r>
           </a:p>
         </p:txBody>
@@ -20034,7 +21979,7 @@
                 <a:ea typeface="DIN Next LT W23"/>
                 <a:cs typeface="DIN Next LT W23"/>
               </a:rPr>
-              <a:t>07  /  29</a:t>
+              <a:t>07  /  33</a:t>
             </a:r>
           </a:p>
         </p:txBody>
@@ -20434,7 +22379,7 @@
                 <a:ea typeface="DIN Next LT W23"/>
                 <a:cs typeface="DIN Next LT W23"/>
               </a:rPr>
-              <a:t>08  /  29</a:t>
+              <a:t>08  /  33</a:t>
             </a:r>
           </a:p>
         </p:txBody>
@@ -20986,7 +22931,7 @@
                 <a:ea typeface="DIN Next LT W23"/>
                 <a:cs typeface="DIN Next LT W23"/>
               </a:rPr>
-              <a:t>09  /  29</a:t>
+              <a:t>09  /  33</a:t>
             </a:r>
           </a:p>
         </p:txBody>

</xml_diff>

<commit_message>
feat: enhance Week 4, Session 1 PowerPoint and scripts by adding new content on long-sequence challenges in transformers and scaling laws, improving educational resources on advanced NLP topics
</commit_message>
<xml_diff>
--- a/web-presentation/pdf-exports/Week4-Session1-GenAI.pptx
+++ b/web-presentation/pdf-exports/Week4-Session1-GenAI.pptx
@@ -38,6 +38,10 @@
     <p:sldId id="286" r:id="rId37"/>
     <p:sldId id="287" r:id="rId38"/>
     <p:sldId id="288" r:id="rId39"/>
+    <p:sldId id="289" r:id="rId40"/>
+    <p:sldId id="290" r:id="rId41"/>
+    <p:sldId id="291" r:id="rId42"/>
+    <p:sldId id="292" r:id="rId43"/>
   </p:sldIdLst>
   <p:sldSz cx="12191695" cy="6858000" type="screen4x3"/>
   <p:notesSz cx="6858000" cy="9144000"/>
@@ -4081,7 +4085,7 @@
                 <a:ea typeface="DIN Next LT W23"/>
                 <a:cs typeface="DIN Next LT W23"/>
               </a:rPr>
-              <a:t>10  /  33</a:t>
+              <a:t>10  /  37</a:t>
             </a:r>
           </a:p>
         </p:txBody>
@@ -4481,7 +4485,7 @@
                 <a:ea typeface="DIN Next LT W23"/>
                 <a:cs typeface="DIN Next LT W23"/>
               </a:rPr>
-              <a:t>11  /  33</a:t>
+              <a:t>11  /  37</a:t>
             </a:r>
           </a:p>
         </p:txBody>
@@ -5070,7 +5074,7 @@
                 <a:ea typeface="DIN Next LT W23"/>
                 <a:cs typeface="DIN Next LT W23"/>
               </a:rPr>
-              <a:t>12  /  33</a:t>
+              <a:t>12  /  37</a:t>
             </a:r>
           </a:p>
         </p:txBody>
@@ -5622,7 +5626,7 @@
                 <a:ea typeface="DIN Next LT W23"/>
                 <a:cs typeface="DIN Next LT W23"/>
               </a:rPr>
-              <a:t>13  /  33</a:t>
+              <a:t>13  /  37</a:t>
             </a:r>
           </a:p>
         </p:txBody>
@@ -6170,7 +6174,7 @@
                 <a:ea typeface="DIN Next LT W23"/>
                 <a:cs typeface="DIN Next LT W23"/>
               </a:rPr>
-              <a:t>14  /  33</a:t>
+              <a:t>14  /  37</a:t>
             </a:r>
           </a:p>
         </p:txBody>
@@ -6759,7 +6763,7 @@
                 <a:ea typeface="DIN Next LT W23"/>
                 <a:cs typeface="DIN Next LT W23"/>
               </a:rPr>
-              <a:t>15  /  33</a:t>
+              <a:t>15  /  37</a:t>
             </a:r>
           </a:p>
         </p:txBody>
@@ -7311,7 +7315,7 @@
                 <a:ea typeface="DIN Next LT W23"/>
                 <a:cs typeface="DIN Next LT W23"/>
               </a:rPr>
-              <a:t>16  /  33</a:t>
+              <a:t>16  /  37</a:t>
             </a:r>
           </a:p>
         </p:txBody>
@@ -7881,7 +7885,7 @@
                 <a:ea typeface="DIN Next LT W23"/>
                 <a:cs typeface="DIN Next LT W23"/>
               </a:rPr>
-              <a:t>17  /  33</a:t>
+              <a:t>17  /  37</a:t>
             </a:r>
           </a:p>
         </p:txBody>
@@ -8281,7 +8285,7 @@
                 <a:ea typeface="DIN Next LT W23"/>
                 <a:cs typeface="DIN Next LT W23"/>
               </a:rPr>
-              <a:t>18  /  33</a:t>
+              <a:t>18  /  37</a:t>
             </a:r>
           </a:p>
         </p:txBody>
@@ -8922,7 +8926,7 @@
                 <a:ea typeface="DIN Next LT W23"/>
                 <a:cs typeface="DIN Next LT W23"/>
               </a:rPr>
-              <a:t>19  /  33</a:t>
+              <a:t>19  /  37</a:t>
             </a:r>
           </a:p>
         </p:txBody>
@@ -10841,7 +10845,7 @@
                 <a:ea typeface="DIN Next LT W23"/>
                 <a:cs typeface="DIN Next LT W23"/>
               </a:rPr>
-              <a:t>02  /  33</a:t>
+              <a:t>02  /  37</a:t>
             </a:r>
           </a:p>
         </p:txBody>
@@ -11241,7 +11245,7 @@
                 <a:ea typeface="DIN Next LT W23"/>
                 <a:cs typeface="DIN Next LT W23"/>
               </a:rPr>
-              <a:t>20  /  33</a:t>
+              <a:t>20  /  37</a:t>
             </a:r>
           </a:p>
         </p:txBody>
@@ -11793,7 +11797,7 @@
                 <a:ea typeface="DIN Next LT W23"/>
                 <a:cs typeface="DIN Next LT W23"/>
               </a:rPr>
-              <a:t>21  /  33</a:t>
+              <a:t>21  /  37</a:t>
             </a:r>
           </a:p>
         </p:txBody>
@@ -12517,7 +12521,7 @@
                 <a:ea typeface="DIN Next LT W23"/>
                 <a:cs typeface="DIN Next LT W23"/>
               </a:rPr>
-              <a:t>22  /  33</a:t>
+              <a:t>22  /  37</a:t>
             </a:r>
           </a:p>
         </p:txBody>
@@ -12917,7 +12921,7 @@
                 <a:ea typeface="DIN Next LT W23"/>
                 <a:cs typeface="DIN Next LT W23"/>
               </a:rPr>
-              <a:t>23  /  33</a:t>
+              <a:t>23  /  37</a:t>
             </a:r>
           </a:p>
         </p:txBody>
@@ -13469,7 +13473,7 @@
                 <a:ea typeface="DIN Next LT W23"/>
                 <a:cs typeface="DIN Next LT W23"/>
               </a:rPr>
-              <a:t>24  /  33</a:t>
+              <a:t>24  /  37</a:t>
             </a:r>
           </a:p>
         </p:txBody>
@@ -14091,7 +14095,7 @@
                 <a:ea typeface="DIN Next LT W23"/>
                 <a:cs typeface="DIN Next LT W23"/>
               </a:rPr>
-              <a:t>25  /  33</a:t>
+              <a:t>25  /  37</a:t>
             </a:r>
           </a:p>
         </p:txBody>
@@ -14744,7 +14748,7 @@
                 <a:ea typeface="DIN Next LT W23"/>
                 <a:cs typeface="DIN Next LT W23"/>
               </a:rPr>
-              <a:t>26  /  33</a:t>
+              <a:t>26  /  37</a:t>
             </a:r>
           </a:p>
         </p:txBody>
@@ -15144,7 +15148,7 @@
                 <a:ea typeface="DIN Next LT W23"/>
                 <a:cs typeface="DIN Next LT W23"/>
               </a:rPr>
-              <a:t>27  /  33</a:t>
+              <a:t>27  /  37</a:t>
             </a:r>
           </a:p>
         </p:txBody>
@@ -15733,7 +15737,7 @@
                 <a:ea typeface="DIN Next LT W23"/>
                 <a:cs typeface="DIN Next LT W23"/>
               </a:rPr>
-              <a:t>28  /  33</a:t>
+              <a:t>28  /  37</a:t>
             </a:r>
           </a:p>
         </p:txBody>
@@ -16133,7 +16137,7 @@
                 <a:ea typeface="DIN Next LT W23"/>
                 <a:cs typeface="DIN Next LT W23"/>
               </a:rPr>
-              <a:t>29  /  33</a:t>
+              <a:t>29  /  37</a:t>
             </a:r>
           </a:p>
         </p:txBody>
@@ -17089,7 +17093,7 @@
                 <a:ea typeface="DIN Next LT W23"/>
                 <a:cs typeface="DIN Next LT W23"/>
               </a:rPr>
-              <a:t>03  /  33</a:t>
+              <a:t>03  /  37</a:t>
             </a:r>
           </a:p>
         </p:txBody>
@@ -17641,7 +17645,7 @@
                 <a:ea typeface="DIN Next LT W23"/>
                 <a:cs typeface="DIN Next LT W23"/>
               </a:rPr>
-              <a:t>30  /  33</a:t>
+              <a:t>30  /  37</a:t>
             </a:r>
           </a:p>
         </p:txBody>
@@ -17829,8 +17833,8 @@
         </p:nvSpPr>
         <p:spPr>
           <a:xfrm>
-            <a:off x="548640" y="1051560"/>
-            <a:ext cx="10241280" cy="594360"/>
+            <a:off x="548640" y="1024128"/>
+            <a:ext cx="10241280" cy="566928"/>
           </a:xfrm>
           <a:prstGeom prst="rect">
             <a:avLst/>
@@ -17853,58 +17857,21 @@
                 <a:ea typeface="DIN Next LT W23"/>
                 <a:cs typeface="DIN Next LT W23"/>
               </a:rPr>
-              <a:t>Scaling &amp; Practice</a:t>
-            </a:r>
-          </a:p>
-        </p:txBody>
-      </p:sp>
-      <p:sp>
-        <p:nvSpPr>
-          <p:cNvPr id="7" name="TextBox 6"/>
-          <p:cNvSpPr txBox="1"/>
-          <p:nvPr/>
-        </p:nvSpPr>
-        <p:spPr>
-          <a:xfrm>
-            <a:off x="548640" y="1600200"/>
-            <a:ext cx="10241280" cy="365760"/>
-          </a:xfrm>
-          <a:prstGeom prst="rect">
-            <a:avLst/>
-          </a:prstGeom>
-          <a:noFill/>
-        </p:spPr>
-        <p:txBody>
-          <a:bodyPr wrap="square" anchor="t">
-            <a:spAutoFit/>
-          </a:bodyPr>
-          <a:lstStyle/>
-          <a:p>
-            <a:pPr algn="l"/>
-            <a:r>
-              <a:rPr sz="1500" b="0">
-                <a:solidFill>
-                  <a:srgbClr val="5A5470"/>
-                </a:solidFill>
-                <a:latin typeface="DIN Next LT W23"/>
-                <a:ea typeface="DIN Next LT W23"/>
-                <a:cs typeface="DIN Next LT W23"/>
-              </a:rPr>
-              <a:t>Topic 7 of 7</a:t>
-            </a:r>
-          </a:p>
-        </p:txBody>
-      </p:sp>
-      <p:sp>
-        <p:nvSpPr>
-          <p:cNvPr id="8" name="Rounded Rectangle 7"/>
+              <a:t>Long-Sequence Challenge in Transformers</a:t>
+            </a:r>
+          </a:p>
+        </p:txBody>
+      </p:sp>
+      <p:sp>
+        <p:nvSpPr>
+          <p:cNvPr id="7" name="Rounded Rectangle 6"/>
           <p:cNvSpPr/>
           <p:nvPr/>
         </p:nvSpPr>
         <p:spPr>
           <a:xfrm>
-            <a:off x="548640" y="2240280"/>
-            <a:ext cx="10972800" cy="3383280"/>
+            <a:off x="548640" y="1737360"/>
+            <a:ext cx="10972800" cy="4617720"/>
           </a:xfrm>
           <a:prstGeom prst="roundRect">
             <a:avLst>
@@ -17941,46 +17908,33 @@
           </a:p>
         </p:txBody>
       </p:sp>
-      <p:sp>
-        <p:nvSpPr>
-          <p:cNvPr id="9" name="TextBox 8"/>
-          <p:cNvSpPr txBox="1"/>
-          <p:nvPr/>
-        </p:nvSpPr>
-        <p:spPr>
-          <a:xfrm>
-            <a:off x="914400" y="3246120"/>
-            <a:ext cx="10241280" cy="502920"/>
-          </a:xfrm>
-          <a:prstGeom prst="rect">
-            <a:avLst/>
-          </a:prstGeom>
-          <a:noFill/>
-        </p:spPr>
-        <p:txBody>
-          <a:bodyPr wrap="square" anchor="t">
-            <a:spAutoFit/>
-          </a:bodyPr>
-          <a:lstStyle/>
-          <a:p>
-            <a:pPr algn="ctr"/>
-            <a:r>
-              <a:rPr sz="2600" b="1">
-                <a:solidFill>
-                  <a:srgbClr val="5234B7"/>
-                </a:solidFill>
-                <a:latin typeface="DIN Next LT W23"/>
-                <a:ea typeface="DIN Next LT W23"/>
-                <a:cs typeface="DIN Next LT W23"/>
-              </a:rPr>
-              <a:t>Scaling &amp; Practice</a:t>
-            </a:r>
-          </a:p>
-        </p:txBody>
-      </p:sp>
-      <p:sp>
-        <p:nvSpPr>
-          <p:cNvPr id="10" name="Rectangle 9"/>
+      <p:pic>
+        <p:nvPicPr>
+          <p:cNvPr id="8" name="Picture 7" descr="transformer-block.png"/>
+          <p:cNvPicPr>
+            <a:picLocks noChangeAspect="1"/>
+          </p:cNvPicPr>
+          <p:nvPr/>
+        </p:nvPicPr>
+        <p:blipFill>
+          <a:blip r:embed="rId3"/>
+          <a:stretch>
+            <a:fillRect/>
+          </a:stretch>
+        </p:blipFill>
+        <p:spPr>
+          <a:xfrm>
+            <a:off x="2668290" y="1847088"/>
+            <a:ext cx="6733498" cy="4398264"/>
+          </a:xfrm>
+          <a:prstGeom prst="rect">
+            <a:avLst/>
+          </a:prstGeom>
+        </p:spPr>
+      </p:pic>
+      <p:sp>
+        <p:nvSpPr>
+          <p:cNvPr id="9" name="Rectangle 8"/>
           <p:cNvSpPr/>
           <p:nvPr/>
         </p:nvSpPr>
@@ -18024,7 +17978,7 @@
       </p:sp>
       <p:sp>
         <p:nvSpPr>
-          <p:cNvPr id="11" name="TextBox 10"/>
+          <p:cNvPr id="10" name="TextBox 9"/>
           <p:cNvSpPr txBox="1"/>
           <p:nvPr/>
         </p:nvSpPr>
@@ -18061,7 +18015,7 @@
       </p:sp>
       <p:sp>
         <p:nvSpPr>
-          <p:cNvPr id="12" name="TextBox 11"/>
+          <p:cNvPr id="11" name="TextBox 10"/>
           <p:cNvSpPr txBox="1"/>
           <p:nvPr/>
         </p:nvSpPr>
@@ -18091,7 +18045,7 @@
                 <a:ea typeface="DIN Next LT W23"/>
                 <a:cs typeface="DIN Next LT W23"/>
               </a:rPr>
-              <a:t>31  /  33</a:t>
+              <a:t>31  /  37</a:t>
             </a:r>
           </a:p>
         </p:txBody>
@@ -18222,7 +18176,7 @@
                 <a:ea typeface="DIN Next LT W23"/>
                 <a:cs typeface="DIN Next LT W23"/>
               </a:rPr>
-              <a:t>S14  ·  Takeaways</a:t>
+              <a:t>S14  ·  GenAI</a:t>
             </a:r>
           </a:p>
         </p:txBody>
@@ -18279,8 +18233,8 @@
         </p:nvSpPr>
         <p:spPr>
           <a:xfrm>
-            <a:off x="548640" y="1051560"/>
-            <a:ext cx="10241280" cy="594360"/>
+            <a:off x="548640" y="1024128"/>
+            <a:ext cx="10241280" cy="566928"/>
           </a:xfrm>
           <a:prstGeom prst="rect">
             <a:avLst/>
@@ -18303,48 +18257,251 @@
                 <a:ea typeface="DIN Next LT W23"/>
                 <a:cs typeface="DIN Next LT W23"/>
               </a:rPr>
-              <a:t>3 Ideas to Keep</a:t>
-            </a:r>
-          </a:p>
-        </p:txBody>
-      </p:sp>
-      <p:sp>
-        <p:nvSpPr>
-          <p:cNvPr id="7" name="TextBox 6"/>
-          <p:cNvSpPr txBox="1"/>
-          <p:nvPr/>
-        </p:nvSpPr>
-        <p:spPr>
-          <a:xfrm>
-            <a:off x="548640" y="1600200"/>
-            <a:ext cx="10241280" cy="365760"/>
-          </a:xfrm>
-          <a:prstGeom prst="rect">
-            <a:avLst/>
-          </a:prstGeom>
-          <a:noFill/>
-        </p:spPr>
-        <p:txBody>
-          <a:bodyPr wrap="square" anchor="t">
-            <a:spAutoFit/>
-          </a:bodyPr>
-          <a:lstStyle/>
-          <a:p>
-            <a:pPr algn="l"/>
-            <a:r>
-              <a:rPr sz="1500" b="0">
-                <a:solidFill>
-                  <a:srgbClr val="5A5470"/>
-                </a:solidFill>
-                <a:latin typeface="DIN Next LT W23"/>
-                <a:ea typeface="DIN Next LT W23"/>
-                <a:cs typeface="DIN Next LT W23"/>
-              </a:rPr>
-              <a:t>Leave with these</a:t>
-            </a:r>
-          </a:p>
-        </p:txBody>
-      </p:sp>
+              <a:t>Long-Sequence Challenge in Transformers</a:t>
+            </a:r>
+          </a:p>
+        </p:txBody>
+      </p:sp>
+      <p:graphicFrame>
+        <p:nvGraphicFramePr>
+          <p:cNvPr id="7" name="Table 6"/>
+          <p:cNvGraphicFramePr>
+            <a:graphicFrameLocks noGrp="1"/>
+          </p:cNvGraphicFramePr>
+          <p:nvPr/>
+        </p:nvGraphicFramePr>
+        <p:xfrm>
+          <a:off x="548640" y="1737360"/>
+          <a:ext cx="10972800" cy="1426464"/>
+        </p:xfrm>
+        <a:graphic>
+          <a:graphicData uri="http://schemas.openxmlformats.org/drawingml/2006/table">
+            <a:tbl>
+              <a:tblPr firstRow="1" bandRow="1">
+                <a:tableStyleId>{5C22544A-7EE6-4342-B048-85BDC9FD1C3A}</a:tableStyleId>
+              </a:tblPr>
+              <a:tblGrid>
+                <a:gridCol w="3657600"/>
+                <a:gridCol w="3657600"/>
+                <a:gridCol w="3657600"/>
+              </a:tblGrid>
+              <a:tr h="475488">
+                <a:tc>
+                  <a:txBody>
+                    <a:bodyPr/>
+                    <a:lstStyle/>
+                    <a:p>
+                      <a:pPr algn="ctr"/>
+                      <a:r>
+                        <a:rPr sz="1200" b="1">
+                          <a:solidFill>
+                            <a:srgbClr val="FFFFFF"/>
+                          </a:solidFill>
+                          <a:latin typeface="Helvetica"/>
+                        </a:rPr>
+                        <a:t>Bottleneck</a:t>
+                      </a:r>
+                    </a:p>
+                  </a:txBody>
+                  <a:tcPr>
+                    <a:solidFill>
+                      <a:srgbClr val="5234B7"/>
+                    </a:solidFill>
+                  </a:tcPr>
+                </a:tc>
+                <a:tc>
+                  <a:txBody>
+                    <a:bodyPr/>
+                    <a:lstStyle/>
+                    <a:p>
+                      <a:pPr algn="ctr"/>
+                      <a:r>
+                        <a:rPr sz="1200" b="1">
+                          <a:solidFill>
+                            <a:srgbClr val="FFFFFF"/>
+                          </a:solidFill>
+                          <a:latin typeface="Helvetica"/>
+                        </a:rPr>
+                        <a:t>Complexity</a:t>
+                      </a:r>
+                    </a:p>
+                  </a:txBody>
+                  <a:tcPr>
+                    <a:solidFill>
+                      <a:srgbClr val="5234B7"/>
+                    </a:solidFill>
+                  </a:tcPr>
+                </a:tc>
+                <a:tc>
+                  <a:txBody>
+                    <a:bodyPr/>
+                    <a:lstStyle/>
+                    <a:p>
+                      <a:pPr algn="ctr"/>
+                      <a:r>
+                        <a:rPr sz="1200" b="1">
+                          <a:solidFill>
+                            <a:srgbClr val="FFFFFF"/>
+                          </a:solidFill>
+                          <a:latin typeface="Helvetica"/>
+                        </a:rPr>
+                        <a:t>Practical Impact</a:t>
+                      </a:r>
+                    </a:p>
+                  </a:txBody>
+                  <a:tcPr>
+                    <a:solidFill>
+                      <a:srgbClr val="5234B7"/>
+                    </a:solidFill>
+                  </a:tcPr>
+                </a:tc>
+              </a:tr>
+              <a:tr h="475488">
+                <a:tc>
+                  <a:txBody>
+                    <a:bodyPr/>
+                    <a:lstStyle/>
+                    <a:p>
+                      <a:pPr algn="l"/>
+                      <a:r>
+                        <a:rPr sz="1300" b="1">
+                          <a:solidFill>
+                            <a:srgbClr val="5234B7"/>
+                          </a:solidFill>
+                          <a:latin typeface="Helvetica"/>
+                        </a:rPr>
+                        <a:t>Attention map computation</a:t>
+                      </a:r>
+                    </a:p>
+                  </a:txBody>
+                  <a:tcPr>
+                    <a:solidFill>
+                      <a:srgbClr val="EEE8FA"/>
+                    </a:solidFill>
+                  </a:tcPr>
+                </a:tc>
+                <a:tc>
+                  <a:txBody>
+                    <a:bodyPr/>
+                    <a:lstStyle/>
+                    <a:p>
+                      <a:pPr algn="l"/>
+                      <a:r>
+                        <a:rPr sz="1300" b="0">
+                          <a:solidFill>
+                            <a:srgbClr val="121018"/>
+                          </a:solidFill>
+                          <a:latin typeface="Helvetica"/>
+                        </a:rPr>
+                        <a:t>O(L²)</a:t>
+                      </a:r>
+                    </a:p>
+                  </a:txBody>
+                  <a:tcPr>
+                    <a:solidFill>
+                      <a:srgbClr val="EEE8FA"/>
+                    </a:solidFill>
+                  </a:tcPr>
+                </a:tc>
+                <a:tc>
+                  <a:txBody>
+                    <a:bodyPr/>
+                    <a:lstStyle/>
+                    <a:p>
+                      <a:pPr algn="l"/>
+                      <a:r>
+                        <a:rPr sz="1300" b="0">
+                          <a:solidFill>
+                            <a:srgbClr val="121018"/>
+                          </a:solidFill>
+                          <a:latin typeface="Helvetica"/>
+                        </a:rPr>
+                        <a:t>Time/memory explode as context grows</a:t>
+                      </a:r>
+                    </a:p>
+                  </a:txBody>
+                  <a:tcPr>
+                    <a:solidFill>
+                      <a:srgbClr val="EEE8FA"/>
+                    </a:solidFill>
+                  </a:tcPr>
+                </a:tc>
+              </a:tr>
+              <a:tr h="475488">
+                <a:tc>
+                  <a:txBody>
+                    <a:bodyPr/>
+                    <a:lstStyle/>
+                    <a:p>
+                      <a:pPr algn="l"/>
+                      <a:r>
+                        <a:rPr sz="1300" b="1">
+                          <a:solidFill>
+                            <a:srgbClr val="5234B7"/>
+                          </a:solidFill>
+                          <a:latin typeface="Helvetica"/>
+                        </a:rPr>
+                        <a:t>Activation storage (training)</a:t>
+                      </a:r>
+                    </a:p>
+                  </a:txBody>
+                  <a:tcPr>
+                    <a:solidFill>
+                      <a:srgbClr val="F5F1FC"/>
+                    </a:solidFill>
+                  </a:tcPr>
+                </a:tc>
+                <a:tc>
+                  <a:txBody>
+                    <a:bodyPr/>
+                    <a:lstStyle/>
+                    <a:p>
+                      <a:pPr algn="l"/>
+                      <a:r>
+                        <a:rPr sz="1300" b="0">
+                          <a:solidFill>
+                            <a:srgbClr val="121018"/>
+                          </a:solidFill>
+                          <a:latin typeface="Helvetica"/>
+                        </a:rPr>
+                        <a:t>O(N*L*d_model)</a:t>
+                      </a:r>
+                    </a:p>
+                  </a:txBody>
+                  <a:tcPr>
+                    <a:solidFill>
+                      <a:srgbClr val="F5F1FC"/>
+                    </a:solidFill>
+                  </a:tcPr>
+                </a:tc>
+                <a:tc>
+                  <a:txBody>
+                    <a:bodyPr/>
+                    <a:lstStyle/>
+                    <a:p>
+                      <a:pPr algn="l"/>
+                      <a:r>
+                        <a:rPr sz="1300" b="0">
+                          <a:solidFill>
+                            <a:srgbClr val="121018"/>
+                          </a:solidFill>
+                          <a:latin typeface="Helvetica"/>
+                        </a:rPr>
+                        <a:t>High VRAM demand for deep long-context models</a:t>
+                      </a:r>
+                    </a:p>
+                  </a:txBody>
+                  <a:tcPr>
+                    <a:solidFill>
+                      <a:srgbClr val="F5F1FC"/>
+                    </a:solidFill>
+                  </a:tcPr>
+                </a:tc>
+              </a:tr>
+            </a:tbl>
+          </a:graphicData>
+        </a:graphic>
+      </p:graphicFrame>
       <p:sp>
         <p:nvSpPr>
           <p:cNvPr id="8" name="Rounded Rectangle 7"/>
@@ -18353,8 +18510,8 @@
         </p:nvSpPr>
         <p:spPr>
           <a:xfrm>
-            <a:off x="548640" y="2148840"/>
-            <a:ext cx="10972800" cy="987552"/>
+            <a:off x="548640" y="3236976"/>
+            <a:ext cx="10972800" cy="411480"/>
           </a:xfrm>
           <a:prstGeom prst="roundRect">
             <a:avLst>
@@ -18399,315 +18556,38 @@
         </p:nvSpPr>
         <p:spPr>
           <a:xfrm>
-            <a:off x="822960" y="2404872"/>
-            <a:ext cx="457200" cy="457200"/>
-          </a:xfrm>
-          <a:prstGeom prst="rect">
-            <a:avLst/>
-          </a:prstGeom>
-          <a:noFill/>
-        </p:spPr>
-        <p:txBody>
-          <a:bodyPr wrap="square" anchor="t">
-            <a:spAutoFit/>
-          </a:bodyPr>
-          <a:lstStyle/>
-          <a:p>
-            <a:pPr algn="l"/>
-            <a:r>
-              <a:rPr sz="2200" b="1">
-                <a:solidFill>
-                  <a:srgbClr val="5234B7"/>
-                </a:solidFill>
-                <a:latin typeface="DIN Next LT W23"/>
-                <a:ea typeface="DIN Next LT W23"/>
-                <a:cs typeface="DIN Next LT W23"/>
-              </a:rPr>
-              <a:t>1</a:t>
-            </a:r>
-          </a:p>
-        </p:txBody>
-      </p:sp>
-      <p:sp>
-        <p:nvSpPr>
-          <p:cNvPr id="10" name="TextBox 9"/>
-          <p:cNvSpPr txBox="1"/>
-          <p:nvPr/>
-        </p:nvSpPr>
-        <p:spPr>
-          <a:xfrm>
-            <a:off x="1417320" y="2404872"/>
-            <a:ext cx="9692640" cy="548640"/>
-          </a:xfrm>
-          <a:prstGeom prst="rect">
-            <a:avLst/>
-          </a:prstGeom>
-          <a:noFill/>
-        </p:spPr>
-        <p:txBody>
-          <a:bodyPr wrap="square" anchor="t">
-            <a:spAutoFit/>
-          </a:bodyPr>
-          <a:lstStyle/>
-          <a:p>
-            <a:pPr algn="l"/>
-            <a:r>
-              <a:rPr sz="1600" b="0">
-                <a:solidFill>
-                  <a:srgbClr val="121018"/>
-                </a:solidFill>
-                <a:latin typeface="DIN Next LT W23"/>
-                <a:ea typeface="DIN Next LT W23"/>
-                <a:cs typeface="DIN Next LT W23"/>
-              </a:rPr>
-              <a:t>Choose architecture by task: encoder-only (BERT), encoder-decoder (T5), or decoder-only (GPT).</a:t>
-            </a:r>
-          </a:p>
-        </p:txBody>
-      </p:sp>
-      <p:sp>
-        <p:nvSpPr>
-          <p:cNvPr id="11" name="Rounded Rectangle 10"/>
-          <p:cNvSpPr/>
-          <p:nvPr/>
-        </p:nvSpPr>
-        <p:spPr>
-          <a:xfrm>
-            <a:off x="548640" y="3291840"/>
-            <a:ext cx="10972800" cy="987552"/>
-          </a:xfrm>
-          <a:prstGeom prst="roundRect">
-            <a:avLst>
-              <a:gd name="adj" fmla="val 10000"/>
-            </a:avLst>
-          </a:prstGeom>
-          <a:solidFill>
-            <a:srgbClr val="EEE8FA"/>
-          </a:solidFill>
-          <a:ln>
-            <a:noFill/>
-          </a:ln>
-          <a:effectLst/>
-        </p:spPr>
-        <p:style>
-          <a:lnRef idx="1">
-            <a:schemeClr val="accent1"/>
-          </a:lnRef>
-          <a:fillRef idx="3">
-            <a:schemeClr val="accent1"/>
-          </a:fillRef>
-          <a:effectRef idx="2">
-            <a:schemeClr val="accent1"/>
-          </a:effectRef>
-          <a:fontRef idx="minor">
-            <a:schemeClr val="lt1"/>
-          </a:fontRef>
-        </p:style>
-        <p:txBody>
-          <a:bodyPr rtlCol="0" anchor="ctr"/>
-          <a:lstStyle/>
-          <a:p>
-            <a:pPr algn="ctr"/>
-          </a:p>
-        </p:txBody>
-      </p:sp>
-      <p:sp>
-        <p:nvSpPr>
-          <p:cNvPr id="12" name="TextBox 11"/>
-          <p:cNvSpPr txBox="1"/>
-          <p:nvPr/>
-        </p:nvSpPr>
-        <p:spPr>
-          <a:xfrm>
-            <a:off x="822960" y="3547872"/>
-            <a:ext cx="457200" cy="457200"/>
-          </a:xfrm>
-          <a:prstGeom prst="rect">
-            <a:avLst/>
-          </a:prstGeom>
-          <a:noFill/>
-        </p:spPr>
-        <p:txBody>
-          <a:bodyPr wrap="square" anchor="t">
-            <a:spAutoFit/>
-          </a:bodyPr>
-          <a:lstStyle/>
-          <a:p>
-            <a:pPr algn="l"/>
-            <a:r>
-              <a:rPr sz="2200" b="1">
-                <a:solidFill>
-                  <a:srgbClr val="5234B7"/>
-                </a:solidFill>
-                <a:latin typeface="DIN Next LT W23"/>
-                <a:ea typeface="DIN Next LT W23"/>
-                <a:cs typeface="DIN Next LT W23"/>
-              </a:rPr>
-              <a:t>2</a:t>
-            </a:r>
-          </a:p>
-        </p:txBody>
-      </p:sp>
-      <p:sp>
-        <p:nvSpPr>
-          <p:cNvPr id="13" name="TextBox 12"/>
-          <p:cNvSpPr txBox="1"/>
-          <p:nvPr/>
-        </p:nvSpPr>
-        <p:spPr>
-          <a:xfrm>
-            <a:off x="1417320" y="3547872"/>
-            <a:ext cx="9692640" cy="548640"/>
-          </a:xfrm>
-          <a:prstGeom prst="rect">
-            <a:avLst/>
-          </a:prstGeom>
-          <a:noFill/>
-        </p:spPr>
-        <p:txBody>
-          <a:bodyPr wrap="square" anchor="t">
-            <a:spAutoFit/>
-          </a:bodyPr>
-          <a:lstStyle/>
-          <a:p>
-            <a:pPr algn="l"/>
-            <a:r>
-              <a:rPr sz="1600" b="0">
-                <a:solidFill>
-                  <a:srgbClr val="121018"/>
-                </a:solidFill>
-                <a:latin typeface="DIN Next LT W23"/>
-                <a:ea typeface="DIN Next LT W23"/>
-                <a:cs typeface="DIN Next LT W23"/>
-              </a:rPr>
-              <a:t>Prefer transfer learning and fine-tuning over training from scratch.</a:t>
-            </a:r>
-          </a:p>
-        </p:txBody>
-      </p:sp>
-      <p:sp>
-        <p:nvSpPr>
-          <p:cNvPr id="14" name="Rounded Rectangle 13"/>
-          <p:cNvSpPr/>
-          <p:nvPr/>
-        </p:nvSpPr>
-        <p:spPr>
-          <a:xfrm>
-            <a:off x="548640" y="4434840"/>
-            <a:ext cx="10972800" cy="987552"/>
-          </a:xfrm>
-          <a:prstGeom prst="roundRect">
-            <a:avLst>
-              <a:gd name="adj" fmla="val 10000"/>
-            </a:avLst>
-          </a:prstGeom>
-          <a:solidFill>
-            <a:srgbClr val="EEE8FA"/>
-          </a:solidFill>
-          <a:ln>
-            <a:noFill/>
-          </a:ln>
-          <a:effectLst/>
-        </p:spPr>
-        <p:style>
-          <a:lnRef idx="1">
-            <a:schemeClr val="accent1"/>
-          </a:lnRef>
-          <a:fillRef idx="3">
-            <a:schemeClr val="accent1"/>
-          </a:fillRef>
-          <a:effectRef idx="2">
-            <a:schemeClr val="accent1"/>
-          </a:effectRef>
-          <a:fontRef idx="minor">
-            <a:schemeClr val="lt1"/>
-          </a:fontRef>
-        </p:style>
-        <p:txBody>
-          <a:bodyPr rtlCol="0" anchor="ctr"/>
-          <a:lstStyle/>
-          <a:p>
-            <a:pPr algn="ctr"/>
-          </a:p>
-        </p:txBody>
-      </p:sp>
-      <p:sp>
-        <p:nvSpPr>
-          <p:cNvPr id="15" name="TextBox 14"/>
-          <p:cNvSpPr txBox="1"/>
-          <p:nvPr/>
-        </p:nvSpPr>
-        <p:spPr>
-          <a:xfrm>
-            <a:off x="822960" y="4690872"/>
-            <a:ext cx="457200" cy="457200"/>
-          </a:xfrm>
-          <a:prstGeom prst="rect">
-            <a:avLst/>
-          </a:prstGeom>
-          <a:noFill/>
-        </p:spPr>
-        <p:txBody>
-          <a:bodyPr wrap="square" anchor="t">
-            <a:spAutoFit/>
-          </a:bodyPr>
-          <a:lstStyle/>
-          <a:p>
-            <a:pPr algn="l"/>
-            <a:r>
-              <a:rPr sz="2200" b="1">
-                <a:solidFill>
-                  <a:srgbClr val="5234B7"/>
-                </a:solidFill>
-                <a:latin typeface="DIN Next LT W23"/>
-                <a:ea typeface="DIN Next LT W23"/>
-                <a:cs typeface="DIN Next LT W23"/>
-              </a:rPr>
-              <a:t>3</a:t>
-            </a:r>
-          </a:p>
-        </p:txBody>
-      </p:sp>
-      <p:sp>
-        <p:nvSpPr>
-          <p:cNvPr id="16" name="TextBox 15"/>
-          <p:cNvSpPr txBox="1"/>
-          <p:nvPr/>
-        </p:nvSpPr>
-        <p:spPr>
-          <a:xfrm>
-            <a:off x="1417320" y="4690872"/>
-            <a:ext cx="9692640" cy="548640"/>
-          </a:xfrm>
-          <a:prstGeom prst="rect">
-            <a:avLst/>
-          </a:prstGeom>
-          <a:noFill/>
-        </p:spPr>
-        <p:txBody>
-          <a:bodyPr wrap="square" anchor="t">
-            <a:spAutoFit/>
-          </a:bodyPr>
-          <a:lstStyle/>
-          <a:p>
-            <a:pPr algn="l"/>
-            <a:r>
-              <a:rPr sz="1600" b="0">
-                <a:solidFill>
-                  <a:srgbClr val="121018"/>
-                </a:solidFill>
-                <a:latin typeface="DIN Next LT W23"/>
-                <a:ea typeface="DIN Next LT W23"/>
-                <a:cs typeface="DIN Next LT W23"/>
-              </a:rPr>
-              <a:t>Attention, decoding strategy, and compute limits shape what you can ship.</a:t>
-            </a:r>
-          </a:p>
-        </p:txBody>
-      </p:sp>
-      <p:sp>
-        <p:nvSpPr>
-          <p:cNvPr id="17" name="Rectangle 16"/>
+            <a:off x="868680" y="3310128"/>
+            <a:ext cx="10332720" cy="292608"/>
+          </a:xfrm>
+          <a:prstGeom prst="rect">
+            <a:avLst/>
+          </a:prstGeom>
+          <a:noFill/>
+        </p:spPr>
+        <p:txBody>
+          <a:bodyPr wrap="square" anchor="t">
+            <a:spAutoFit/>
+          </a:bodyPr>
+          <a:lstStyle/>
+          <a:p>
+            <a:pPr algn="l"/>
+            <a:r>
+              <a:rPr sz="1200" b="0">
+                <a:solidFill>
+                  <a:srgbClr val="5A5470"/>
+                </a:solidFill>
+                <a:latin typeface="DIN Next LT W23"/>
+                <a:ea typeface="DIN Next LT W23"/>
+                <a:cs typeface="DIN Next LT W23"/>
+              </a:rPr>
+              <a:t>Long-context efficiency is now a central LLM engineering topic.</a:t>
+            </a:r>
+          </a:p>
+        </p:txBody>
+      </p:sp>
+      <p:sp>
+        <p:nvSpPr>
+          <p:cNvPr id="10" name="Rectangle 9"/>
           <p:cNvSpPr/>
           <p:nvPr/>
         </p:nvSpPr>
@@ -18751,7 +18631,7 @@
       </p:sp>
       <p:sp>
         <p:nvSpPr>
-          <p:cNvPr id="18" name="TextBox 17"/>
+          <p:cNvPr id="11" name="TextBox 10"/>
           <p:cNvSpPr txBox="1"/>
           <p:nvPr/>
         </p:nvSpPr>
@@ -18788,7 +18668,7 @@
       </p:sp>
       <p:sp>
         <p:nvSpPr>
-          <p:cNvPr id="19" name="TextBox 18"/>
+          <p:cNvPr id="12" name="TextBox 11"/>
           <p:cNvSpPr txBox="1"/>
           <p:nvPr/>
         </p:nvSpPr>
@@ -18818,7 +18698,7 @@
                 <a:ea typeface="DIN Next LT W23"/>
                 <a:cs typeface="DIN Next LT W23"/>
               </a:rPr>
-              <a:t>32  /  33</a:t>
+              <a:t>32  /  37</a:t>
             </a:r>
           </a:p>
         </p:txBody>
@@ -18910,7 +18790,7 @@
         <p:spPr>
           <a:xfrm>
             <a:off x="10561320" y="411480"/>
-            <a:ext cx="1378516" cy="365760"/>
+            <a:ext cx="1206201" cy="320040"/>
           </a:xfrm>
           <a:prstGeom prst="rect">
             <a:avLst/>
@@ -18925,23 +18805,104 @@
         </p:nvSpPr>
         <p:spPr>
           <a:xfrm>
-            <a:off x="548640" y="2651760"/>
-            <a:ext cx="10972800" cy="731520"/>
-          </a:xfrm>
-          <a:prstGeom prst="rect">
-            <a:avLst/>
-          </a:prstGeom>
-          <a:noFill/>
-        </p:spPr>
-        <p:txBody>
-          <a:bodyPr wrap="square" anchor="t">
-            <a:spAutoFit/>
-          </a:bodyPr>
+            <a:off x="548640" y="438912"/>
+            <a:ext cx="7772400" cy="274320"/>
+          </a:xfrm>
+          <a:prstGeom prst="rect">
+            <a:avLst/>
+          </a:prstGeom>
+          <a:noFill/>
+        </p:spPr>
+        <p:txBody>
+          <a:bodyPr wrap="square" anchor="t">
+            <a:spAutoFit/>
+          </a:bodyPr>
+          <a:lstStyle/>
+          <a:p>
+            <a:pPr algn="l"/>
+            <a:r>
+              <a:rPr sz="1200" b="0">
+                <a:solidFill>
+                  <a:srgbClr val="5A5470"/>
+                </a:solidFill>
+                <a:latin typeface="DIN Next LT W23"/>
+                <a:ea typeface="DIN Next LT W23"/>
+                <a:cs typeface="DIN Next LT W23"/>
+              </a:rPr>
+              <a:t>S14  ·  GenAI</a:t>
+            </a:r>
+          </a:p>
+        </p:txBody>
+      </p:sp>
+      <p:sp>
+        <p:nvSpPr>
+          <p:cNvPr id="5" name="Rectangle 4"/>
+          <p:cNvSpPr/>
+          <p:nvPr/>
+        </p:nvSpPr>
+        <p:spPr>
+          <a:xfrm>
+            <a:off x="548640" y="822960"/>
+            <a:ext cx="11064240" cy="10972"/>
+          </a:xfrm>
+          <a:prstGeom prst="rect">
+            <a:avLst/>
+          </a:prstGeom>
+          <a:solidFill>
+            <a:srgbClr val="E4DCF4"/>
+          </a:solidFill>
+          <a:ln>
+            <a:noFill/>
+          </a:ln>
+          <a:effectLst/>
+        </p:spPr>
+        <p:style>
+          <a:lnRef idx="1">
+            <a:schemeClr val="accent1"/>
+          </a:lnRef>
+          <a:fillRef idx="3">
+            <a:schemeClr val="accent1"/>
+          </a:fillRef>
+          <a:effectRef idx="2">
+            <a:schemeClr val="accent1"/>
+          </a:effectRef>
+          <a:fontRef idx="minor">
+            <a:schemeClr val="lt1"/>
+          </a:fontRef>
+        </p:style>
+        <p:txBody>
+          <a:bodyPr rtlCol="0" anchor="ctr"/>
           <a:lstStyle/>
           <a:p>
             <a:pPr algn="ctr"/>
-            <a:r>
-              <a:rPr sz="4000" b="1">
+          </a:p>
+        </p:txBody>
+      </p:sp>
+      <p:sp>
+        <p:nvSpPr>
+          <p:cNvPr id="6" name="TextBox 5"/>
+          <p:cNvSpPr txBox="1"/>
+          <p:nvPr/>
+        </p:nvSpPr>
+        <p:spPr>
+          <a:xfrm>
+            <a:off x="548640" y="1024128"/>
+            <a:ext cx="10241280" cy="566928"/>
+          </a:xfrm>
+          <a:prstGeom prst="rect">
+            <a:avLst/>
+          </a:prstGeom>
+          <a:noFill/>
+        </p:spPr>
+        <p:txBody>
+          <a:bodyPr wrap="square" anchor="t">
+            <a:spAutoFit/>
+          </a:bodyPr>
+          <a:lstStyle/>
+          <a:p>
+            <a:pPr algn="l"/>
+            <a:r>
+              <a:rPr sz="3200" b="1">
                 <a:solidFill>
                   <a:srgbClr val="5234B7"/>
                 </a:solidFill>
@@ -18949,88 +18910,236 @@
                 <a:ea typeface="DIN Next LT W23"/>
                 <a:cs typeface="DIN Next LT W23"/>
               </a:rPr>
-              <a:t>Thank you</a:t>
-            </a:r>
-          </a:p>
-        </p:txBody>
-      </p:sp>
-      <p:sp>
-        <p:nvSpPr>
-          <p:cNvPr id="5" name="TextBox 4"/>
-          <p:cNvSpPr txBox="1"/>
-          <p:nvPr/>
-        </p:nvSpPr>
-        <p:spPr>
-          <a:xfrm>
-            <a:off x="548640" y="3474720"/>
-            <a:ext cx="10972800" cy="365760"/>
-          </a:xfrm>
-          <a:prstGeom prst="rect">
-            <a:avLst/>
-          </a:prstGeom>
-          <a:noFill/>
-        </p:spPr>
-        <p:txBody>
-          <a:bodyPr wrap="square" anchor="t">
-            <a:spAutoFit/>
-          </a:bodyPr>
-          <a:lstStyle/>
-          <a:p>
-            <a:pPr algn="ctr"/>
-            <a:r>
-              <a:rPr sz="1600" b="0">
-                <a:solidFill>
-                  <a:srgbClr val="5A5470"/>
-                </a:solidFill>
-                <a:latin typeface="DIN Next LT W23"/>
-                <a:ea typeface="DIN Next LT W23"/>
-                <a:cs typeface="DIN Next LT W23"/>
-              </a:rPr>
-              <a:t>Labs: code/17- GenAI</a:t>
-            </a:r>
-          </a:p>
-        </p:txBody>
-      </p:sp>
-      <p:sp>
-        <p:nvSpPr>
-          <p:cNvPr id="6" name="TextBox 5"/>
-          <p:cNvSpPr txBox="1"/>
-          <p:nvPr/>
-        </p:nvSpPr>
-        <p:spPr>
-          <a:xfrm>
-            <a:off x="548640" y="6126480"/>
-            <a:ext cx="5486400" cy="274320"/>
-          </a:xfrm>
-          <a:prstGeom prst="rect">
-            <a:avLst/>
-          </a:prstGeom>
-          <a:noFill/>
-        </p:spPr>
-        <p:txBody>
-          <a:bodyPr wrap="square" anchor="t">
-            <a:spAutoFit/>
-          </a:bodyPr>
-          <a:lstStyle/>
-          <a:p>
-            <a:pPr algn="l"/>
-            <a:r>
-              <a:rPr sz="1200" b="1">
-                <a:solidFill>
-                  <a:srgbClr val="5234B7"/>
-                </a:solidFill>
-                <a:latin typeface="DIN Next LT W23"/>
-                <a:ea typeface="DIN Next LT W23"/>
-                <a:cs typeface="DIN Next LT W23"/>
-              </a:rPr>
-              <a:t>ETRA</a:t>
-            </a:r>
-          </a:p>
-        </p:txBody>
-      </p:sp>
-      <p:sp>
-        <p:nvSpPr>
-          <p:cNvPr id="7" name="Rectangle 6"/>
+              <a:t>Scaling Laws and Compute-Optimal Training</a:t>
+            </a:r>
+          </a:p>
+        </p:txBody>
+      </p:sp>
+      <p:sp>
+        <p:nvSpPr>
+          <p:cNvPr id="7" name="TextBox 6"/>
+          <p:cNvSpPr txBox="1"/>
+          <p:nvPr/>
+        </p:nvSpPr>
+        <p:spPr>
+          <a:xfrm>
+            <a:off x="548640" y="1737360"/>
+            <a:ext cx="320040" cy="605790"/>
+          </a:xfrm>
+          <a:prstGeom prst="rect">
+            <a:avLst/>
+          </a:prstGeom>
+          <a:noFill/>
+        </p:spPr>
+        <p:txBody>
+          <a:bodyPr wrap="square" anchor="t">
+            <a:spAutoFit/>
+          </a:bodyPr>
+          <a:lstStyle/>
+          <a:p>
+            <a:pPr algn="l"/>
+            <a:r>
+              <a:rPr sz="1500" b="0">
+                <a:solidFill>
+                  <a:srgbClr val="9E59CD"/>
+                </a:solidFill>
+                <a:latin typeface="DIN Next LT W23"/>
+                <a:ea typeface="DIN Next LT W23"/>
+                <a:cs typeface="DIN Next LT W23"/>
+              </a:rPr>
+              <a:t>–</a:t>
+            </a:r>
+          </a:p>
+        </p:txBody>
+      </p:sp>
+      <p:sp>
+        <p:nvSpPr>
+          <p:cNvPr id="8" name="TextBox 7"/>
+          <p:cNvSpPr txBox="1"/>
+          <p:nvPr/>
+        </p:nvSpPr>
+        <p:spPr>
+          <a:xfrm>
+            <a:off x="914400" y="1737360"/>
+            <a:ext cx="9875519" cy="605790"/>
+          </a:xfrm>
+          <a:prstGeom prst="rect">
+            <a:avLst/>
+          </a:prstGeom>
+          <a:noFill/>
+        </p:spPr>
+        <p:txBody>
+          <a:bodyPr wrap="square" anchor="t">
+            <a:spAutoFit/>
+          </a:bodyPr>
+          <a:lstStyle/>
+          <a:p>
+            <a:pPr algn="l"/>
+            <a:r>
+              <a:rPr sz="1500" b="0">
+                <a:solidFill>
+                  <a:srgbClr val="121018"/>
+                </a:solidFill>
+                <a:latin typeface="DIN Next LT W23"/>
+                <a:ea typeface="DIN Next LT W23"/>
+                <a:cs typeface="DIN Next LT W23"/>
+              </a:rPr>
+              <a:t>Performance improves with data, model size, and compute, but with diminishing returns.</a:t>
+            </a:r>
+          </a:p>
+        </p:txBody>
+      </p:sp>
+      <p:sp>
+        <p:nvSpPr>
+          <p:cNvPr id="9" name="TextBox 8"/>
+          <p:cNvSpPr txBox="1"/>
+          <p:nvPr/>
+        </p:nvSpPr>
+        <p:spPr>
+          <a:xfrm>
+            <a:off x="548640" y="2434590"/>
+            <a:ext cx="320040" cy="605790"/>
+          </a:xfrm>
+          <a:prstGeom prst="rect">
+            <a:avLst/>
+          </a:prstGeom>
+          <a:noFill/>
+        </p:spPr>
+        <p:txBody>
+          <a:bodyPr wrap="square" anchor="t">
+            <a:spAutoFit/>
+          </a:bodyPr>
+          <a:lstStyle/>
+          <a:p>
+            <a:pPr algn="l"/>
+            <a:r>
+              <a:rPr sz="1500" b="0">
+                <a:solidFill>
+                  <a:srgbClr val="9E59CD"/>
+                </a:solidFill>
+                <a:latin typeface="DIN Next LT W23"/>
+                <a:ea typeface="DIN Next LT W23"/>
+                <a:cs typeface="DIN Next LT W23"/>
+              </a:rPr>
+              <a:t>–</a:t>
+            </a:r>
+          </a:p>
+        </p:txBody>
+      </p:sp>
+      <p:sp>
+        <p:nvSpPr>
+          <p:cNvPr id="10" name="TextBox 9"/>
+          <p:cNvSpPr txBox="1"/>
+          <p:nvPr/>
+        </p:nvSpPr>
+        <p:spPr>
+          <a:xfrm>
+            <a:off x="914400" y="2434590"/>
+            <a:ext cx="9875519" cy="605790"/>
+          </a:xfrm>
+          <a:prstGeom prst="rect">
+            <a:avLst/>
+          </a:prstGeom>
+          <a:noFill/>
+        </p:spPr>
+        <p:txBody>
+          <a:bodyPr wrap="square" anchor="t">
+            <a:spAutoFit/>
+          </a:bodyPr>
+          <a:lstStyle/>
+          <a:p>
+            <a:pPr algn="l"/>
+            <a:r>
+              <a:rPr sz="1500" b="0">
+                <a:solidFill>
+                  <a:srgbClr val="121018"/>
+                </a:solidFill>
+                <a:latin typeface="DIN Next LT W23"/>
+                <a:ea typeface="DIN Next LT W23"/>
+                <a:cs typeface="DIN Next LT W23"/>
+              </a:rPr>
+              <a:t>Compute-optimal training balances parameter count and token budget.</a:t>
+            </a:r>
+          </a:p>
+        </p:txBody>
+      </p:sp>
+      <p:sp>
+        <p:nvSpPr>
+          <p:cNvPr id="11" name="TextBox 10"/>
+          <p:cNvSpPr txBox="1"/>
+          <p:nvPr/>
+        </p:nvSpPr>
+        <p:spPr>
+          <a:xfrm>
+            <a:off x="548640" y="3131820"/>
+            <a:ext cx="320040" cy="605790"/>
+          </a:xfrm>
+          <a:prstGeom prst="rect">
+            <a:avLst/>
+          </a:prstGeom>
+          <a:noFill/>
+        </p:spPr>
+        <p:txBody>
+          <a:bodyPr wrap="square" anchor="t">
+            <a:spAutoFit/>
+          </a:bodyPr>
+          <a:lstStyle/>
+          <a:p>
+            <a:pPr algn="l"/>
+            <a:r>
+              <a:rPr sz="1500" b="0">
+                <a:solidFill>
+                  <a:srgbClr val="9E59CD"/>
+                </a:solidFill>
+                <a:latin typeface="DIN Next LT W23"/>
+                <a:ea typeface="DIN Next LT W23"/>
+                <a:cs typeface="DIN Next LT W23"/>
+              </a:rPr>
+              <a:t>–</a:t>
+            </a:r>
+          </a:p>
+        </p:txBody>
+      </p:sp>
+      <p:sp>
+        <p:nvSpPr>
+          <p:cNvPr id="12" name="TextBox 11"/>
+          <p:cNvSpPr txBox="1"/>
+          <p:nvPr/>
+        </p:nvSpPr>
+        <p:spPr>
+          <a:xfrm>
+            <a:off x="914400" y="3131820"/>
+            <a:ext cx="9875519" cy="605790"/>
+          </a:xfrm>
+          <a:prstGeom prst="rect">
+            <a:avLst/>
+          </a:prstGeom>
+          <a:noFill/>
+        </p:spPr>
+        <p:txBody>
+          <a:bodyPr wrap="square" anchor="t">
+            <a:spAutoFit/>
+          </a:bodyPr>
+          <a:lstStyle/>
+          <a:p>
+            <a:pPr algn="l"/>
+            <a:r>
+              <a:rPr sz="1500" b="0">
+                <a:solidFill>
+                  <a:srgbClr val="121018"/>
+                </a:solidFill>
+                <a:latin typeface="DIN Next LT W23"/>
+                <a:ea typeface="DIN Next LT W23"/>
+                <a:cs typeface="DIN Next LT W23"/>
+              </a:rPr>
+              <a:t>Chinchilla-style insight: many large models are under-trained relative to their size.</a:t>
+            </a:r>
+          </a:p>
+        </p:txBody>
+      </p:sp>
+      <p:sp>
+        <p:nvSpPr>
+          <p:cNvPr id="13" name="Rectangle 12"/>
           <p:cNvSpPr/>
           <p:nvPr/>
         </p:nvSpPr>
@@ -19074,7 +19183,7 @@
       </p:sp>
       <p:sp>
         <p:nvSpPr>
-          <p:cNvPr id="8" name="TextBox 7"/>
+          <p:cNvPr id="14" name="TextBox 13"/>
           <p:cNvSpPr txBox="1"/>
           <p:nvPr/>
         </p:nvSpPr>
@@ -19111,7 +19220,7 @@
       </p:sp>
       <p:sp>
         <p:nvSpPr>
-          <p:cNvPr id="9" name="TextBox 8"/>
+          <p:cNvPr id="15" name="TextBox 14"/>
           <p:cNvSpPr txBox="1"/>
           <p:nvPr/>
         </p:nvSpPr>
@@ -19141,7 +19250,2342 @@
                 <a:ea typeface="DIN Next LT W23"/>
                 <a:cs typeface="DIN Next LT W23"/>
               </a:rPr>
-              <a:t>33  /  33</a:t>
+              <a:t>33  /  37</a:t>
+            </a:r>
+          </a:p>
+        </p:txBody>
+      </p:sp>
+    </p:spTree>
+  </p:cSld>
+  <p:clrMapOvr>
+    <a:masterClrMapping/>
+  </p:clrMapOvr>
+</p:sld>
+</file>
+
+<file path=ppt/slides/slide34.xml><?xml version="1.0" encoding="utf-8"?>
+<p:sld xmlns:a="http://schemas.openxmlformats.org/drawingml/2006/main" xmlns:p="http://schemas.openxmlformats.org/presentationml/2006/main" xmlns:r="http://schemas.openxmlformats.org/officeDocument/2006/relationships">
+  <p:cSld>
+    <p:bg>
+      <p:bgPr>
+        <a:solidFill>
+          <a:srgbClr val="FAF8FF"/>
+        </a:solidFill>
+        <a:effectLst/>
+      </p:bgPr>
+    </p:bg>
+    <p:spTree>
+      <p:nvGrpSpPr>
+        <p:cNvPr id="1" name=""/>
+        <p:cNvGrpSpPr/>
+        <p:nvPr/>
+      </p:nvGrpSpPr>
+      <p:grpSpPr/>
+      <p:sp>
+        <p:nvSpPr>
+          <p:cNvPr id="2" name="Rectangle 1"/>
+          <p:cNvSpPr/>
+          <p:nvPr/>
+        </p:nvSpPr>
+        <p:spPr>
+          <a:xfrm>
+            <a:off x="12136831" y="0"/>
+            <a:ext cx="54864" cy="6858000"/>
+          </a:xfrm>
+          <a:prstGeom prst="rect">
+            <a:avLst/>
+          </a:prstGeom>
+          <a:solidFill>
+            <a:srgbClr val="5234B7"/>
+          </a:solidFill>
+          <a:ln>
+            <a:noFill/>
+          </a:ln>
+          <a:effectLst/>
+        </p:spPr>
+        <p:style>
+          <a:lnRef idx="1">
+            <a:schemeClr val="accent1"/>
+          </a:lnRef>
+          <a:fillRef idx="3">
+            <a:schemeClr val="accent1"/>
+          </a:fillRef>
+          <a:effectRef idx="2">
+            <a:schemeClr val="accent1"/>
+          </a:effectRef>
+          <a:fontRef idx="minor">
+            <a:schemeClr val="lt1"/>
+          </a:fontRef>
+        </p:style>
+        <p:txBody>
+          <a:bodyPr rtlCol="0" anchor="ctr"/>
+          <a:lstStyle/>
+          <a:p>
+            <a:pPr algn="ctr"/>
+          </a:p>
+        </p:txBody>
+      </p:sp>
+      <p:pic>
+        <p:nvPicPr>
+          <p:cNvPr id="3" name="Picture 2" descr="etra-wordmark.png"/>
+          <p:cNvPicPr>
+            <a:picLocks noChangeAspect="1"/>
+          </p:cNvPicPr>
+          <p:nvPr/>
+        </p:nvPicPr>
+        <p:blipFill>
+          <a:blip r:embed="rId2"/>
+          <a:stretch>
+            <a:fillRect/>
+          </a:stretch>
+        </p:blipFill>
+        <p:spPr>
+          <a:xfrm>
+            <a:off x="10561320" y="411480"/>
+            <a:ext cx="1206201" cy="320040"/>
+          </a:xfrm>
+          <a:prstGeom prst="rect">
+            <a:avLst/>
+          </a:prstGeom>
+        </p:spPr>
+      </p:pic>
+      <p:sp>
+        <p:nvSpPr>
+          <p:cNvPr id="4" name="TextBox 3"/>
+          <p:cNvSpPr txBox="1"/>
+          <p:nvPr/>
+        </p:nvSpPr>
+        <p:spPr>
+          <a:xfrm>
+            <a:off x="548640" y="438912"/>
+            <a:ext cx="7772400" cy="274320"/>
+          </a:xfrm>
+          <a:prstGeom prst="rect">
+            <a:avLst/>
+          </a:prstGeom>
+          <a:noFill/>
+        </p:spPr>
+        <p:txBody>
+          <a:bodyPr wrap="square" anchor="t">
+            <a:spAutoFit/>
+          </a:bodyPr>
+          <a:lstStyle/>
+          <a:p>
+            <a:pPr algn="l"/>
+            <a:r>
+              <a:rPr sz="1200" b="0">
+                <a:solidFill>
+                  <a:srgbClr val="5A5470"/>
+                </a:solidFill>
+                <a:latin typeface="DIN Next LT W23"/>
+                <a:ea typeface="DIN Next LT W23"/>
+                <a:cs typeface="DIN Next LT W23"/>
+              </a:rPr>
+              <a:t>S14  ·  GenAI</a:t>
+            </a:r>
+          </a:p>
+        </p:txBody>
+      </p:sp>
+      <p:sp>
+        <p:nvSpPr>
+          <p:cNvPr id="5" name="Rectangle 4"/>
+          <p:cNvSpPr/>
+          <p:nvPr/>
+        </p:nvSpPr>
+        <p:spPr>
+          <a:xfrm>
+            <a:off x="548640" y="822960"/>
+            <a:ext cx="11064240" cy="10972"/>
+          </a:xfrm>
+          <a:prstGeom prst="rect">
+            <a:avLst/>
+          </a:prstGeom>
+          <a:solidFill>
+            <a:srgbClr val="E4DCF4"/>
+          </a:solidFill>
+          <a:ln>
+            <a:noFill/>
+          </a:ln>
+          <a:effectLst/>
+        </p:spPr>
+        <p:style>
+          <a:lnRef idx="1">
+            <a:schemeClr val="accent1"/>
+          </a:lnRef>
+          <a:fillRef idx="3">
+            <a:schemeClr val="accent1"/>
+          </a:fillRef>
+          <a:effectRef idx="2">
+            <a:schemeClr val="accent1"/>
+          </a:effectRef>
+          <a:fontRef idx="minor">
+            <a:schemeClr val="lt1"/>
+          </a:fontRef>
+        </p:style>
+        <p:txBody>
+          <a:bodyPr rtlCol="0" anchor="ctr"/>
+          <a:lstStyle/>
+          <a:p>
+            <a:pPr algn="ctr"/>
+          </a:p>
+        </p:txBody>
+      </p:sp>
+      <p:sp>
+        <p:nvSpPr>
+          <p:cNvPr id="6" name="TextBox 5"/>
+          <p:cNvSpPr txBox="1"/>
+          <p:nvPr/>
+        </p:nvSpPr>
+        <p:spPr>
+          <a:xfrm>
+            <a:off x="548640" y="1024128"/>
+            <a:ext cx="10241280" cy="566928"/>
+          </a:xfrm>
+          <a:prstGeom prst="rect">
+            <a:avLst/>
+          </a:prstGeom>
+          <a:noFill/>
+        </p:spPr>
+        <p:txBody>
+          <a:bodyPr wrap="square" anchor="t">
+            <a:spAutoFit/>
+          </a:bodyPr>
+          <a:lstStyle/>
+          <a:p>
+            <a:pPr algn="l"/>
+            <a:r>
+              <a:rPr sz="3200" b="1">
+                <a:solidFill>
+                  <a:srgbClr val="5234B7"/>
+                </a:solidFill>
+                <a:latin typeface="DIN Next LT W23"/>
+                <a:ea typeface="DIN Next LT W23"/>
+                <a:cs typeface="DIN Next LT W23"/>
+              </a:rPr>
+              <a:t>Scaling Laws and Compute-Optimal Training</a:t>
+            </a:r>
+          </a:p>
+        </p:txBody>
+      </p:sp>
+      <p:graphicFrame>
+        <p:nvGraphicFramePr>
+          <p:cNvPr id="7" name="Table 6"/>
+          <p:cNvGraphicFramePr>
+            <a:graphicFrameLocks noGrp="1"/>
+          </p:cNvGraphicFramePr>
+          <p:nvPr/>
+        </p:nvGraphicFramePr>
+        <p:xfrm>
+          <a:off x="548640" y="1737360"/>
+          <a:ext cx="10972800" cy="1901952"/>
+        </p:xfrm>
+        <a:graphic>
+          <a:graphicData uri="http://schemas.openxmlformats.org/drawingml/2006/table">
+            <a:tbl>
+              <a:tblPr firstRow="1" bandRow="1">
+                <a:tableStyleId>{5C22544A-7EE6-4342-B048-85BDC9FD1C3A}</a:tableStyleId>
+              </a:tblPr>
+              <a:tblGrid>
+                <a:gridCol w="5486400"/>
+                <a:gridCol w="5486400"/>
+              </a:tblGrid>
+              <a:tr h="475488">
+                <a:tc>
+                  <a:txBody>
+                    <a:bodyPr/>
+                    <a:lstStyle/>
+                    <a:p>
+                      <a:pPr algn="ctr"/>
+                      <a:r>
+                        <a:rPr sz="1200" b="1">
+                          <a:solidFill>
+                            <a:srgbClr val="FFFFFF"/>
+                          </a:solidFill>
+                          <a:latin typeface="Helvetica"/>
+                        </a:rPr>
+                        <a:t>Principle</a:t>
+                      </a:r>
+                    </a:p>
+                  </a:txBody>
+                  <a:tcPr>
+                    <a:solidFill>
+                      <a:srgbClr val="5234B7"/>
+                    </a:solidFill>
+                  </a:tcPr>
+                </a:tc>
+                <a:tc>
+                  <a:txBody>
+                    <a:bodyPr/>
+                    <a:lstStyle/>
+                    <a:p>
+                      <a:pPr algn="ctr"/>
+                      <a:r>
+                        <a:rPr sz="1200" b="1">
+                          <a:solidFill>
+                            <a:srgbClr val="FFFFFF"/>
+                          </a:solidFill>
+                          <a:latin typeface="Helvetica"/>
+                        </a:rPr>
+                        <a:t>Implication</a:t>
+                      </a:r>
+                    </a:p>
+                  </a:txBody>
+                  <a:tcPr>
+                    <a:solidFill>
+                      <a:srgbClr val="5234B7"/>
+                    </a:solidFill>
+                  </a:tcPr>
+                </a:tc>
+              </a:tr>
+              <a:tr h="475488">
+                <a:tc>
+                  <a:txBody>
+                    <a:bodyPr/>
+                    <a:lstStyle/>
+                    <a:p>
+                      <a:pPr algn="l"/>
+                      <a:r>
+                        <a:rPr sz="1300" b="1">
+                          <a:solidFill>
+                            <a:srgbClr val="5234B7"/>
+                          </a:solidFill>
+                          <a:latin typeface="Helvetica"/>
+                        </a:rPr>
+                        <a:t>Fixed compute budget</a:t>
+                      </a:r>
+                    </a:p>
+                  </a:txBody>
+                  <a:tcPr>
+                    <a:solidFill>
+                      <a:srgbClr val="EEE8FA"/>
+                    </a:solidFill>
+                  </a:tcPr>
+                </a:tc>
+                <a:tc>
+                  <a:txBody>
+                    <a:bodyPr/>
+                    <a:lstStyle/>
+                    <a:p>
+                      <a:pPr algn="l"/>
+                      <a:r>
+                        <a:rPr sz="1300" b="0">
+                          <a:solidFill>
+                            <a:srgbClr val="121018"/>
+                          </a:solidFill>
+                          <a:latin typeface="Helvetica"/>
+                        </a:rPr>
+                        <a:t>Tune model size and data volume jointly</a:t>
+                      </a:r>
+                    </a:p>
+                  </a:txBody>
+                  <a:tcPr>
+                    <a:solidFill>
+                      <a:srgbClr val="EEE8FA"/>
+                    </a:solidFill>
+                  </a:tcPr>
+                </a:tc>
+              </a:tr>
+              <a:tr h="475488">
+                <a:tc>
+                  <a:txBody>
+                    <a:bodyPr/>
+                    <a:lstStyle/>
+                    <a:p>
+                      <a:pPr algn="l"/>
+                      <a:r>
+                        <a:rPr sz="1300" b="1">
+                          <a:solidFill>
+                            <a:srgbClr val="5234B7"/>
+                          </a:solidFill>
+                          <a:latin typeface="Helvetica"/>
+                        </a:rPr>
+                        <a:t>Data-quality filtering</a:t>
+                      </a:r>
+                    </a:p>
+                  </a:txBody>
+                  <a:tcPr>
+                    <a:solidFill>
+                      <a:srgbClr val="F5F1FC"/>
+                    </a:solidFill>
+                  </a:tcPr>
+                </a:tc>
+                <a:tc>
+                  <a:txBody>
+                    <a:bodyPr/>
+                    <a:lstStyle/>
+                    <a:p>
+                      <a:pPr algn="l"/>
+                      <a:r>
+                        <a:rPr sz="1300" b="0">
+                          <a:solidFill>
+                            <a:srgbClr val="121018"/>
+                          </a:solidFill>
+                          <a:latin typeface="Helvetica"/>
+                        </a:rPr>
+                        <a:t>Small fraction of tokens may dominate useful learning</a:t>
+                      </a:r>
+                    </a:p>
+                  </a:txBody>
+                  <a:tcPr>
+                    <a:solidFill>
+                      <a:srgbClr val="F5F1FC"/>
+                    </a:solidFill>
+                  </a:tcPr>
+                </a:tc>
+              </a:tr>
+              <a:tr h="475488">
+                <a:tc>
+                  <a:txBody>
+                    <a:bodyPr/>
+                    <a:lstStyle/>
+                    <a:p>
+                      <a:pPr algn="l"/>
+                      <a:r>
+                        <a:rPr sz="1300" b="1">
+                          <a:solidFill>
+                            <a:srgbClr val="5234B7"/>
+                          </a:solidFill>
+                          <a:latin typeface="Helvetica"/>
+                        </a:rPr>
+                        <a:t>Chinchilla ratio (rule of thumb)</a:t>
+                      </a:r>
+                    </a:p>
+                  </a:txBody>
+                  <a:tcPr>
+                    <a:solidFill>
+                      <a:srgbClr val="EEE8FA"/>
+                    </a:solidFill>
+                  </a:tcPr>
+                </a:tc>
+                <a:tc>
+                  <a:txBody>
+                    <a:bodyPr/>
+                    <a:lstStyle/>
+                    <a:p>
+                      <a:pPr algn="l"/>
+                      <a:r>
+                        <a:rPr sz="1300" b="0">
+                          <a:solidFill>
+                            <a:srgbClr val="121018"/>
+                          </a:solidFill>
+                          <a:latin typeface="Helvetica"/>
+                        </a:rPr>
+                        <a:t>Roughly ~20 training tokens per parameter</a:t>
+                      </a:r>
+                    </a:p>
+                  </a:txBody>
+                  <a:tcPr>
+                    <a:solidFill>
+                      <a:srgbClr val="EEE8FA"/>
+                    </a:solidFill>
+                  </a:tcPr>
+                </a:tc>
+              </a:tr>
+            </a:tbl>
+          </a:graphicData>
+        </a:graphic>
+      </p:graphicFrame>
+      <p:sp>
+        <p:nvSpPr>
+          <p:cNvPr id="8" name="Rectangle 7"/>
+          <p:cNvSpPr/>
+          <p:nvPr/>
+        </p:nvSpPr>
+        <p:spPr>
+          <a:xfrm>
+            <a:off x="548640" y="6446520"/>
+            <a:ext cx="11064240" cy="10972"/>
+          </a:xfrm>
+          <a:prstGeom prst="rect">
+            <a:avLst/>
+          </a:prstGeom>
+          <a:solidFill>
+            <a:srgbClr val="5234B7"/>
+          </a:solidFill>
+          <a:ln>
+            <a:noFill/>
+          </a:ln>
+          <a:effectLst/>
+        </p:spPr>
+        <p:style>
+          <a:lnRef idx="1">
+            <a:schemeClr val="accent1"/>
+          </a:lnRef>
+          <a:fillRef idx="3">
+            <a:schemeClr val="accent1"/>
+          </a:fillRef>
+          <a:effectRef idx="2">
+            <a:schemeClr val="accent1"/>
+          </a:effectRef>
+          <a:fontRef idx="minor">
+            <a:schemeClr val="lt1"/>
+          </a:fontRef>
+        </p:style>
+        <p:txBody>
+          <a:bodyPr rtlCol="0" anchor="ctr"/>
+          <a:lstStyle/>
+          <a:p>
+            <a:pPr algn="ctr"/>
+          </a:p>
+        </p:txBody>
+      </p:sp>
+      <p:sp>
+        <p:nvSpPr>
+          <p:cNvPr id="9" name="TextBox 8"/>
+          <p:cNvSpPr txBox="1"/>
+          <p:nvPr/>
+        </p:nvSpPr>
+        <p:spPr>
+          <a:xfrm>
+            <a:off x="548640" y="6510528"/>
+            <a:ext cx="2743200" cy="256032"/>
+          </a:xfrm>
+          <a:prstGeom prst="rect">
+            <a:avLst/>
+          </a:prstGeom>
+          <a:noFill/>
+        </p:spPr>
+        <p:txBody>
+          <a:bodyPr wrap="square" anchor="t">
+            <a:spAutoFit/>
+          </a:bodyPr>
+          <a:lstStyle/>
+          <a:p>
+            <a:pPr algn="l"/>
+            <a:r>
+              <a:rPr sz="1100" b="1">
+                <a:solidFill>
+                  <a:srgbClr val="5234B7"/>
+                </a:solidFill>
+                <a:latin typeface="DIN Next LT W23"/>
+                <a:ea typeface="DIN Next LT W23"/>
+                <a:cs typeface="DIN Next LT W23"/>
+              </a:rPr>
+              <a:t>ETRA</a:t>
+            </a:r>
+          </a:p>
+        </p:txBody>
+      </p:sp>
+      <p:sp>
+        <p:nvSpPr>
+          <p:cNvPr id="10" name="TextBox 9"/>
+          <p:cNvSpPr txBox="1"/>
+          <p:nvPr/>
+        </p:nvSpPr>
+        <p:spPr>
+          <a:xfrm>
+            <a:off x="9601200" y="6510528"/>
+            <a:ext cx="2011680" cy="256032"/>
+          </a:xfrm>
+          <a:prstGeom prst="rect">
+            <a:avLst/>
+          </a:prstGeom>
+          <a:noFill/>
+        </p:spPr>
+        <p:txBody>
+          <a:bodyPr wrap="square" anchor="t">
+            <a:spAutoFit/>
+          </a:bodyPr>
+          <a:lstStyle/>
+          <a:p>
+            <a:pPr algn="r"/>
+            <a:r>
+              <a:rPr sz="1100" b="0">
+                <a:solidFill>
+                  <a:srgbClr val="5A5470"/>
+                </a:solidFill>
+                <a:latin typeface="DIN Next LT W23"/>
+                <a:ea typeface="DIN Next LT W23"/>
+                <a:cs typeface="DIN Next LT W23"/>
+              </a:rPr>
+              <a:t>34  /  37</a:t>
+            </a:r>
+          </a:p>
+        </p:txBody>
+      </p:sp>
+    </p:spTree>
+  </p:cSld>
+  <p:clrMapOvr>
+    <a:masterClrMapping/>
+  </p:clrMapOvr>
+</p:sld>
+</file>
+
+<file path=ppt/slides/slide35.xml><?xml version="1.0" encoding="utf-8"?>
+<p:sld xmlns:a="http://schemas.openxmlformats.org/drawingml/2006/main" xmlns:p="http://schemas.openxmlformats.org/presentationml/2006/main" xmlns:r="http://schemas.openxmlformats.org/officeDocument/2006/relationships">
+  <p:cSld>
+    <p:bg>
+      <p:bgPr>
+        <a:solidFill>
+          <a:srgbClr val="FAF8FF"/>
+        </a:solidFill>
+        <a:effectLst/>
+      </p:bgPr>
+    </p:bg>
+    <p:spTree>
+      <p:nvGrpSpPr>
+        <p:cNvPr id="1" name=""/>
+        <p:cNvGrpSpPr/>
+        <p:nvPr/>
+      </p:nvGrpSpPr>
+      <p:grpSpPr/>
+      <p:sp>
+        <p:nvSpPr>
+          <p:cNvPr id="2" name="Rectangle 1"/>
+          <p:cNvSpPr/>
+          <p:nvPr/>
+        </p:nvSpPr>
+        <p:spPr>
+          <a:xfrm>
+            <a:off x="12136831" y="0"/>
+            <a:ext cx="54864" cy="6858000"/>
+          </a:xfrm>
+          <a:prstGeom prst="rect">
+            <a:avLst/>
+          </a:prstGeom>
+          <a:solidFill>
+            <a:srgbClr val="5234B7"/>
+          </a:solidFill>
+          <a:ln>
+            <a:noFill/>
+          </a:ln>
+          <a:effectLst/>
+        </p:spPr>
+        <p:style>
+          <a:lnRef idx="1">
+            <a:schemeClr val="accent1"/>
+          </a:lnRef>
+          <a:fillRef idx="3">
+            <a:schemeClr val="accent1"/>
+          </a:fillRef>
+          <a:effectRef idx="2">
+            <a:schemeClr val="accent1"/>
+          </a:effectRef>
+          <a:fontRef idx="minor">
+            <a:schemeClr val="lt1"/>
+          </a:fontRef>
+        </p:style>
+        <p:txBody>
+          <a:bodyPr rtlCol="0" anchor="ctr"/>
+          <a:lstStyle/>
+          <a:p>
+            <a:pPr algn="ctr"/>
+          </a:p>
+        </p:txBody>
+      </p:sp>
+      <p:pic>
+        <p:nvPicPr>
+          <p:cNvPr id="3" name="Picture 2" descr="etra-wordmark.png"/>
+          <p:cNvPicPr>
+            <a:picLocks noChangeAspect="1"/>
+          </p:cNvPicPr>
+          <p:nvPr/>
+        </p:nvPicPr>
+        <p:blipFill>
+          <a:blip r:embed="rId2"/>
+          <a:stretch>
+            <a:fillRect/>
+          </a:stretch>
+        </p:blipFill>
+        <p:spPr>
+          <a:xfrm>
+            <a:off x="10561320" y="411480"/>
+            <a:ext cx="1206201" cy="320040"/>
+          </a:xfrm>
+          <a:prstGeom prst="rect">
+            <a:avLst/>
+          </a:prstGeom>
+        </p:spPr>
+      </p:pic>
+      <p:sp>
+        <p:nvSpPr>
+          <p:cNvPr id="4" name="TextBox 3"/>
+          <p:cNvSpPr txBox="1"/>
+          <p:nvPr/>
+        </p:nvSpPr>
+        <p:spPr>
+          <a:xfrm>
+            <a:off x="548640" y="438912"/>
+            <a:ext cx="7772400" cy="274320"/>
+          </a:xfrm>
+          <a:prstGeom prst="rect">
+            <a:avLst/>
+          </a:prstGeom>
+          <a:noFill/>
+        </p:spPr>
+        <p:txBody>
+          <a:bodyPr wrap="square" anchor="t">
+            <a:spAutoFit/>
+          </a:bodyPr>
+          <a:lstStyle/>
+          <a:p>
+            <a:pPr algn="l"/>
+            <a:r>
+              <a:rPr sz="1200" b="0">
+                <a:solidFill>
+                  <a:srgbClr val="5A5470"/>
+                </a:solidFill>
+                <a:latin typeface="DIN Next LT W23"/>
+                <a:ea typeface="DIN Next LT W23"/>
+                <a:cs typeface="DIN Next LT W23"/>
+              </a:rPr>
+              <a:t>S14  ·  GenAI</a:t>
+            </a:r>
+          </a:p>
+        </p:txBody>
+      </p:sp>
+      <p:sp>
+        <p:nvSpPr>
+          <p:cNvPr id="5" name="Rectangle 4"/>
+          <p:cNvSpPr/>
+          <p:nvPr/>
+        </p:nvSpPr>
+        <p:spPr>
+          <a:xfrm>
+            <a:off x="548640" y="822960"/>
+            <a:ext cx="11064240" cy="10972"/>
+          </a:xfrm>
+          <a:prstGeom prst="rect">
+            <a:avLst/>
+          </a:prstGeom>
+          <a:solidFill>
+            <a:srgbClr val="E4DCF4"/>
+          </a:solidFill>
+          <a:ln>
+            <a:noFill/>
+          </a:ln>
+          <a:effectLst/>
+        </p:spPr>
+        <p:style>
+          <a:lnRef idx="1">
+            <a:schemeClr val="accent1"/>
+          </a:lnRef>
+          <a:fillRef idx="3">
+            <a:schemeClr val="accent1"/>
+          </a:fillRef>
+          <a:effectRef idx="2">
+            <a:schemeClr val="accent1"/>
+          </a:effectRef>
+          <a:fontRef idx="minor">
+            <a:schemeClr val="lt1"/>
+          </a:fontRef>
+        </p:style>
+        <p:txBody>
+          <a:bodyPr rtlCol="0" anchor="ctr"/>
+          <a:lstStyle/>
+          <a:p>
+            <a:pPr algn="ctr"/>
+          </a:p>
+        </p:txBody>
+      </p:sp>
+      <p:sp>
+        <p:nvSpPr>
+          <p:cNvPr id="6" name="TextBox 5"/>
+          <p:cNvSpPr txBox="1"/>
+          <p:nvPr/>
+        </p:nvSpPr>
+        <p:spPr>
+          <a:xfrm>
+            <a:off x="548640" y="1024128"/>
+            <a:ext cx="10241280" cy="566928"/>
+          </a:xfrm>
+          <a:prstGeom prst="rect">
+            <a:avLst/>
+          </a:prstGeom>
+          <a:noFill/>
+        </p:spPr>
+        <p:txBody>
+          <a:bodyPr wrap="square" anchor="t">
+            <a:spAutoFit/>
+          </a:bodyPr>
+          <a:lstStyle/>
+          <a:p>
+            <a:pPr algn="l"/>
+            <a:r>
+              <a:rPr sz="3200" b="1">
+                <a:solidFill>
+                  <a:srgbClr val="5234B7"/>
+                </a:solidFill>
+                <a:latin typeface="DIN Next LT W23"/>
+                <a:ea typeface="DIN Next LT W23"/>
+                <a:cs typeface="DIN Next LT W23"/>
+              </a:rPr>
+              <a:t>Generative AI Practical Takeaways</a:t>
+            </a:r>
+          </a:p>
+        </p:txBody>
+      </p:sp>
+      <p:sp>
+        <p:nvSpPr>
+          <p:cNvPr id="7" name="TextBox 6"/>
+          <p:cNvSpPr txBox="1"/>
+          <p:nvPr/>
+        </p:nvSpPr>
+        <p:spPr>
+          <a:xfrm>
+            <a:off x="548640" y="1737360"/>
+            <a:ext cx="320040" cy="571500"/>
+          </a:xfrm>
+          <a:prstGeom prst="rect">
+            <a:avLst/>
+          </a:prstGeom>
+          <a:noFill/>
+        </p:spPr>
+        <p:txBody>
+          <a:bodyPr wrap="square" anchor="t">
+            <a:spAutoFit/>
+          </a:bodyPr>
+          <a:lstStyle/>
+          <a:p>
+            <a:pPr algn="l"/>
+            <a:r>
+              <a:rPr sz="1400" b="0">
+                <a:solidFill>
+                  <a:srgbClr val="9E59CD"/>
+                </a:solidFill>
+                <a:latin typeface="DIN Next LT W23"/>
+                <a:ea typeface="DIN Next LT W23"/>
+                <a:cs typeface="DIN Next LT W23"/>
+              </a:rPr>
+              <a:t>–</a:t>
+            </a:r>
+          </a:p>
+        </p:txBody>
+      </p:sp>
+      <p:sp>
+        <p:nvSpPr>
+          <p:cNvPr id="8" name="TextBox 7"/>
+          <p:cNvSpPr txBox="1"/>
+          <p:nvPr/>
+        </p:nvSpPr>
+        <p:spPr>
+          <a:xfrm>
+            <a:off x="914400" y="1737360"/>
+            <a:ext cx="9875519" cy="571500"/>
+          </a:xfrm>
+          <a:prstGeom prst="rect">
+            <a:avLst/>
+          </a:prstGeom>
+          <a:noFill/>
+        </p:spPr>
+        <p:txBody>
+          <a:bodyPr wrap="square" anchor="t">
+            <a:spAutoFit/>
+          </a:bodyPr>
+          <a:lstStyle/>
+          <a:p>
+            <a:pPr algn="l"/>
+            <a:r>
+              <a:rPr sz="1400" b="0">
+                <a:solidFill>
+                  <a:srgbClr val="121018"/>
+                </a:solidFill>
+                <a:latin typeface="DIN Next LT W23"/>
+                <a:ea typeface="DIN Next LT W23"/>
+                <a:cs typeface="DIN Next LT W23"/>
+              </a:rPr>
+              <a:t>Choose architecture by task type: encoder-only, encoder-decoder, or decoder-only.</a:t>
+            </a:r>
+          </a:p>
+        </p:txBody>
+      </p:sp>
+      <p:sp>
+        <p:nvSpPr>
+          <p:cNvPr id="9" name="TextBox 8"/>
+          <p:cNvSpPr txBox="1"/>
+          <p:nvPr/>
+        </p:nvSpPr>
+        <p:spPr>
+          <a:xfrm>
+            <a:off x="548640" y="2400300"/>
+            <a:ext cx="320040" cy="571500"/>
+          </a:xfrm>
+          <a:prstGeom prst="rect">
+            <a:avLst/>
+          </a:prstGeom>
+          <a:noFill/>
+        </p:spPr>
+        <p:txBody>
+          <a:bodyPr wrap="square" anchor="t">
+            <a:spAutoFit/>
+          </a:bodyPr>
+          <a:lstStyle/>
+          <a:p>
+            <a:pPr algn="l"/>
+            <a:r>
+              <a:rPr sz="1400" b="0">
+                <a:solidFill>
+                  <a:srgbClr val="9E59CD"/>
+                </a:solidFill>
+                <a:latin typeface="DIN Next LT W23"/>
+                <a:ea typeface="DIN Next LT W23"/>
+                <a:cs typeface="DIN Next LT W23"/>
+              </a:rPr>
+              <a:t>–</a:t>
+            </a:r>
+          </a:p>
+        </p:txBody>
+      </p:sp>
+      <p:sp>
+        <p:nvSpPr>
+          <p:cNvPr id="10" name="TextBox 9"/>
+          <p:cNvSpPr txBox="1"/>
+          <p:nvPr/>
+        </p:nvSpPr>
+        <p:spPr>
+          <a:xfrm>
+            <a:off x="914400" y="2400300"/>
+            <a:ext cx="9875519" cy="571500"/>
+          </a:xfrm>
+          <a:prstGeom prst="rect">
+            <a:avLst/>
+          </a:prstGeom>
+          <a:noFill/>
+        </p:spPr>
+        <p:txBody>
+          <a:bodyPr wrap="square" anchor="t">
+            <a:spAutoFit/>
+          </a:bodyPr>
+          <a:lstStyle/>
+          <a:p>
+            <a:pPr algn="l"/>
+            <a:r>
+              <a:rPr sz="1400" b="0">
+                <a:solidFill>
+                  <a:srgbClr val="121018"/>
+                </a:solidFill>
+                <a:latin typeface="DIN Next LT W23"/>
+                <a:ea typeface="DIN Next LT W23"/>
+                <a:cs typeface="DIN Next LT W23"/>
+              </a:rPr>
+              <a:t>Prefer transfer learning and fine-tuning over training from scratch when possible.</a:t>
+            </a:r>
+          </a:p>
+        </p:txBody>
+      </p:sp>
+      <p:sp>
+        <p:nvSpPr>
+          <p:cNvPr id="11" name="TextBox 10"/>
+          <p:cNvSpPr txBox="1"/>
+          <p:nvPr/>
+        </p:nvSpPr>
+        <p:spPr>
+          <a:xfrm>
+            <a:off x="548640" y="3063240"/>
+            <a:ext cx="320040" cy="571500"/>
+          </a:xfrm>
+          <a:prstGeom prst="rect">
+            <a:avLst/>
+          </a:prstGeom>
+          <a:noFill/>
+        </p:spPr>
+        <p:txBody>
+          <a:bodyPr wrap="square" anchor="t">
+            <a:spAutoFit/>
+          </a:bodyPr>
+          <a:lstStyle/>
+          <a:p>
+            <a:pPr algn="l"/>
+            <a:r>
+              <a:rPr sz="1400" b="0">
+                <a:solidFill>
+                  <a:srgbClr val="9E59CD"/>
+                </a:solidFill>
+                <a:latin typeface="DIN Next LT W23"/>
+                <a:ea typeface="DIN Next LT W23"/>
+                <a:cs typeface="DIN Next LT W23"/>
+              </a:rPr>
+              <a:t>–</a:t>
+            </a:r>
+          </a:p>
+        </p:txBody>
+      </p:sp>
+      <p:sp>
+        <p:nvSpPr>
+          <p:cNvPr id="12" name="TextBox 11"/>
+          <p:cNvSpPr txBox="1"/>
+          <p:nvPr/>
+        </p:nvSpPr>
+        <p:spPr>
+          <a:xfrm>
+            <a:off x="914400" y="3063240"/>
+            <a:ext cx="9875519" cy="571500"/>
+          </a:xfrm>
+          <a:prstGeom prst="rect">
+            <a:avLst/>
+          </a:prstGeom>
+          <a:noFill/>
+        </p:spPr>
+        <p:txBody>
+          <a:bodyPr wrap="square" anchor="t">
+            <a:spAutoFit/>
+          </a:bodyPr>
+          <a:lstStyle/>
+          <a:p>
+            <a:pPr algn="l"/>
+            <a:r>
+              <a:rPr sz="1400" b="0">
+                <a:solidFill>
+                  <a:srgbClr val="121018"/>
+                </a:solidFill>
+                <a:latin typeface="DIN Next LT W23"/>
+                <a:ea typeface="DIN Next LT W23"/>
+                <a:cs typeface="DIN Next LT W23"/>
+              </a:rPr>
+              <a:t>Use attention-aware designs and decoding strategy (greedy/beam) based on product constraints.</a:t>
+            </a:r>
+          </a:p>
+        </p:txBody>
+      </p:sp>
+      <p:sp>
+        <p:nvSpPr>
+          <p:cNvPr id="13" name="TextBox 12"/>
+          <p:cNvSpPr txBox="1"/>
+          <p:nvPr/>
+        </p:nvSpPr>
+        <p:spPr>
+          <a:xfrm>
+            <a:off x="548640" y="3726179"/>
+            <a:ext cx="320040" cy="571500"/>
+          </a:xfrm>
+          <a:prstGeom prst="rect">
+            <a:avLst/>
+          </a:prstGeom>
+          <a:noFill/>
+        </p:spPr>
+        <p:txBody>
+          <a:bodyPr wrap="square" anchor="t">
+            <a:spAutoFit/>
+          </a:bodyPr>
+          <a:lstStyle/>
+          <a:p>
+            <a:pPr algn="l"/>
+            <a:r>
+              <a:rPr sz="1400" b="0">
+                <a:solidFill>
+                  <a:srgbClr val="9E59CD"/>
+                </a:solidFill>
+                <a:latin typeface="DIN Next LT W23"/>
+                <a:ea typeface="DIN Next LT W23"/>
+                <a:cs typeface="DIN Next LT W23"/>
+              </a:rPr>
+              <a:t>–</a:t>
+            </a:r>
+          </a:p>
+        </p:txBody>
+      </p:sp>
+      <p:sp>
+        <p:nvSpPr>
+          <p:cNvPr id="14" name="TextBox 13"/>
+          <p:cNvSpPr txBox="1"/>
+          <p:nvPr/>
+        </p:nvSpPr>
+        <p:spPr>
+          <a:xfrm>
+            <a:off x="914400" y="3726179"/>
+            <a:ext cx="9875519" cy="571500"/>
+          </a:xfrm>
+          <a:prstGeom prst="rect">
+            <a:avLst/>
+          </a:prstGeom>
+          <a:noFill/>
+        </p:spPr>
+        <p:txBody>
+          <a:bodyPr wrap="square" anchor="t">
+            <a:spAutoFit/>
+          </a:bodyPr>
+          <a:lstStyle/>
+          <a:p>
+            <a:pPr algn="l"/>
+            <a:r>
+              <a:rPr sz="1400" b="0">
+                <a:solidFill>
+                  <a:srgbClr val="121018"/>
+                </a:solidFill>
+                <a:latin typeface="DIN Next LT W23"/>
+                <a:ea typeface="DIN Next LT W23"/>
+                <a:cs typeface="DIN Next LT W23"/>
+              </a:rPr>
+              <a:t>Plan for memory/compute early: quantization, context limits, and deployment targets.</a:t>
+            </a:r>
+          </a:p>
+        </p:txBody>
+      </p:sp>
+      <p:sp>
+        <p:nvSpPr>
+          <p:cNvPr id="15" name="TextBox 14"/>
+          <p:cNvSpPr txBox="1"/>
+          <p:nvPr/>
+        </p:nvSpPr>
+        <p:spPr>
+          <a:xfrm>
+            <a:off x="548640" y="4389120"/>
+            <a:ext cx="320040" cy="571500"/>
+          </a:xfrm>
+          <a:prstGeom prst="rect">
+            <a:avLst/>
+          </a:prstGeom>
+          <a:noFill/>
+        </p:spPr>
+        <p:txBody>
+          <a:bodyPr wrap="square" anchor="t">
+            <a:spAutoFit/>
+          </a:bodyPr>
+          <a:lstStyle/>
+          <a:p>
+            <a:pPr algn="l"/>
+            <a:r>
+              <a:rPr sz="1400" b="0">
+                <a:solidFill>
+                  <a:srgbClr val="9E59CD"/>
+                </a:solidFill>
+                <a:latin typeface="DIN Next LT W23"/>
+                <a:ea typeface="DIN Next LT W23"/>
+                <a:cs typeface="DIN Next LT W23"/>
+              </a:rPr>
+              <a:t>–</a:t>
+            </a:r>
+          </a:p>
+        </p:txBody>
+      </p:sp>
+      <p:sp>
+        <p:nvSpPr>
+          <p:cNvPr id="16" name="TextBox 15"/>
+          <p:cNvSpPr txBox="1"/>
+          <p:nvPr/>
+        </p:nvSpPr>
+        <p:spPr>
+          <a:xfrm>
+            <a:off x="914400" y="4389120"/>
+            <a:ext cx="9875519" cy="571500"/>
+          </a:xfrm>
+          <a:prstGeom prst="rect">
+            <a:avLst/>
+          </a:prstGeom>
+          <a:noFill/>
+        </p:spPr>
+        <p:txBody>
+          <a:bodyPr wrap="square" anchor="t">
+            <a:spAutoFit/>
+          </a:bodyPr>
+          <a:lstStyle/>
+          <a:p>
+            <a:pPr algn="l"/>
+            <a:r>
+              <a:rPr sz="1400" b="0">
+                <a:solidFill>
+                  <a:srgbClr val="121018"/>
+                </a:solidFill>
+                <a:latin typeface="DIN Next LT W23"/>
+                <a:ea typeface="DIN Next LT W23"/>
+                <a:cs typeface="DIN Next LT W23"/>
+              </a:rPr>
+              <a:t>For domain-heavy use cases, adapt with specialized corpora and evaluation protocols.</a:t>
+            </a:r>
+          </a:p>
+        </p:txBody>
+      </p:sp>
+      <p:sp>
+        <p:nvSpPr>
+          <p:cNvPr id="17" name="TextBox 16"/>
+          <p:cNvSpPr txBox="1"/>
+          <p:nvPr/>
+        </p:nvSpPr>
+        <p:spPr>
+          <a:xfrm>
+            <a:off x="548640" y="5897880"/>
+            <a:ext cx="10972800" cy="274320"/>
+          </a:xfrm>
+          <a:prstGeom prst="rect">
+            <a:avLst/>
+          </a:prstGeom>
+          <a:noFill/>
+        </p:spPr>
+        <p:txBody>
+          <a:bodyPr wrap="square" anchor="t">
+            <a:spAutoFit/>
+          </a:bodyPr>
+          <a:lstStyle/>
+          <a:p>
+            <a:pPr algn="l"/>
+            <a:r>
+              <a:rPr sz="1200" b="0">
+                <a:solidFill>
+                  <a:srgbClr val="5A5470"/>
+                </a:solidFill>
+                <a:latin typeface="DIN Next LT W23"/>
+                <a:ea typeface="DIN Next LT W23"/>
+                <a:cs typeface="DIN Next LT W23"/>
+              </a:rPr>
+              <a:t>Strong GenAI systems come from balanced choices across data, architecture, compute, and evaluation.</a:t>
+            </a:r>
+          </a:p>
+        </p:txBody>
+      </p:sp>
+      <p:sp>
+        <p:nvSpPr>
+          <p:cNvPr id="18" name="Rectangle 17"/>
+          <p:cNvSpPr/>
+          <p:nvPr/>
+        </p:nvSpPr>
+        <p:spPr>
+          <a:xfrm>
+            <a:off x="548640" y="6446520"/>
+            <a:ext cx="11064240" cy="10972"/>
+          </a:xfrm>
+          <a:prstGeom prst="rect">
+            <a:avLst/>
+          </a:prstGeom>
+          <a:solidFill>
+            <a:srgbClr val="5234B7"/>
+          </a:solidFill>
+          <a:ln>
+            <a:noFill/>
+          </a:ln>
+          <a:effectLst/>
+        </p:spPr>
+        <p:style>
+          <a:lnRef idx="1">
+            <a:schemeClr val="accent1"/>
+          </a:lnRef>
+          <a:fillRef idx="3">
+            <a:schemeClr val="accent1"/>
+          </a:fillRef>
+          <a:effectRef idx="2">
+            <a:schemeClr val="accent1"/>
+          </a:effectRef>
+          <a:fontRef idx="minor">
+            <a:schemeClr val="lt1"/>
+          </a:fontRef>
+        </p:style>
+        <p:txBody>
+          <a:bodyPr rtlCol="0" anchor="ctr"/>
+          <a:lstStyle/>
+          <a:p>
+            <a:pPr algn="ctr"/>
+          </a:p>
+        </p:txBody>
+      </p:sp>
+      <p:sp>
+        <p:nvSpPr>
+          <p:cNvPr id="19" name="TextBox 18"/>
+          <p:cNvSpPr txBox="1"/>
+          <p:nvPr/>
+        </p:nvSpPr>
+        <p:spPr>
+          <a:xfrm>
+            <a:off x="548640" y="6510528"/>
+            <a:ext cx="2743200" cy="256032"/>
+          </a:xfrm>
+          <a:prstGeom prst="rect">
+            <a:avLst/>
+          </a:prstGeom>
+          <a:noFill/>
+        </p:spPr>
+        <p:txBody>
+          <a:bodyPr wrap="square" anchor="t">
+            <a:spAutoFit/>
+          </a:bodyPr>
+          <a:lstStyle/>
+          <a:p>
+            <a:pPr algn="l"/>
+            <a:r>
+              <a:rPr sz="1100" b="1">
+                <a:solidFill>
+                  <a:srgbClr val="5234B7"/>
+                </a:solidFill>
+                <a:latin typeface="DIN Next LT W23"/>
+                <a:ea typeface="DIN Next LT W23"/>
+                <a:cs typeface="DIN Next LT W23"/>
+              </a:rPr>
+              <a:t>ETRA</a:t>
+            </a:r>
+          </a:p>
+        </p:txBody>
+      </p:sp>
+      <p:sp>
+        <p:nvSpPr>
+          <p:cNvPr id="20" name="TextBox 19"/>
+          <p:cNvSpPr txBox="1"/>
+          <p:nvPr/>
+        </p:nvSpPr>
+        <p:spPr>
+          <a:xfrm>
+            <a:off x="9601200" y="6510528"/>
+            <a:ext cx="2011680" cy="256032"/>
+          </a:xfrm>
+          <a:prstGeom prst="rect">
+            <a:avLst/>
+          </a:prstGeom>
+          <a:noFill/>
+        </p:spPr>
+        <p:txBody>
+          <a:bodyPr wrap="square" anchor="t">
+            <a:spAutoFit/>
+          </a:bodyPr>
+          <a:lstStyle/>
+          <a:p>
+            <a:pPr algn="r"/>
+            <a:r>
+              <a:rPr sz="1100" b="0">
+                <a:solidFill>
+                  <a:srgbClr val="5A5470"/>
+                </a:solidFill>
+                <a:latin typeface="DIN Next LT W23"/>
+                <a:ea typeface="DIN Next LT W23"/>
+                <a:cs typeface="DIN Next LT W23"/>
+              </a:rPr>
+              <a:t>35  /  37</a:t>
+            </a:r>
+          </a:p>
+        </p:txBody>
+      </p:sp>
+    </p:spTree>
+  </p:cSld>
+  <p:clrMapOvr>
+    <a:masterClrMapping/>
+  </p:clrMapOvr>
+</p:sld>
+</file>
+
+<file path=ppt/slides/slide36.xml><?xml version="1.0" encoding="utf-8"?>
+<p:sld xmlns:a="http://schemas.openxmlformats.org/drawingml/2006/main" xmlns:p="http://schemas.openxmlformats.org/presentationml/2006/main" xmlns:r="http://schemas.openxmlformats.org/officeDocument/2006/relationships">
+  <p:cSld>
+    <p:bg>
+      <p:bgPr>
+        <a:solidFill>
+          <a:srgbClr val="FAF8FF"/>
+        </a:solidFill>
+        <a:effectLst/>
+      </p:bgPr>
+    </p:bg>
+    <p:spTree>
+      <p:nvGrpSpPr>
+        <p:cNvPr id="1" name=""/>
+        <p:cNvGrpSpPr/>
+        <p:nvPr/>
+      </p:nvGrpSpPr>
+      <p:grpSpPr/>
+      <p:sp>
+        <p:nvSpPr>
+          <p:cNvPr id="2" name="Rectangle 1"/>
+          <p:cNvSpPr/>
+          <p:nvPr/>
+        </p:nvSpPr>
+        <p:spPr>
+          <a:xfrm>
+            <a:off x="12136831" y="0"/>
+            <a:ext cx="54864" cy="6858000"/>
+          </a:xfrm>
+          <a:prstGeom prst="rect">
+            <a:avLst/>
+          </a:prstGeom>
+          <a:solidFill>
+            <a:srgbClr val="5234B7"/>
+          </a:solidFill>
+          <a:ln>
+            <a:noFill/>
+          </a:ln>
+          <a:effectLst/>
+        </p:spPr>
+        <p:style>
+          <a:lnRef idx="1">
+            <a:schemeClr val="accent1"/>
+          </a:lnRef>
+          <a:fillRef idx="3">
+            <a:schemeClr val="accent1"/>
+          </a:fillRef>
+          <a:effectRef idx="2">
+            <a:schemeClr val="accent1"/>
+          </a:effectRef>
+          <a:fontRef idx="minor">
+            <a:schemeClr val="lt1"/>
+          </a:fontRef>
+        </p:style>
+        <p:txBody>
+          <a:bodyPr rtlCol="0" anchor="ctr"/>
+          <a:lstStyle/>
+          <a:p>
+            <a:pPr algn="ctr"/>
+          </a:p>
+        </p:txBody>
+      </p:sp>
+      <p:pic>
+        <p:nvPicPr>
+          <p:cNvPr id="3" name="Picture 2" descr="etra-wordmark.png"/>
+          <p:cNvPicPr>
+            <a:picLocks noChangeAspect="1"/>
+          </p:cNvPicPr>
+          <p:nvPr/>
+        </p:nvPicPr>
+        <p:blipFill>
+          <a:blip r:embed="rId2"/>
+          <a:stretch>
+            <a:fillRect/>
+          </a:stretch>
+        </p:blipFill>
+        <p:spPr>
+          <a:xfrm>
+            <a:off x="10561320" y="411480"/>
+            <a:ext cx="1206201" cy="320040"/>
+          </a:xfrm>
+          <a:prstGeom prst="rect">
+            <a:avLst/>
+          </a:prstGeom>
+        </p:spPr>
+      </p:pic>
+      <p:sp>
+        <p:nvSpPr>
+          <p:cNvPr id="4" name="TextBox 3"/>
+          <p:cNvSpPr txBox="1"/>
+          <p:nvPr/>
+        </p:nvSpPr>
+        <p:spPr>
+          <a:xfrm>
+            <a:off x="548640" y="438912"/>
+            <a:ext cx="7772400" cy="274320"/>
+          </a:xfrm>
+          <a:prstGeom prst="rect">
+            <a:avLst/>
+          </a:prstGeom>
+          <a:noFill/>
+        </p:spPr>
+        <p:txBody>
+          <a:bodyPr wrap="square" anchor="t">
+            <a:spAutoFit/>
+          </a:bodyPr>
+          <a:lstStyle/>
+          <a:p>
+            <a:pPr algn="l"/>
+            <a:r>
+              <a:rPr sz="1200" b="0">
+                <a:solidFill>
+                  <a:srgbClr val="5A5470"/>
+                </a:solidFill>
+                <a:latin typeface="DIN Next LT W23"/>
+                <a:ea typeface="DIN Next LT W23"/>
+                <a:cs typeface="DIN Next LT W23"/>
+              </a:rPr>
+              <a:t>S14  ·  Takeaways</a:t>
+            </a:r>
+          </a:p>
+        </p:txBody>
+      </p:sp>
+      <p:sp>
+        <p:nvSpPr>
+          <p:cNvPr id="5" name="Rectangle 4"/>
+          <p:cNvSpPr/>
+          <p:nvPr/>
+        </p:nvSpPr>
+        <p:spPr>
+          <a:xfrm>
+            <a:off x="548640" y="822960"/>
+            <a:ext cx="11064240" cy="10972"/>
+          </a:xfrm>
+          <a:prstGeom prst="rect">
+            <a:avLst/>
+          </a:prstGeom>
+          <a:solidFill>
+            <a:srgbClr val="E4DCF4"/>
+          </a:solidFill>
+          <a:ln>
+            <a:noFill/>
+          </a:ln>
+          <a:effectLst/>
+        </p:spPr>
+        <p:style>
+          <a:lnRef idx="1">
+            <a:schemeClr val="accent1"/>
+          </a:lnRef>
+          <a:fillRef idx="3">
+            <a:schemeClr val="accent1"/>
+          </a:fillRef>
+          <a:effectRef idx="2">
+            <a:schemeClr val="accent1"/>
+          </a:effectRef>
+          <a:fontRef idx="minor">
+            <a:schemeClr val="lt1"/>
+          </a:fontRef>
+        </p:style>
+        <p:txBody>
+          <a:bodyPr rtlCol="0" anchor="ctr"/>
+          <a:lstStyle/>
+          <a:p>
+            <a:pPr algn="ctr"/>
+          </a:p>
+        </p:txBody>
+      </p:sp>
+      <p:sp>
+        <p:nvSpPr>
+          <p:cNvPr id="6" name="TextBox 5"/>
+          <p:cNvSpPr txBox="1"/>
+          <p:nvPr/>
+        </p:nvSpPr>
+        <p:spPr>
+          <a:xfrm>
+            <a:off x="548640" y="1051560"/>
+            <a:ext cx="10241280" cy="594360"/>
+          </a:xfrm>
+          <a:prstGeom prst="rect">
+            <a:avLst/>
+          </a:prstGeom>
+          <a:noFill/>
+        </p:spPr>
+        <p:txBody>
+          <a:bodyPr wrap="square" anchor="t">
+            <a:spAutoFit/>
+          </a:bodyPr>
+          <a:lstStyle/>
+          <a:p>
+            <a:pPr algn="l"/>
+            <a:r>
+              <a:rPr sz="3200" b="1">
+                <a:solidFill>
+                  <a:srgbClr val="5234B7"/>
+                </a:solidFill>
+                <a:latin typeface="DIN Next LT W23"/>
+                <a:ea typeface="DIN Next LT W23"/>
+                <a:cs typeface="DIN Next LT W23"/>
+              </a:rPr>
+              <a:t>3 Ideas to Keep</a:t>
+            </a:r>
+          </a:p>
+        </p:txBody>
+      </p:sp>
+      <p:sp>
+        <p:nvSpPr>
+          <p:cNvPr id="7" name="TextBox 6"/>
+          <p:cNvSpPr txBox="1"/>
+          <p:nvPr/>
+        </p:nvSpPr>
+        <p:spPr>
+          <a:xfrm>
+            <a:off x="548640" y="1600200"/>
+            <a:ext cx="10241280" cy="365760"/>
+          </a:xfrm>
+          <a:prstGeom prst="rect">
+            <a:avLst/>
+          </a:prstGeom>
+          <a:noFill/>
+        </p:spPr>
+        <p:txBody>
+          <a:bodyPr wrap="square" anchor="t">
+            <a:spAutoFit/>
+          </a:bodyPr>
+          <a:lstStyle/>
+          <a:p>
+            <a:pPr algn="l"/>
+            <a:r>
+              <a:rPr sz="1500" b="0">
+                <a:solidFill>
+                  <a:srgbClr val="5A5470"/>
+                </a:solidFill>
+                <a:latin typeface="DIN Next LT W23"/>
+                <a:ea typeface="DIN Next LT W23"/>
+                <a:cs typeface="DIN Next LT W23"/>
+              </a:rPr>
+              <a:t>Leave with these</a:t>
+            </a:r>
+          </a:p>
+        </p:txBody>
+      </p:sp>
+      <p:sp>
+        <p:nvSpPr>
+          <p:cNvPr id="8" name="Rounded Rectangle 7"/>
+          <p:cNvSpPr/>
+          <p:nvPr/>
+        </p:nvSpPr>
+        <p:spPr>
+          <a:xfrm>
+            <a:off x="548640" y="2148840"/>
+            <a:ext cx="10972800" cy="987552"/>
+          </a:xfrm>
+          <a:prstGeom prst="roundRect">
+            <a:avLst>
+              <a:gd name="adj" fmla="val 10000"/>
+            </a:avLst>
+          </a:prstGeom>
+          <a:solidFill>
+            <a:srgbClr val="EEE8FA"/>
+          </a:solidFill>
+          <a:ln>
+            <a:noFill/>
+          </a:ln>
+          <a:effectLst/>
+        </p:spPr>
+        <p:style>
+          <a:lnRef idx="1">
+            <a:schemeClr val="accent1"/>
+          </a:lnRef>
+          <a:fillRef idx="3">
+            <a:schemeClr val="accent1"/>
+          </a:fillRef>
+          <a:effectRef idx="2">
+            <a:schemeClr val="accent1"/>
+          </a:effectRef>
+          <a:fontRef idx="minor">
+            <a:schemeClr val="lt1"/>
+          </a:fontRef>
+        </p:style>
+        <p:txBody>
+          <a:bodyPr rtlCol="0" anchor="ctr"/>
+          <a:lstStyle/>
+          <a:p>
+            <a:pPr algn="ctr"/>
+          </a:p>
+        </p:txBody>
+      </p:sp>
+      <p:sp>
+        <p:nvSpPr>
+          <p:cNvPr id="9" name="TextBox 8"/>
+          <p:cNvSpPr txBox="1"/>
+          <p:nvPr/>
+        </p:nvSpPr>
+        <p:spPr>
+          <a:xfrm>
+            <a:off x="822960" y="2404872"/>
+            <a:ext cx="457200" cy="457200"/>
+          </a:xfrm>
+          <a:prstGeom prst="rect">
+            <a:avLst/>
+          </a:prstGeom>
+          <a:noFill/>
+        </p:spPr>
+        <p:txBody>
+          <a:bodyPr wrap="square" anchor="t">
+            <a:spAutoFit/>
+          </a:bodyPr>
+          <a:lstStyle/>
+          <a:p>
+            <a:pPr algn="l"/>
+            <a:r>
+              <a:rPr sz="2200" b="1">
+                <a:solidFill>
+                  <a:srgbClr val="5234B7"/>
+                </a:solidFill>
+                <a:latin typeface="DIN Next LT W23"/>
+                <a:ea typeface="DIN Next LT W23"/>
+                <a:cs typeface="DIN Next LT W23"/>
+              </a:rPr>
+              <a:t>1</a:t>
+            </a:r>
+          </a:p>
+        </p:txBody>
+      </p:sp>
+      <p:sp>
+        <p:nvSpPr>
+          <p:cNvPr id="10" name="TextBox 9"/>
+          <p:cNvSpPr txBox="1"/>
+          <p:nvPr/>
+        </p:nvSpPr>
+        <p:spPr>
+          <a:xfrm>
+            <a:off x="1417320" y="2404872"/>
+            <a:ext cx="9692640" cy="548640"/>
+          </a:xfrm>
+          <a:prstGeom prst="rect">
+            <a:avLst/>
+          </a:prstGeom>
+          <a:noFill/>
+        </p:spPr>
+        <p:txBody>
+          <a:bodyPr wrap="square" anchor="t">
+            <a:spAutoFit/>
+          </a:bodyPr>
+          <a:lstStyle/>
+          <a:p>
+            <a:pPr algn="l"/>
+            <a:r>
+              <a:rPr sz="1600" b="0">
+                <a:solidFill>
+                  <a:srgbClr val="121018"/>
+                </a:solidFill>
+                <a:latin typeface="DIN Next LT W23"/>
+                <a:ea typeface="DIN Next LT W23"/>
+                <a:cs typeface="DIN Next LT W23"/>
+              </a:rPr>
+              <a:t>Choose architecture by task: encoder-only (BERT), encoder-decoder (T5), or decoder-only (GPT).</a:t>
+            </a:r>
+          </a:p>
+        </p:txBody>
+      </p:sp>
+      <p:sp>
+        <p:nvSpPr>
+          <p:cNvPr id="11" name="Rounded Rectangle 10"/>
+          <p:cNvSpPr/>
+          <p:nvPr/>
+        </p:nvSpPr>
+        <p:spPr>
+          <a:xfrm>
+            <a:off x="548640" y="3291840"/>
+            <a:ext cx="10972800" cy="987552"/>
+          </a:xfrm>
+          <a:prstGeom prst="roundRect">
+            <a:avLst>
+              <a:gd name="adj" fmla="val 10000"/>
+            </a:avLst>
+          </a:prstGeom>
+          <a:solidFill>
+            <a:srgbClr val="EEE8FA"/>
+          </a:solidFill>
+          <a:ln>
+            <a:noFill/>
+          </a:ln>
+          <a:effectLst/>
+        </p:spPr>
+        <p:style>
+          <a:lnRef idx="1">
+            <a:schemeClr val="accent1"/>
+          </a:lnRef>
+          <a:fillRef idx="3">
+            <a:schemeClr val="accent1"/>
+          </a:fillRef>
+          <a:effectRef idx="2">
+            <a:schemeClr val="accent1"/>
+          </a:effectRef>
+          <a:fontRef idx="minor">
+            <a:schemeClr val="lt1"/>
+          </a:fontRef>
+        </p:style>
+        <p:txBody>
+          <a:bodyPr rtlCol="0" anchor="ctr"/>
+          <a:lstStyle/>
+          <a:p>
+            <a:pPr algn="ctr"/>
+          </a:p>
+        </p:txBody>
+      </p:sp>
+      <p:sp>
+        <p:nvSpPr>
+          <p:cNvPr id="12" name="TextBox 11"/>
+          <p:cNvSpPr txBox="1"/>
+          <p:nvPr/>
+        </p:nvSpPr>
+        <p:spPr>
+          <a:xfrm>
+            <a:off x="822960" y="3547872"/>
+            <a:ext cx="457200" cy="457200"/>
+          </a:xfrm>
+          <a:prstGeom prst="rect">
+            <a:avLst/>
+          </a:prstGeom>
+          <a:noFill/>
+        </p:spPr>
+        <p:txBody>
+          <a:bodyPr wrap="square" anchor="t">
+            <a:spAutoFit/>
+          </a:bodyPr>
+          <a:lstStyle/>
+          <a:p>
+            <a:pPr algn="l"/>
+            <a:r>
+              <a:rPr sz="2200" b="1">
+                <a:solidFill>
+                  <a:srgbClr val="5234B7"/>
+                </a:solidFill>
+                <a:latin typeface="DIN Next LT W23"/>
+                <a:ea typeface="DIN Next LT W23"/>
+                <a:cs typeface="DIN Next LT W23"/>
+              </a:rPr>
+              <a:t>2</a:t>
+            </a:r>
+          </a:p>
+        </p:txBody>
+      </p:sp>
+      <p:sp>
+        <p:nvSpPr>
+          <p:cNvPr id="13" name="TextBox 12"/>
+          <p:cNvSpPr txBox="1"/>
+          <p:nvPr/>
+        </p:nvSpPr>
+        <p:spPr>
+          <a:xfrm>
+            <a:off x="1417320" y="3547872"/>
+            <a:ext cx="9692640" cy="548640"/>
+          </a:xfrm>
+          <a:prstGeom prst="rect">
+            <a:avLst/>
+          </a:prstGeom>
+          <a:noFill/>
+        </p:spPr>
+        <p:txBody>
+          <a:bodyPr wrap="square" anchor="t">
+            <a:spAutoFit/>
+          </a:bodyPr>
+          <a:lstStyle/>
+          <a:p>
+            <a:pPr algn="l"/>
+            <a:r>
+              <a:rPr sz="1600" b="0">
+                <a:solidFill>
+                  <a:srgbClr val="121018"/>
+                </a:solidFill>
+                <a:latin typeface="DIN Next LT W23"/>
+                <a:ea typeface="DIN Next LT W23"/>
+                <a:cs typeface="DIN Next LT W23"/>
+              </a:rPr>
+              <a:t>Prefer transfer learning and fine-tuning over training from scratch.</a:t>
+            </a:r>
+          </a:p>
+        </p:txBody>
+      </p:sp>
+      <p:sp>
+        <p:nvSpPr>
+          <p:cNvPr id="14" name="Rounded Rectangle 13"/>
+          <p:cNvSpPr/>
+          <p:nvPr/>
+        </p:nvSpPr>
+        <p:spPr>
+          <a:xfrm>
+            <a:off x="548640" y="4434840"/>
+            <a:ext cx="10972800" cy="987552"/>
+          </a:xfrm>
+          <a:prstGeom prst="roundRect">
+            <a:avLst>
+              <a:gd name="adj" fmla="val 10000"/>
+            </a:avLst>
+          </a:prstGeom>
+          <a:solidFill>
+            <a:srgbClr val="EEE8FA"/>
+          </a:solidFill>
+          <a:ln>
+            <a:noFill/>
+          </a:ln>
+          <a:effectLst/>
+        </p:spPr>
+        <p:style>
+          <a:lnRef idx="1">
+            <a:schemeClr val="accent1"/>
+          </a:lnRef>
+          <a:fillRef idx="3">
+            <a:schemeClr val="accent1"/>
+          </a:fillRef>
+          <a:effectRef idx="2">
+            <a:schemeClr val="accent1"/>
+          </a:effectRef>
+          <a:fontRef idx="minor">
+            <a:schemeClr val="lt1"/>
+          </a:fontRef>
+        </p:style>
+        <p:txBody>
+          <a:bodyPr rtlCol="0" anchor="ctr"/>
+          <a:lstStyle/>
+          <a:p>
+            <a:pPr algn="ctr"/>
+          </a:p>
+        </p:txBody>
+      </p:sp>
+      <p:sp>
+        <p:nvSpPr>
+          <p:cNvPr id="15" name="TextBox 14"/>
+          <p:cNvSpPr txBox="1"/>
+          <p:nvPr/>
+        </p:nvSpPr>
+        <p:spPr>
+          <a:xfrm>
+            <a:off x="822960" y="4690872"/>
+            <a:ext cx="457200" cy="457200"/>
+          </a:xfrm>
+          <a:prstGeom prst="rect">
+            <a:avLst/>
+          </a:prstGeom>
+          <a:noFill/>
+        </p:spPr>
+        <p:txBody>
+          <a:bodyPr wrap="square" anchor="t">
+            <a:spAutoFit/>
+          </a:bodyPr>
+          <a:lstStyle/>
+          <a:p>
+            <a:pPr algn="l"/>
+            <a:r>
+              <a:rPr sz="2200" b="1">
+                <a:solidFill>
+                  <a:srgbClr val="5234B7"/>
+                </a:solidFill>
+                <a:latin typeface="DIN Next LT W23"/>
+                <a:ea typeface="DIN Next LT W23"/>
+                <a:cs typeface="DIN Next LT W23"/>
+              </a:rPr>
+              <a:t>3</a:t>
+            </a:r>
+          </a:p>
+        </p:txBody>
+      </p:sp>
+      <p:sp>
+        <p:nvSpPr>
+          <p:cNvPr id="16" name="TextBox 15"/>
+          <p:cNvSpPr txBox="1"/>
+          <p:nvPr/>
+        </p:nvSpPr>
+        <p:spPr>
+          <a:xfrm>
+            <a:off x="1417320" y="4690872"/>
+            <a:ext cx="9692640" cy="548640"/>
+          </a:xfrm>
+          <a:prstGeom prst="rect">
+            <a:avLst/>
+          </a:prstGeom>
+          <a:noFill/>
+        </p:spPr>
+        <p:txBody>
+          <a:bodyPr wrap="square" anchor="t">
+            <a:spAutoFit/>
+          </a:bodyPr>
+          <a:lstStyle/>
+          <a:p>
+            <a:pPr algn="l"/>
+            <a:r>
+              <a:rPr sz="1600" b="0">
+                <a:solidFill>
+                  <a:srgbClr val="121018"/>
+                </a:solidFill>
+                <a:latin typeface="DIN Next LT W23"/>
+                <a:ea typeface="DIN Next LT W23"/>
+                <a:cs typeface="DIN Next LT W23"/>
+              </a:rPr>
+              <a:t>Attention, decoding strategy, and compute limits shape what you can ship.</a:t>
+            </a:r>
+          </a:p>
+        </p:txBody>
+      </p:sp>
+      <p:sp>
+        <p:nvSpPr>
+          <p:cNvPr id="17" name="Rectangle 16"/>
+          <p:cNvSpPr/>
+          <p:nvPr/>
+        </p:nvSpPr>
+        <p:spPr>
+          <a:xfrm>
+            <a:off x="548640" y="6446520"/>
+            <a:ext cx="11064240" cy="10972"/>
+          </a:xfrm>
+          <a:prstGeom prst="rect">
+            <a:avLst/>
+          </a:prstGeom>
+          <a:solidFill>
+            <a:srgbClr val="5234B7"/>
+          </a:solidFill>
+          <a:ln>
+            <a:noFill/>
+          </a:ln>
+          <a:effectLst/>
+        </p:spPr>
+        <p:style>
+          <a:lnRef idx="1">
+            <a:schemeClr val="accent1"/>
+          </a:lnRef>
+          <a:fillRef idx="3">
+            <a:schemeClr val="accent1"/>
+          </a:fillRef>
+          <a:effectRef idx="2">
+            <a:schemeClr val="accent1"/>
+          </a:effectRef>
+          <a:fontRef idx="minor">
+            <a:schemeClr val="lt1"/>
+          </a:fontRef>
+        </p:style>
+        <p:txBody>
+          <a:bodyPr rtlCol="0" anchor="ctr"/>
+          <a:lstStyle/>
+          <a:p>
+            <a:pPr algn="ctr"/>
+          </a:p>
+        </p:txBody>
+      </p:sp>
+      <p:sp>
+        <p:nvSpPr>
+          <p:cNvPr id="18" name="TextBox 17"/>
+          <p:cNvSpPr txBox="1"/>
+          <p:nvPr/>
+        </p:nvSpPr>
+        <p:spPr>
+          <a:xfrm>
+            <a:off x="548640" y="6510528"/>
+            <a:ext cx="2743200" cy="256032"/>
+          </a:xfrm>
+          <a:prstGeom prst="rect">
+            <a:avLst/>
+          </a:prstGeom>
+          <a:noFill/>
+        </p:spPr>
+        <p:txBody>
+          <a:bodyPr wrap="square" anchor="t">
+            <a:spAutoFit/>
+          </a:bodyPr>
+          <a:lstStyle/>
+          <a:p>
+            <a:pPr algn="l"/>
+            <a:r>
+              <a:rPr sz="1100" b="1">
+                <a:solidFill>
+                  <a:srgbClr val="5234B7"/>
+                </a:solidFill>
+                <a:latin typeface="DIN Next LT W23"/>
+                <a:ea typeface="DIN Next LT W23"/>
+                <a:cs typeface="DIN Next LT W23"/>
+              </a:rPr>
+              <a:t>ETRA</a:t>
+            </a:r>
+          </a:p>
+        </p:txBody>
+      </p:sp>
+      <p:sp>
+        <p:nvSpPr>
+          <p:cNvPr id="19" name="TextBox 18"/>
+          <p:cNvSpPr txBox="1"/>
+          <p:nvPr/>
+        </p:nvSpPr>
+        <p:spPr>
+          <a:xfrm>
+            <a:off x="9601200" y="6510528"/>
+            <a:ext cx="2011680" cy="256032"/>
+          </a:xfrm>
+          <a:prstGeom prst="rect">
+            <a:avLst/>
+          </a:prstGeom>
+          <a:noFill/>
+        </p:spPr>
+        <p:txBody>
+          <a:bodyPr wrap="square" anchor="t">
+            <a:spAutoFit/>
+          </a:bodyPr>
+          <a:lstStyle/>
+          <a:p>
+            <a:pPr algn="r"/>
+            <a:r>
+              <a:rPr sz="1100" b="0">
+                <a:solidFill>
+                  <a:srgbClr val="5A5470"/>
+                </a:solidFill>
+                <a:latin typeface="DIN Next LT W23"/>
+                <a:ea typeface="DIN Next LT W23"/>
+                <a:cs typeface="DIN Next LT W23"/>
+              </a:rPr>
+              <a:t>36  /  37</a:t>
+            </a:r>
+          </a:p>
+        </p:txBody>
+      </p:sp>
+    </p:spTree>
+  </p:cSld>
+  <p:clrMapOvr>
+    <a:masterClrMapping/>
+  </p:clrMapOvr>
+</p:sld>
+</file>
+
+<file path=ppt/slides/slide37.xml><?xml version="1.0" encoding="utf-8"?>
+<p:sld xmlns:a="http://schemas.openxmlformats.org/drawingml/2006/main" xmlns:p="http://schemas.openxmlformats.org/presentationml/2006/main" xmlns:r="http://schemas.openxmlformats.org/officeDocument/2006/relationships">
+  <p:cSld>
+    <p:bg>
+      <p:bgPr>
+        <a:solidFill>
+          <a:srgbClr val="FAF8FF"/>
+        </a:solidFill>
+        <a:effectLst/>
+      </p:bgPr>
+    </p:bg>
+    <p:spTree>
+      <p:nvGrpSpPr>
+        <p:cNvPr id="1" name=""/>
+        <p:cNvGrpSpPr/>
+        <p:nvPr/>
+      </p:nvGrpSpPr>
+      <p:grpSpPr/>
+      <p:sp>
+        <p:nvSpPr>
+          <p:cNvPr id="2" name="Rectangle 1"/>
+          <p:cNvSpPr/>
+          <p:nvPr/>
+        </p:nvSpPr>
+        <p:spPr>
+          <a:xfrm>
+            <a:off x="12136831" y="0"/>
+            <a:ext cx="54864" cy="6858000"/>
+          </a:xfrm>
+          <a:prstGeom prst="rect">
+            <a:avLst/>
+          </a:prstGeom>
+          <a:solidFill>
+            <a:srgbClr val="5234B7"/>
+          </a:solidFill>
+          <a:ln>
+            <a:noFill/>
+          </a:ln>
+          <a:effectLst/>
+        </p:spPr>
+        <p:style>
+          <a:lnRef idx="1">
+            <a:schemeClr val="accent1"/>
+          </a:lnRef>
+          <a:fillRef idx="3">
+            <a:schemeClr val="accent1"/>
+          </a:fillRef>
+          <a:effectRef idx="2">
+            <a:schemeClr val="accent1"/>
+          </a:effectRef>
+          <a:fontRef idx="minor">
+            <a:schemeClr val="lt1"/>
+          </a:fontRef>
+        </p:style>
+        <p:txBody>
+          <a:bodyPr rtlCol="0" anchor="ctr"/>
+          <a:lstStyle/>
+          <a:p>
+            <a:pPr algn="ctr"/>
+          </a:p>
+        </p:txBody>
+      </p:sp>
+      <p:pic>
+        <p:nvPicPr>
+          <p:cNvPr id="3" name="Picture 2" descr="etra-wordmark.png"/>
+          <p:cNvPicPr>
+            <a:picLocks noChangeAspect="1"/>
+          </p:cNvPicPr>
+          <p:nvPr/>
+        </p:nvPicPr>
+        <p:blipFill>
+          <a:blip r:embed="rId2"/>
+          <a:stretch>
+            <a:fillRect/>
+          </a:stretch>
+        </p:blipFill>
+        <p:spPr>
+          <a:xfrm>
+            <a:off x="10561320" y="411480"/>
+            <a:ext cx="1378516" cy="365760"/>
+          </a:xfrm>
+          <a:prstGeom prst="rect">
+            <a:avLst/>
+          </a:prstGeom>
+        </p:spPr>
+      </p:pic>
+      <p:sp>
+        <p:nvSpPr>
+          <p:cNvPr id="4" name="TextBox 3"/>
+          <p:cNvSpPr txBox="1"/>
+          <p:nvPr/>
+        </p:nvSpPr>
+        <p:spPr>
+          <a:xfrm>
+            <a:off x="548640" y="2651760"/>
+            <a:ext cx="10972800" cy="731520"/>
+          </a:xfrm>
+          <a:prstGeom prst="rect">
+            <a:avLst/>
+          </a:prstGeom>
+          <a:noFill/>
+        </p:spPr>
+        <p:txBody>
+          <a:bodyPr wrap="square" anchor="t">
+            <a:spAutoFit/>
+          </a:bodyPr>
+          <a:lstStyle/>
+          <a:p>
+            <a:pPr algn="ctr"/>
+            <a:r>
+              <a:rPr sz="4000" b="1">
+                <a:solidFill>
+                  <a:srgbClr val="5234B7"/>
+                </a:solidFill>
+                <a:latin typeface="DIN Next LT W23"/>
+                <a:ea typeface="DIN Next LT W23"/>
+                <a:cs typeface="DIN Next LT W23"/>
+              </a:rPr>
+              <a:t>Thank you</a:t>
+            </a:r>
+          </a:p>
+        </p:txBody>
+      </p:sp>
+      <p:sp>
+        <p:nvSpPr>
+          <p:cNvPr id="5" name="TextBox 4"/>
+          <p:cNvSpPr txBox="1"/>
+          <p:nvPr/>
+        </p:nvSpPr>
+        <p:spPr>
+          <a:xfrm>
+            <a:off x="548640" y="3474720"/>
+            <a:ext cx="10972800" cy="365760"/>
+          </a:xfrm>
+          <a:prstGeom prst="rect">
+            <a:avLst/>
+          </a:prstGeom>
+          <a:noFill/>
+        </p:spPr>
+        <p:txBody>
+          <a:bodyPr wrap="square" anchor="t">
+            <a:spAutoFit/>
+          </a:bodyPr>
+          <a:lstStyle/>
+          <a:p>
+            <a:pPr algn="ctr"/>
+            <a:r>
+              <a:rPr sz="1600" b="0">
+                <a:solidFill>
+                  <a:srgbClr val="5A5470"/>
+                </a:solidFill>
+                <a:latin typeface="DIN Next LT W23"/>
+                <a:ea typeface="DIN Next LT W23"/>
+                <a:cs typeface="DIN Next LT W23"/>
+              </a:rPr>
+              <a:t>Labs: code/17- GenAI</a:t>
+            </a:r>
+          </a:p>
+        </p:txBody>
+      </p:sp>
+      <p:sp>
+        <p:nvSpPr>
+          <p:cNvPr id="6" name="TextBox 5"/>
+          <p:cNvSpPr txBox="1"/>
+          <p:nvPr/>
+        </p:nvSpPr>
+        <p:spPr>
+          <a:xfrm>
+            <a:off x="548640" y="6126480"/>
+            <a:ext cx="5486400" cy="274320"/>
+          </a:xfrm>
+          <a:prstGeom prst="rect">
+            <a:avLst/>
+          </a:prstGeom>
+          <a:noFill/>
+        </p:spPr>
+        <p:txBody>
+          <a:bodyPr wrap="square" anchor="t">
+            <a:spAutoFit/>
+          </a:bodyPr>
+          <a:lstStyle/>
+          <a:p>
+            <a:pPr algn="l"/>
+            <a:r>
+              <a:rPr sz="1200" b="1">
+                <a:solidFill>
+                  <a:srgbClr val="5234B7"/>
+                </a:solidFill>
+                <a:latin typeface="DIN Next LT W23"/>
+                <a:ea typeface="DIN Next LT W23"/>
+                <a:cs typeface="DIN Next LT W23"/>
+              </a:rPr>
+              <a:t>ETRA</a:t>
+            </a:r>
+          </a:p>
+        </p:txBody>
+      </p:sp>
+      <p:sp>
+        <p:nvSpPr>
+          <p:cNvPr id="7" name="Rectangle 6"/>
+          <p:cNvSpPr/>
+          <p:nvPr/>
+        </p:nvSpPr>
+        <p:spPr>
+          <a:xfrm>
+            <a:off x="548640" y="6446520"/>
+            <a:ext cx="11064240" cy="10972"/>
+          </a:xfrm>
+          <a:prstGeom prst="rect">
+            <a:avLst/>
+          </a:prstGeom>
+          <a:solidFill>
+            <a:srgbClr val="5234B7"/>
+          </a:solidFill>
+          <a:ln>
+            <a:noFill/>
+          </a:ln>
+          <a:effectLst/>
+        </p:spPr>
+        <p:style>
+          <a:lnRef idx="1">
+            <a:schemeClr val="accent1"/>
+          </a:lnRef>
+          <a:fillRef idx="3">
+            <a:schemeClr val="accent1"/>
+          </a:fillRef>
+          <a:effectRef idx="2">
+            <a:schemeClr val="accent1"/>
+          </a:effectRef>
+          <a:fontRef idx="minor">
+            <a:schemeClr val="lt1"/>
+          </a:fontRef>
+        </p:style>
+        <p:txBody>
+          <a:bodyPr rtlCol="0" anchor="ctr"/>
+          <a:lstStyle/>
+          <a:p>
+            <a:pPr algn="ctr"/>
+          </a:p>
+        </p:txBody>
+      </p:sp>
+      <p:sp>
+        <p:nvSpPr>
+          <p:cNvPr id="8" name="TextBox 7"/>
+          <p:cNvSpPr txBox="1"/>
+          <p:nvPr/>
+        </p:nvSpPr>
+        <p:spPr>
+          <a:xfrm>
+            <a:off x="548640" y="6510528"/>
+            <a:ext cx="2743200" cy="256032"/>
+          </a:xfrm>
+          <a:prstGeom prst="rect">
+            <a:avLst/>
+          </a:prstGeom>
+          <a:noFill/>
+        </p:spPr>
+        <p:txBody>
+          <a:bodyPr wrap="square" anchor="t">
+            <a:spAutoFit/>
+          </a:bodyPr>
+          <a:lstStyle/>
+          <a:p>
+            <a:pPr algn="l"/>
+            <a:r>
+              <a:rPr sz="1100" b="1">
+                <a:solidFill>
+                  <a:srgbClr val="5234B7"/>
+                </a:solidFill>
+                <a:latin typeface="DIN Next LT W23"/>
+                <a:ea typeface="DIN Next LT W23"/>
+                <a:cs typeface="DIN Next LT W23"/>
+              </a:rPr>
+              <a:t>ETRA</a:t>
+            </a:r>
+          </a:p>
+        </p:txBody>
+      </p:sp>
+      <p:sp>
+        <p:nvSpPr>
+          <p:cNvPr id="9" name="TextBox 8"/>
+          <p:cNvSpPr txBox="1"/>
+          <p:nvPr/>
+        </p:nvSpPr>
+        <p:spPr>
+          <a:xfrm>
+            <a:off x="9601200" y="6510528"/>
+            <a:ext cx="2011680" cy="256032"/>
+          </a:xfrm>
+          <a:prstGeom prst="rect">
+            <a:avLst/>
+          </a:prstGeom>
+          <a:noFill/>
+        </p:spPr>
+        <p:txBody>
+          <a:bodyPr wrap="square" anchor="t">
+            <a:spAutoFit/>
+          </a:bodyPr>
+          <a:lstStyle/>
+          <a:p>
+            <a:pPr algn="r"/>
+            <a:r>
+              <a:rPr sz="1100" b="0">
+                <a:solidFill>
+                  <a:srgbClr val="5A5470"/>
+                </a:solidFill>
+                <a:latin typeface="DIN Next LT W23"/>
+                <a:ea typeface="DIN Next LT W23"/>
+                <a:cs typeface="DIN Next LT W23"/>
+              </a:rPr>
+              <a:t>37  /  37</a:t>
             </a:r>
           </a:p>
         </p:txBody>
@@ -20026,7 +22470,7 @@
                 <a:ea typeface="DIN Next LT W23"/>
                 <a:cs typeface="DIN Next LT W23"/>
               </a:rPr>
-              <a:t>04  /  33</a:t>
+              <a:t>04  /  37</a:t>
             </a:r>
           </a:p>
         </p:txBody>
@@ -20615,7 +23059,7 @@
                 <a:ea typeface="DIN Next LT W23"/>
                 <a:cs typeface="DIN Next LT W23"/>
               </a:rPr>
-              <a:t>05  /  33</a:t>
+              <a:t>05  /  37</a:t>
             </a:r>
           </a:p>
         </p:txBody>
@@ -21339,7 +23783,7 @@
                 <a:ea typeface="DIN Next LT W23"/>
                 <a:cs typeface="DIN Next LT W23"/>
               </a:rPr>
-              <a:t>06  /  33</a:t>
+              <a:t>06  /  37</a:t>
             </a:r>
           </a:p>
         </p:txBody>
@@ -21979,7 +24423,7 @@
                 <a:ea typeface="DIN Next LT W23"/>
                 <a:cs typeface="DIN Next LT W23"/>
               </a:rPr>
-              <a:t>07  /  33</a:t>
+              <a:t>07  /  37</a:t>
             </a:r>
           </a:p>
         </p:txBody>
@@ -22379,7 +24823,7 @@
                 <a:ea typeface="DIN Next LT W23"/>
                 <a:cs typeface="DIN Next LT W23"/>
               </a:rPr>
-              <a:t>08  /  33</a:t>
+              <a:t>08  /  37</a:t>
             </a:r>
           </a:p>
         </p:txBody>
@@ -22931,7 +25375,7 @@
                 <a:ea typeface="DIN Next LT W23"/>
                 <a:cs typeface="DIN Next LT W23"/>
               </a:rPr>
-              <a:t>09  /  33</a:t>
+              <a:t>09  /  37</a:t>
             </a:r>
           </a:p>
         </p:txBody>

</xml_diff>